<commit_message>
Time pills and number circles bordered like every other box (today's decks)
Co-Authored-By: Claude Opus 5.5 <noreply@anthropic.com>
Claude-Session: https://claude.ai/code/session_01WMhLn9wqKhsSQGNMWzVMPf
</commit_message>
<xml_diff>
--- a/materials/B2/B2_6B-2_Music_to_my_ears.pptx
+++ b/materials/B2/B2_6B-2_Music_to_my_ears.pptx
@@ -2651,7 +2651,7 @@
           </a:solidFill>
           <a:ln w="28575">
             <a:solidFill>
-              <a:srgbClr val="FFFFFF"/>
+              <a:srgbClr val="F7A6C4"/>
             </a:solidFill>
           </a:ln>
           <a:effectLst>
@@ -3454,7 +3454,7 @@
           </a:solidFill>
           <a:ln w="28575">
             <a:solidFill>
-              <a:srgbClr val="FFFFFF"/>
+              <a:srgbClr val="A8E5BE"/>
             </a:solidFill>
           </a:ln>
           <a:effectLst>
@@ -3760,7 +3760,7 @@
           </a:solidFill>
           <a:ln w="28575">
             <a:solidFill>
-              <a:srgbClr val="C9D3E2"/>
+              <a:srgbClr val="A9D3F5"/>
             </a:solidFill>
           </a:ln>
         </p:spPr>
@@ -3809,7 +3809,7 @@
           </a:solidFill>
           <a:ln w="28575">
             <a:solidFill>
-              <a:srgbClr val="D9CCF5"/>
+              <a:srgbClr val="CDBFF3"/>
             </a:solidFill>
           </a:ln>
         </p:spPr>
@@ -4168,7 +4168,7 @@
           </a:solidFill>
           <a:ln w="28575">
             <a:solidFill>
-              <a:srgbClr val="FFFFFF"/>
+              <a:srgbClr val="A9D3F5"/>
             </a:solidFill>
           </a:ln>
           <a:effectLst>
@@ -4555,7 +4555,7 @@
           </a:solidFill>
           <a:ln w="28575">
             <a:solidFill>
-              <a:srgbClr val="C9D3E2"/>
+              <a:srgbClr val="A9D3F5"/>
             </a:solidFill>
           </a:ln>
         </p:spPr>
@@ -4604,7 +4604,7 @@
           </a:solidFill>
           <a:ln w="28575">
             <a:solidFill>
-              <a:srgbClr val="D9CCF5"/>
+              <a:srgbClr val="CDBFF3"/>
             </a:solidFill>
           </a:ln>
         </p:spPr>
@@ -4728,7 +4728,7 @@
           </a:solidFill>
           <a:ln w="28575">
             <a:solidFill>
-              <a:srgbClr val="FFFFFF"/>
+              <a:srgbClr val="F7A6C4"/>
             </a:solidFill>
           </a:ln>
           <a:effectLst>
@@ -4878,7 +4878,7 @@
           </a:solidFill>
           <a:ln w="28575">
             <a:solidFill>
-              <a:srgbClr val="FFFFFF"/>
+              <a:srgbClr val="A9D3F5"/>
             </a:solidFill>
           </a:ln>
           <a:effectLst>
@@ -5028,7 +5028,7 @@
           </a:solidFill>
           <a:ln w="28575">
             <a:solidFill>
-              <a:srgbClr val="FFFFFF"/>
+              <a:srgbClr val="A8E5BE"/>
             </a:solidFill>
           </a:ln>
           <a:effectLst>
@@ -5178,7 +5178,7 @@
           </a:solidFill>
           <a:ln w="28575">
             <a:solidFill>
-              <a:srgbClr val="FFFFFF"/>
+              <a:srgbClr val="FFE07A"/>
             </a:solidFill>
           </a:ln>
           <a:effectLst>
@@ -5328,7 +5328,7 @@
           </a:solidFill>
           <a:ln w="28575">
             <a:solidFill>
-              <a:srgbClr val="FFFFFF"/>
+              <a:srgbClr val="F7A6C4"/>
             </a:solidFill>
           </a:ln>
           <a:effectLst>
@@ -5478,7 +5478,7 @@
           </a:solidFill>
           <a:ln w="28575">
             <a:solidFill>
-              <a:srgbClr val="FFFFFF"/>
+              <a:srgbClr val="A9D3F5"/>
             </a:solidFill>
           </a:ln>
           <a:effectLst>
@@ -5628,7 +5628,7 @@
           </a:solidFill>
           <a:ln w="28575">
             <a:solidFill>
-              <a:srgbClr val="FFFFFF"/>
+              <a:srgbClr val="A8E5BE"/>
             </a:solidFill>
           </a:ln>
           <a:effectLst>
@@ -5778,7 +5778,7 @@
           </a:solidFill>
           <a:ln w="28575">
             <a:solidFill>
-              <a:srgbClr val="FFFFFF"/>
+              <a:srgbClr val="FFE07A"/>
             </a:solidFill>
           </a:ln>
           <a:effectLst>
@@ -6424,7 +6424,7 @@
           </a:solidFill>
           <a:ln w="28575">
             <a:solidFill>
-              <a:srgbClr val="FFFFFF"/>
+              <a:srgbClr val="A8E5BE"/>
             </a:solidFill>
           </a:ln>
           <a:effectLst>
@@ -6730,7 +6730,7 @@
           </a:solidFill>
           <a:ln w="28575">
             <a:solidFill>
-              <a:srgbClr val="C9D3E2"/>
+              <a:srgbClr val="A9D3F5"/>
             </a:solidFill>
           </a:ln>
         </p:spPr>
@@ -6779,7 +6779,7 @@
           </a:solidFill>
           <a:ln w="28575">
             <a:solidFill>
-              <a:srgbClr val="D9CCF5"/>
+              <a:srgbClr val="CDBFF3"/>
             </a:solidFill>
           </a:ln>
         </p:spPr>
@@ -6903,7 +6903,7 @@
           </a:solidFill>
           <a:ln w="28575">
             <a:solidFill>
-              <a:srgbClr val="FFFFFF"/>
+              <a:srgbClr val="F7A6C4"/>
             </a:solidFill>
           </a:ln>
           <a:effectLst>
@@ -7084,7 +7084,7 @@
           </a:solidFill>
           <a:ln w="28575">
             <a:solidFill>
-              <a:srgbClr val="FFFFFF"/>
+              <a:srgbClr val="A9D3F5"/>
             </a:solidFill>
           </a:ln>
           <a:effectLst>
@@ -7265,7 +7265,7 @@
           </a:solidFill>
           <a:ln w="28575">
             <a:solidFill>
-              <a:srgbClr val="FFFFFF"/>
+              <a:srgbClr val="A8E5BE"/>
             </a:solidFill>
           </a:ln>
           <a:effectLst>
@@ -7446,7 +7446,7 @@
           </a:solidFill>
           <a:ln w="28575">
             <a:solidFill>
-              <a:srgbClr val="FFFFFF"/>
+              <a:srgbClr val="FFE07A"/>
             </a:solidFill>
           </a:ln>
           <a:effectLst>
@@ -7627,7 +7627,7 @@
           </a:solidFill>
           <a:ln w="28575">
             <a:solidFill>
-              <a:srgbClr val="FFFFFF"/>
+              <a:srgbClr val="F7A6C4"/>
             </a:solidFill>
           </a:ln>
           <a:effectLst>
@@ -7808,7 +7808,7 @@
           </a:solidFill>
           <a:ln w="28575">
             <a:solidFill>
-              <a:srgbClr val="FFFFFF"/>
+              <a:srgbClr val="A9D3F5"/>
             </a:solidFill>
           </a:ln>
           <a:effectLst>
@@ -8410,7 +8410,7 @@
           </a:solidFill>
           <a:ln w="28575">
             <a:solidFill>
-              <a:srgbClr val="FFFFFF"/>
+              <a:srgbClr val="F7A6C4"/>
             </a:solidFill>
           </a:ln>
           <a:effectLst>
@@ -8797,7 +8797,7 @@
           </a:solidFill>
           <a:ln w="28575">
             <a:solidFill>
-              <a:srgbClr val="C9D3E2"/>
+              <a:srgbClr val="A9D3F5"/>
             </a:solidFill>
           </a:ln>
         </p:spPr>
@@ -8846,7 +8846,7 @@
           </a:solidFill>
           <a:ln w="28575">
             <a:solidFill>
-              <a:srgbClr val="D9CCF5"/>
+              <a:srgbClr val="CDBFF3"/>
             </a:solidFill>
           </a:ln>
         </p:spPr>
@@ -9220,7 +9220,7 @@
           </a:solidFill>
           <a:ln w="28575">
             <a:solidFill>
-              <a:srgbClr val="FFFFFF"/>
+              <a:srgbClr val="F7A6C4"/>
             </a:solidFill>
           </a:ln>
           <a:effectLst>
@@ -9345,7 +9345,7 @@
           </a:solidFill>
           <a:ln w="28575">
             <a:solidFill>
-              <a:srgbClr val="FFFFFF"/>
+              <a:srgbClr val="A9D3F5"/>
             </a:solidFill>
           </a:ln>
           <a:effectLst>
@@ -9470,7 +9470,7 @@
           </a:solidFill>
           <a:ln w="28575">
             <a:solidFill>
-              <a:srgbClr val="FFFFFF"/>
+              <a:srgbClr val="A8E5BE"/>
             </a:solidFill>
           </a:ln>
           <a:effectLst>
@@ -9595,7 +9595,7 @@
           </a:solidFill>
           <a:ln w="28575">
             <a:solidFill>
-              <a:srgbClr val="FFFFFF"/>
+              <a:srgbClr val="FFE07A"/>
             </a:solidFill>
           </a:ln>
           <a:effectLst>
@@ -10144,7 +10144,7 @@
           </a:solidFill>
           <a:ln w="28575">
             <a:solidFill>
-              <a:srgbClr val="FFFFFF"/>
+              <a:srgbClr val="F7A6C4"/>
             </a:solidFill>
           </a:ln>
           <a:effectLst>
@@ -10450,7 +10450,7 @@
           </a:solidFill>
           <a:ln w="28575">
             <a:solidFill>
-              <a:srgbClr val="C9D3E2"/>
+              <a:srgbClr val="A9D3F5"/>
             </a:solidFill>
           </a:ln>
         </p:spPr>
@@ -10499,7 +10499,7 @@
           </a:solidFill>
           <a:ln w="28575">
             <a:solidFill>
-              <a:srgbClr val="D9CCF5"/>
+              <a:srgbClr val="CDBFF3"/>
             </a:solidFill>
           </a:ln>
         </p:spPr>
@@ -10897,7 +10897,7 @@
           </a:solidFill>
           <a:ln w="28575">
             <a:solidFill>
-              <a:srgbClr val="FFFFFF"/>
+              <a:srgbClr val="F7A6C4"/>
             </a:solidFill>
           </a:ln>
           <a:effectLst>
@@ -11022,7 +11022,7 @@
           </a:solidFill>
           <a:ln w="28575">
             <a:solidFill>
-              <a:srgbClr val="FFFFFF"/>
+              <a:srgbClr val="A9D3F5"/>
             </a:solidFill>
           </a:ln>
           <a:effectLst>
@@ -11147,7 +11147,7 @@
           </a:solidFill>
           <a:ln w="28575">
             <a:solidFill>
-              <a:srgbClr val="FFFFFF"/>
+              <a:srgbClr val="A8E5BE"/>
             </a:solidFill>
           </a:ln>
           <a:effectLst>
@@ -11272,7 +11272,7 @@
           </a:solidFill>
           <a:ln w="28575">
             <a:solidFill>
-              <a:srgbClr val="FFFFFF"/>
+              <a:srgbClr val="FFE07A"/>
             </a:solidFill>
           </a:ln>
           <a:effectLst>
@@ -11397,7 +11397,7 @@
           </a:solidFill>
           <a:ln w="28575">
             <a:solidFill>
-              <a:srgbClr val="FFFFFF"/>
+              <a:srgbClr val="F7A6C4"/>
             </a:solidFill>
           </a:ln>
           <a:effectLst>
@@ -12034,7 +12034,7 @@
           </a:solidFill>
           <a:ln w="28575">
             <a:solidFill>
-              <a:srgbClr val="FFFFFF"/>
+              <a:srgbClr val="CDBFF3"/>
             </a:solidFill>
           </a:ln>
           <a:effectLst>
@@ -12421,7 +12421,7 @@
           </a:solidFill>
           <a:ln w="28575">
             <a:solidFill>
-              <a:srgbClr val="C9D3E2"/>
+              <a:srgbClr val="A9D3F5"/>
             </a:solidFill>
           </a:ln>
         </p:spPr>
@@ -12470,7 +12470,7 @@
           </a:solidFill>
           <a:ln w="28575">
             <a:solidFill>
-              <a:srgbClr val="D9CCF5"/>
+              <a:srgbClr val="CDBFF3"/>
             </a:solidFill>
           </a:ln>
         </p:spPr>
@@ -12765,12 +12765,11 @@
           </a:bodyPr>
           <a:lstStyle/>
           <a:p>
-            <a:pPr marL="152400" indent="-152400">
+            <a:pPr indent="0" marL="0">
               <a:spcAft>
                 <a:spcPts val="200"/>
               </a:spcAft>
-              <a:buSzPct val="100000"/>
-              <a:buChar char="•"/>
+              <a:buNone/>
             </a:pPr>
             <a:r>
               <a:rPr lang="en-US" sz="1150" dirty="0">
@@ -12786,15 +12785,14 @@
             <a:endParaRPr lang="en-US" sz="1150" dirty="0"/>
           </a:p>
           <a:p>
-            <a:pPr marL="152400" indent="-152400">
+            <a:pPr indent="0" marL="0">
               <a:spcBef>
                 <a:spcPts val="600"/>
               </a:spcBef>
               <a:spcAft>
                 <a:spcPts val="200"/>
               </a:spcAft>
-              <a:buSzPct val="100000"/>
-              <a:buChar char="•"/>
+              <a:buNone/>
             </a:pPr>
             <a:r>
               <a:rPr lang="en-US" sz="1150" dirty="0">
@@ -12810,15 +12808,14 @@
             <a:endParaRPr lang="en-US" sz="1150" dirty="0"/>
           </a:p>
           <a:p>
-            <a:pPr marL="152400" indent="-152400">
+            <a:pPr indent="0" marL="0">
               <a:spcBef>
                 <a:spcPts val="600"/>
               </a:spcBef>
               <a:spcAft>
                 <a:spcPts val="200"/>
               </a:spcAft>
-              <a:buSzPct val="100000"/>
-              <a:buChar char="•"/>
+              <a:buNone/>
             </a:pPr>
             <a:r>
               <a:rPr lang="en-US" sz="1150" dirty="0">
@@ -12834,15 +12831,14 @@
             <a:endParaRPr lang="en-US" sz="1150" dirty="0"/>
           </a:p>
           <a:p>
-            <a:pPr marL="152400" indent="-152400">
+            <a:pPr indent="0" marL="0">
               <a:spcBef>
                 <a:spcPts val="600"/>
               </a:spcBef>
               <a:spcAft>
                 <a:spcPts val="200"/>
               </a:spcAft>
-              <a:buSzPct val="100000"/>
-              <a:buChar char="•"/>
+              <a:buNone/>
             </a:pPr>
             <a:r>
               <a:rPr lang="en-US" sz="1150" dirty="0">
@@ -12858,15 +12854,14 @@
             <a:endParaRPr lang="en-US" sz="1150" dirty="0"/>
           </a:p>
           <a:p>
-            <a:pPr marL="152400" indent="-152400">
+            <a:pPr indent="0" marL="0">
               <a:spcBef>
                 <a:spcPts val="600"/>
               </a:spcBef>
               <a:spcAft>
                 <a:spcPts val="200"/>
               </a:spcAft>
-              <a:buSzPct val="100000"/>
-              <a:buChar char="•"/>
+              <a:buNone/>
             </a:pPr>
             <a:r>
               <a:rPr lang="en-US" sz="1150" dirty="0">
@@ -12902,7 +12897,7 @@
           </a:solidFill>
           <a:ln w="28575">
             <a:solidFill>
-              <a:srgbClr val="FFFFFF"/>
+              <a:srgbClr val="F7A6C4"/>
             </a:solidFill>
           </a:ln>
           <a:effectLst>
@@ -13087,7 +13082,7 @@
           </a:solidFill>
           <a:ln w="28575">
             <a:solidFill>
-              <a:srgbClr val="FFFFFF"/>
+              <a:srgbClr val="A9D3F5"/>
             </a:solidFill>
           </a:ln>
           <a:effectLst>
@@ -13303,7 +13298,7 @@
           </a:solidFill>
           <a:ln w="28575">
             <a:solidFill>
-              <a:srgbClr val="FFFFFF"/>
+              <a:srgbClr val="A8E5BE"/>
             </a:solidFill>
           </a:ln>
           <a:effectLst>
@@ -13488,7 +13483,7 @@
           </a:solidFill>
           <a:ln w="28575">
             <a:solidFill>
-              <a:srgbClr val="FFFFFF"/>
+              <a:srgbClr val="FFE07A"/>
             </a:solidFill>
           </a:ln>
           <a:effectLst>
@@ -13673,7 +13668,7 @@
           </a:solidFill>
           <a:ln w="28575">
             <a:solidFill>
-              <a:srgbClr val="FFFFFF"/>
+              <a:srgbClr val="F7A6C4"/>
             </a:solidFill>
           </a:ln>
           <a:effectLst>
@@ -13827,7 +13822,7 @@
           </a:solidFill>
           <a:ln w="28575">
             <a:solidFill>
-              <a:srgbClr val="FFFFFF"/>
+              <a:srgbClr val="A9D3F5"/>
             </a:solidFill>
           </a:ln>
           <a:effectLst>
@@ -14581,7 +14576,7 @@
           </a:solidFill>
           <a:ln w="28575">
             <a:solidFill>
-              <a:srgbClr val="FFFFFF"/>
+              <a:srgbClr val="CDBFF3"/>
             </a:solidFill>
           </a:ln>
           <a:effectLst>
@@ -14887,7 +14882,7 @@
           </a:solidFill>
           <a:ln w="28575">
             <a:solidFill>
-              <a:srgbClr val="C9D3E2"/>
+              <a:srgbClr val="A9D3F5"/>
             </a:solidFill>
           </a:ln>
         </p:spPr>
@@ -14936,7 +14931,7 @@
           </a:solidFill>
           <a:ln w="28575">
             <a:solidFill>
-              <a:srgbClr val="D9CCF5"/>
+              <a:srgbClr val="CDBFF3"/>
             </a:solidFill>
           </a:ln>
         </p:spPr>
@@ -15060,7 +15055,7 @@
           </a:solidFill>
           <a:ln w="28575">
             <a:solidFill>
-              <a:srgbClr val="FFFFFF"/>
+              <a:srgbClr val="F7A6C4"/>
             </a:solidFill>
           </a:ln>
           <a:effectLst>
@@ -15166,7 +15161,7 @@
           </a:solidFill>
           <a:ln w="28575">
             <a:solidFill>
-              <a:srgbClr val="FFFFFF"/>
+              <a:srgbClr val="A9D3F5"/>
             </a:solidFill>
           </a:ln>
           <a:effectLst>
@@ -15272,7 +15267,7 @@
           </a:solidFill>
           <a:ln w="28575">
             <a:solidFill>
-              <a:srgbClr val="FFFFFF"/>
+              <a:srgbClr val="A8E5BE"/>
             </a:solidFill>
           </a:ln>
           <a:effectLst>
@@ -15378,7 +15373,7 @@
           </a:solidFill>
           <a:ln w="28575">
             <a:solidFill>
-              <a:srgbClr val="FFFFFF"/>
+              <a:srgbClr val="FFE07A"/>
             </a:solidFill>
           </a:ln>
           <a:effectLst>
@@ -15484,7 +15479,7 @@
           </a:solidFill>
           <a:ln w="28575">
             <a:solidFill>
-              <a:srgbClr val="FFFFFF"/>
+              <a:srgbClr val="F7A6C4"/>
             </a:solidFill>
           </a:ln>
           <a:effectLst>
@@ -15590,7 +15585,7 @@
           </a:solidFill>
           <a:ln w="28575">
             <a:solidFill>
-              <a:srgbClr val="FFFFFF"/>
+              <a:srgbClr val="A9D3F5"/>
             </a:solidFill>
           </a:ln>
           <a:effectLst>
@@ -16296,7 +16291,7 @@
           </a:solidFill>
           <a:ln w="28575">
             <a:solidFill>
-              <a:srgbClr val="FFFFFF"/>
+              <a:srgbClr val="F7A6C4"/>
             </a:solidFill>
           </a:ln>
           <a:effectLst>
@@ -16602,7 +16597,7 @@
           </a:solidFill>
           <a:ln w="28575">
             <a:solidFill>
-              <a:srgbClr val="C9D3E2"/>
+              <a:srgbClr val="A9D3F5"/>
             </a:solidFill>
           </a:ln>
         </p:spPr>
@@ -16651,7 +16646,7 @@
           </a:solidFill>
           <a:ln w="28575">
             <a:solidFill>
-              <a:srgbClr val="D9CCF5"/>
+              <a:srgbClr val="CDBFF3"/>
             </a:solidFill>
           </a:ln>
         </p:spPr>
@@ -17072,7 +17067,7 @@
           </a:solidFill>
           <a:ln w="28575">
             <a:solidFill>
-              <a:srgbClr val="FFFFFF"/>
+              <a:srgbClr val="F7A6C4"/>
             </a:solidFill>
           </a:ln>
           <a:effectLst>
@@ -17222,7 +17217,7 @@
           </a:solidFill>
           <a:ln w="28575">
             <a:solidFill>
-              <a:srgbClr val="FFFFFF"/>
+              <a:srgbClr val="A9D3F5"/>
             </a:solidFill>
           </a:ln>
           <a:effectLst>
@@ -17372,7 +17367,7 @@
           </a:solidFill>
           <a:ln w="28575">
             <a:solidFill>
-              <a:srgbClr val="FFFFFF"/>
+              <a:srgbClr val="A8E5BE"/>
             </a:solidFill>
           </a:ln>
           <a:effectLst>
@@ -17522,7 +17517,7 @@
           </a:solidFill>
           <a:ln w="28575">
             <a:solidFill>
-              <a:srgbClr val="FFFFFF"/>
+              <a:srgbClr val="FFE07A"/>
             </a:solidFill>
           </a:ln>
           <a:effectLst>
@@ -17956,7 +17951,7 @@
           </a:solidFill>
           <a:ln w="28575">
             <a:solidFill>
-              <a:srgbClr val="FFFFFF"/>
+              <a:srgbClr val="A9D3F5"/>
             </a:solidFill>
           </a:ln>
           <a:effectLst>
@@ -18181,7 +18176,7 @@
           </a:solidFill>
           <a:ln w="28575">
             <a:solidFill>
-              <a:srgbClr val="C9D3E2"/>
+              <a:srgbClr val="A9D3F5"/>
             </a:solidFill>
           </a:ln>
         </p:spPr>
@@ -18230,7 +18225,7 @@
           </a:solidFill>
           <a:ln w="28575">
             <a:solidFill>
-              <a:srgbClr val="D9CCF5"/>
+              <a:srgbClr val="CDBFF3"/>
             </a:solidFill>
           </a:ln>
         </p:spPr>
@@ -18354,7 +18349,7 @@
           </a:solidFill>
           <a:ln w="28575">
             <a:solidFill>
-              <a:srgbClr val="FFFFFF"/>
+              <a:srgbClr val="F7A6C4"/>
             </a:solidFill>
           </a:ln>
           <a:effectLst>
@@ -18462,7 +18457,7 @@
           </a:solidFill>
           <a:ln w="28575">
             <a:solidFill>
-              <a:srgbClr val="FFFFFF"/>
+              <a:srgbClr val="A9D3F5"/>
             </a:solidFill>
           </a:ln>
           <a:effectLst>
@@ -18570,7 +18565,7 @@
           </a:solidFill>
           <a:ln w="28575">
             <a:solidFill>
-              <a:srgbClr val="FFFFFF"/>
+              <a:srgbClr val="A8E5BE"/>
             </a:solidFill>
           </a:ln>
           <a:effectLst>
@@ -18952,7 +18947,7 @@
           </a:solidFill>
           <a:ln w="28575">
             <a:solidFill>
-              <a:srgbClr val="FFFFFF"/>
+              <a:srgbClr val="A8E5BE"/>
             </a:solidFill>
           </a:ln>
           <a:effectLst>
@@ -19258,7 +19253,7 @@
           </a:solidFill>
           <a:ln w="28575">
             <a:solidFill>
-              <a:srgbClr val="C9D3E2"/>
+              <a:srgbClr val="A9D3F5"/>
             </a:solidFill>
           </a:ln>
         </p:spPr>
@@ -19307,7 +19302,7 @@
           </a:solidFill>
           <a:ln w="28575">
             <a:solidFill>
-              <a:srgbClr val="D9CCF5"/>
+              <a:srgbClr val="CDBFF3"/>
             </a:solidFill>
           </a:ln>
         </p:spPr>
@@ -20591,7 +20586,7 @@
           </a:solidFill>
           <a:ln w="28575">
             <a:solidFill>
-              <a:srgbClr val="FFFFFF"/>
+              <a:srgbClr val="F7A6C4"/>
             </a:solidFill>
           </a:ln>
           <a:effectLst>
@@ -20897,7 +20892,7 @@
           </a:solidFill>
           <a:ln w="28575">
             <a:solidFill>
-              <a:srgbClr val="C9D3E2"/>
+              <a:srgbClr val="A9D3F5"/>
             </a:solidFill>
           </a:ln>
         </p:spPr>
@@ -20946,7 +20941,7 @@
           </a:solidFill>
           <a:ln w="28575">
             <a:solidFill>
-              <a:srgbClr val="D9CCF5"/>
+              <a:srgbClr val="CDBFF3"/>
             </a:solidFill>
           </a:ln>
         </p:spPr>
@@ -21343,7 +21338,7 @@
           </a:solidFill>
           <a:ln w="28575">
             <a:solidFill>
-              <a:srgbClr val="FFFFFF"/>
+              <a:srgbClr val="F7A6C4"/>
             </a:solidFill>
           </a:ln>
           <a:effectLst>
@@ -21493,7 +21488,7 @@
           </a:solidFill>
           <a:ln w="28575">
             <a:solidFill>
-              <a:srgbClr val="FFFFFF"/>
+              <a:srgbClr val="A9D3F5"/>
             </a:solidFill>
           </a:ln>
           <a:effectLst>
@@ -21643,7 +21638,7 @@
           </a:solidFill>
           <a:ln w="28575">
             <a:solidFill>
-              <a:srgbClr val="FFFFFF"/>
+              <a:srgbClr val="A8E5BE"/>
             </a:solidFill>
           </a:ln>
           <a:effectLst>
@@ -21793,7 +21788,7 @@
           </a:solidFill>
           <a:ln w="28575">
             <a:solidFill>
-              <a:srgbClr val="FFFFFF"/>
+              <a:srgbClr val="FFE07A"/>
             </a:solidFill>
           </a:ln>
           <a:effectLst>
@@ -21943,7 +21938,7 @@
           </a:solidFill>
           <a:ln w="28575">
             <a:solidFill>
-              <a:srgbClr val="FFFFFF"/>
+              <a:srgbClr val="F7A6C4"/>
             </a:solidFill>
           </a:ln>
           <a:effectLst>
@@ -22093,7 +22088,7 @@
           </a:solidFill>
           <a:ln w="28575">
             <a:solidFill>
-              <a:srgbClr val="FFFFFF"/>
+              <a:srgbClr val="A9D3F5"/>
             </a:solidFill>
           </a:ln>
           <a:effectLst>
@@ -22633,7 +22628,7 @@
           </a:solidFill>
           <a:ln w="28575">
             <a:solidFill>
-              <a:srgbClr val="FFFFFF"/>
+              <a:srgbClr val="F7A6C4"/>
             </a:solidFill>
           </a:ln>
           <a:effectLst>
@@ -22939,7 +22934,7 @@
           </a:solidFill>
           <a:ln w="28575">
             <a:solidFill>
-              <a:srgbClr val="C9D3E2"/>
+              <a:srgbClr val="A9D3F5"/>
             </a:solidFill>
           </a:ln>
         </p:spPr>
@@ -22988,7 +22983,7 @@
           </a:solidFill>
           <a:ln w="28575">
             <a:solidFill>
-              <a:srgbClr val="D9CCF5"/>
+              <a:srgbClr val="CDBFF3"/>
             </a:solidFill>
           </a:ln>
         </p:spPr>
@@ -23392,7 +23387,7 @@
           </a:solidFill>
           <a:ln w="28575">
             <a:solidFill>
-              <a:srgbClr val="FFFFFF"/>
+              <a:srgbClr val="F7A6C4"/>
             </a:solidFill>
           </a:ln>
           <a:effectLst>
@@ -23517,7 +23512,7 @@
           </a:solidFill>
           <a:ln w="28575">
             <a:solidFill>
-              <a:srgbClr val="FFFFFF"/>
+              <a:srgbClr val="A9D3F5"/>
             </a:solidFill>
           </a:ln>
           <a:effectLst>
@@ -23642,7 +23637,7 @@
           </a:solidFill>
           <a:ln w="28575">
             <a:solidFill>
-              <a:srgbClr val="FFFFFF"/>
+              <a:srgbClr val="A8E5BE"/>
             </a:solidFill>
           </a:ln>
           <a:effectLst>
@@ -23767,7 +23762,7 @@
           </a:solidFill>
           <a:ln w="28575">
             <a:solidFill>
-              <a:srgbClr val="FFFFFF"/>
+              <a:srgbClr val="FFE07A"/>
             </a:solidFill>
           </a:ln>
           <a:effectLst>
@@ -23892,7 +23887,7 @@
           </a:solidFill>
           <a:ln w="28575">
             <a:solidFill>
-              <a:srgbClr val="FFFFFF"/>
+              <a:srgbClr val="F7A6C4"/>
             </a:solidFill>
           </a:ln>
           <a:effectLst>
@@ -24529,7 +24524,7 @@
           </a:solidFill>
           <a:ln w="28575">
             <a:solidFill>
-              <a:srgbClr val="FFFFFF"/>
+              <a:srgbClr val="F7A6C4"/>
             </a:solidFill>
           </a:ln>
           <a:effectLst>
@@ -24835,7 +24830,7 @@
           </a:solidFill>
           <a:ln w="28575">
             <a:solidFill>
-              <a:srgbClr val="C9D3E2"/>
+              <a:srgbClr val="A9D3F5"/>
             </a:solidFill>
           </a:ln>
         </p:spPr>
@@ -24884,7 +24879,7 @@
           </a:solidFill>
           <a:ln w="28575">
             <a:solidFill>
-              <a:srgbClr val="D9CCF5"/>
+              <a:srgbClr val="CDBFF3"/>
             </a:solidFill>
           </a:ln>
         </p:spPr>
@@ -25258,7 +25253,7 @@
           </a:solidFill>
           <a:ln w="28575">
             <a:solidFill>
-              <a:srgbClr val="FFFFFF"/>
+              <a:srgbClr val="F7A6C4"/>
             </a:solidFill>
           </a:ln>
           <a:effectLst>
@@ -25383,7 +25378,7 @@
           </a:solidFill>
           <a:ln w="28575">
             <a:solidFill>
-              <a:srgbClr val="FFFFFF"/>
+              <a:srgbClr val="A9D3F5"/>
             </a:solidFill>
           </a:ln>
           <a:effectLst>
@@ -25508,7 +25503,7 @@
           </a:solidFill>
           <a:ln w="28575">
             <a:solidFill>
-              <a:srgbClr val="FFFFFF"/>
+              <a:srgbClr val="A8E5BE"/>
             </a:solidFill>
           </a:ln>
           <a:effectLst>
@@ -25633,7 +25628,7 @@
           </a:solidFill>
           <a:ln w="28575">
             <a:solidFill>
-              <a:srgbClr val="FFFFFF"/>
+              <a:srgbClr val="FFE07A"/>
             </a:solidFill>
           </a:ln>
           <a:effectLst>
@@ -26182,7 +26177,7 @@
           </a:solidFill>
           <a:ln w="28575">
             <a:solidFill>
-              <a:srgbClr val="FFFFFF"/>
+              <a:srgbClr val="A8E5BE"/>
             </a:solidFill>
           </a:ln>
           <a:effectLst>
@@ -26488,7 +26483,7 @@
           </a:solidFill>
           <a:ln w="28575">
             <a:solidFill>
-              <a:srgbClr val="C9D3E2"/>
+              <a:srgbClr val="A9D3F5"/>
             </a:solidFill>
           </a:ln>
         </p:spPr>
@@ -26537,7 +26532,7 @@
           </a:solidFill>
           <a:ln w="28575">
             <a:solidFill>
-              <a:srgbClr val="D9CCF5"/>
+              <a:srgbClr val="CDBFF3"/>
             </a:solidFill>
           </a:ln>
         </p:spPr>
@@ -29304,7 +29299,7 @@
           </a:solidFill>
           <a:ln w="28575">
             <a:solidFill>
-              <a:srgbClr val="FFFFFF"/>
+              <a:srgbClr val="A8E5BE"/>
             </a:solidFill>
           </a:ln>
           <a:effectLst>
@@ -29691,7 +29686,7 @@
           </a:solidFill>
           <a:ln w="28575">
             <a:solidFill>
-              <a:srgbClr val="C9D3E2"/>
+              <a:srgbClr val="A9D3F5"/>
             </a:solidFill>
           </a:ln>
         </p:spPr>
@@ -29740,7 +29735,7 @@
           </a:solidFill>
           <a:ln w="28575">
             <a:solidFill>
-              <a:srgbClr val="D9CCF5"/>
+              <a:srgbClr val="CDBFF3"/>
             </a:solidFill>
           </a:ln>
         </p:spPr>
@@ -30117,7 +30112,7 @@
           </a:solidFill>
           <a:ln w="28575">
             <a:solidFill>
-              <a:srgbClr val="FFFFFF"/>
+              <a:srgbClr val="A8E5BE"/>
             </a:solidFill>
           </a:ln>
           <a:effectLst>
@@ -30423,7 +30418,7 @@
           </a:solidFill>
           <a:ln w="28575">
             <a:solidFill>
-              <a:srgbClr val="C9D3E2"/>
+              <a:srgbClr val="A9D3F5"/>
             </a:solidFill>
           </a:ln>
         </p:spPr>
@@ -30472,7 +30467,7 @@
           </a:solidFill>
           <a:ln w="28575">
             <a:solidFill>
-              <a:srgbClr val="D9CCF5"/>
+              <a:srgbClr val="CDBFF3"/>
             </a:solidFill>
           </a:ln>
         </p:spPr>
@@ -31357,7 +31352,7 @@
           </a:solidFill>
           <a:ln w="28575">
             <a:solidFill>
-              <a:srgbClr val="FFFFFF"/>
+              <a:srgbClr val="A8E5BE"/>
             </a:solidFill>
           </a:ln>
           <a:effectLst>
@@ -31744,7 +31739,7 @@
           </a:solidFill>
           <a:ln w="28575">
             <a:solidFill>
-              <a:srgbClr val="C9D3E2"/>
+              <a:srgbClr val="A9D3F5"/>
             </a:solidFill>
           </a:ln>
         </p:spPr>
@@ -31793,7 +31788,7 @@
           </a:solidFill>
           <a:ln w="28575">
             <a:solidFill>
-              <a:srgbClr val="D9CCF5"/>
+              <a:srgbClr val="CDBFF3"/>
             </a:solidFill>
           </a:ln>
         </p:spPr>
@@ -34187,7 +34182,7 @@
           </a:solidFill>
           <a:ln w="28575">
             <a:solidFill>
-              <a:srgbClr val="FFFFFF"/>
+              <a:srgbClr val="F7A6C4"/>
             </a:solidFill>
           </a:ln>
           <a:effectLst>
@@ -34288,7 +34283,7 @@
           </a:solidFill>
           <a:ln w="28575">
             <a:solidFill>
-              <a:srgbClr val="FFFFFF"/>
+              <a:srgbClr val="A9D3F5"/>
             </a:solidFill>
           </a:ln>
           <a:effectLst>
@@ -34389,7 +34384,7 @@
           </a:solidFill>
           <a:ln w="28575">
             <a:solidFill>
-              <a:srgbClr val="FFFFFF"/>
+              <a:srgbClr val="A8E5BE"/>
             </a:solidFill>
           </a:ln>
           <a:effectLst>
@@ -34490,7 +34485,7 @@
           </a:solidFill>
           <a:ln w="28575">
             <a:solidFill>
-              <a:srgbClr val="FFFFFF"/>
+              <a:srgbClr val="FFE07A"/>
             </a:solidFill>
           </a:ln>
           <a:effectLst>
@@ -34591,7 +34586,7 @@
           </a:solidFill>
           <a:ln w="28575">
             <a:solidFill>
-              <a:srgbClr val="FFFFFF"/>
+              <a:srgbClr val="F7A6C4"/>
             </a:solidFill>
           </a:ln>
           <a:effectLst>
@@ -34692,7 +34687,7 @@
           </a:solidFill>
           <a:ln w="28575">
             <a:solidFill>
-              <a:srgbClr val="FFFFFF"/>
+              <a:srgbClr val="A9D3F5"/>
             </a:solidFill>
           </a:ln>
           <a:effectLst>
@@ -35130,7 +35125,7 @@
           </a:solidFill>
           <a:ln w="28575">
             <a:solidFill>
-              <a:srgbClr val="FFFFFF"/>
+              <a:srgbClr val="F7A6C4"/>
             </a:solidFill>
           </a:ln>
           <a:effectLst>
@@ -35517,7 +35512,7 @@
           </a:solidFill>
           <a:ln w="28575">
             <a:solidFill>
-              <a:srgbClr val="C9D3E2"/>
+              <a:srgbClr val="A9D3F5"/>
             </a:solidFill>
           </a:ln>
         </p:spPr>
@@ -35566,7 +35561,7 @@
           </a:solidFill>
           <a:ln w="28575">
             <a:solidFill>
-              <a:srgbClr val="D9CCF5"/>
+              <a:srgbClr val="CDBFF3"/>
             </a:solidFill>
           </a:ln>
         </p:spPr>
@@ -35974,7 +35969,7 @@
           </a:solidFill>
           <a:ln w="28575">
             <a:solidFill>
-              <a:srgbClr val="FFFFFF"/>
+              <a:srgbClr val="F7A6C4"/>
             </a:solidFill>
           </a:ln>
           <a:effectLst>
@@ -36099,7 +36094,7 @@
           </a:solidFill>
           <a:ln w="28575">
             <a:solidFill>
-              <a:srgbClr val="FFFFFF"/>
+              <a:srgbClr val="A9D3F5"/>
             </a:solidFill>
           </a:ln>
           <a:effectLst>
@@ -36224,7 +36219,7 @@
           </a:solidFill>
           <a:ln w="28575">
             <a:solidFill>
-              <a:srgbClr val="FFFFFF"/>
+              <a:srgbClr val="A8E5BE"/>
             </a:solidFill>
           </a:ln>
           <a:effectLst>
@@ -36685,7 +36680,7 @@
           </a:solidFill>
           <a:ln w="28575">
             <a:solidFill>
-              <a:srgbClr val="FFFFFF"/>
+              <a:srgbClr val="A8E5BE"/>
             </a:solidFill>
           </a:ln>
           <a:effectLst>
@@ -36991,7 +36986,7 @@
           </a:solidFill>
           <a:ln w="28575">
             <a:solidFill>
-              <a:srgbClr val="C9D3E2"/>
+              <a:srgbClr val="A9D3F5"/>
             </a:solidFill>
           </a:ln>
         </p:spPr>
@@ -37040,7 +37035,7 @@
           </a:solidFill>
           <a:ln w="28575">
             <a:solidFill>
-              <a:srgbClr val="D9CCF5"/>
+              <a:srgbClr val="CDBFF3"/>
             </a:solidFill>
           </a:ln>
         </p:spPr>

</xml_diff>

<commit_message>
Make-up lessons from class Notes ('Make-up: YYYY-MM-DD HH:MM') show on that day; decks: 'Optional extensions' divider + label
Co-Authored-By: Claude Opus 5.5 <noreply@anthropic.com>
Claude-Session: https://claude.ai/code/session_01WMhLn9wqKhsSQGNMWzVMPf
</commit_message>
<xml_diff>
--- a/materials/B2/B2_6B-2_Music_to_my_ears.pptx
+++ b/materials/B2/B2_6B-2_Music_to_my_ears.pptx
@@ -25,9 +25,10 @@
     <p:sldId id="273" r:id="rId19"/>
     <p:sldId id="274" r:id="rId20"/>
     <p:sldId id="275" r:id="rId21"/>
+    <p:sldId id="276" r:id="rId22"/>
   </p:sldIdLst>
   <p:notesMasterIdLst>
-    <p:notesMasterId r:id="rId22"/>
+    <p:notesMasterId r:id="rId23"/>
   </p:notesMasterIdLst>
   <p:sldSz cx="9144000" cy="5143500"/>
   <p:notesSz cx="5143500" cy="9144000"/>
@@ -1589,8 +1590,8 @@
           <a:p>
             <a:r>
               <a:rPr lang="en-US" dirty="0"/>
-              <a:t>20. Speaking · debate statements (5 min)
-EXTRA (5 min). SB 5. Statements one per click. Each group discusses; then one student must argue the OPPOSITE of what they think ('devil's advocate'). VIDEO 6 (Isata Kanneh-Mason): the video is not in our files – if you have English File Online Practice / the DVD, SB 6a–c work well here (key in SB key 6).</a:t>
+              <a:t>20. OPTIONAL EXTENSIONS
+The lesson ended on the previous slide ("Today you…"). Use the next slides only if there is time left, or keep them for a quick start next lesson.</a:t>
             </a:r>
             <a:endParaRPr lang="en-US" dirty="0"/>
           </a:p>
@@ -1614,6 +1615,95 @@
             <a:fld id="{F7021451-1387-4CA6-816F-3879F97B5CBC}" type="slidenum">
               <a:rPr lang="en-US"/>
               <a:t>20</a:t>
+            </a:fld>
+            <a:endParaRPr lang="en-US"/>
+          </a:p>
+        </p:txBody>
+      </p:sp>
+    </p:spTree>
+    <p:extLst>
+      <p:ext uri="{BB962C8B-B14F-4D97-AF65-F5344CB8AC3E}">
+        <p14:creationId xmlns:p14="http://schemas.microsoft.com/office/powerpoint/2010/main" val="1024086991"/>
+      </p:ext>
+    </p:extLst>
+  </p:cSld>
+  <p:clrMapOvr>
+    <a:masterClrMapping/>
+  </p:clrMapOvr>
+</p:notes>
+</file>
+
+<file path=ppt/notesSlides/notesSlide21.xml><?xml version="1.0" encoding="utf-8"?>
+<p:notes xmlns:a="http://schemas.openxmlformats.org/drawingml/2006/main" xmlns:r="http://schemas.openxmlformats.org/officeDocument/2006/relationships" xmlns:p="http://schemas.openxmlformats.org/presentationml/2006/main">
+  <p:cSld>
+    <p:spTree>
+      <p:nvGrpSpPr>
+        <p:cNvPr id="1" name=""/>
+        <p:cNvGrpSpPr/>
+        <p:nvPr/>
+      </p:nvGrpSpPr>
+      <p:grpSpPr>
+        <a:xfrm>
+          <a:off x="0" y="0"/>
+          <a:ext cx="0" cy="0"/>
+          <a:chOff x="0" y="0"/>
+          <a:chExt cx="0" cy="0"/>
+        </a:xfrm>
+      </p:grpSpPr>
+      <p:sp>
+        <p:nvSpPr>
+          <p:cNvPr id="2" name="Slide Image Placeholder 1"/>
+          <p:cNvSpPr>
+            <a:spLocks noGrp="1" noRot="1" noChangeAspect="1"/>
+          </p:cNvSpPr>
+          <p:nvPr>
+            <p:ph type="sldImg"/>
+          </p:nvPr>
+        </p:nvSpPr>
+        <p:spPr/>
+      </p:sp>
+      <p:sp>
+        <p:nvSpPr>
+          <p:cNvPr id="3" name="Notes Placeholder 2"/>
+          <p:cNvSpPr>
+            <a:spLocks noGrp="1"/>
+          </p:cNvSpPr>
+          <p:nvPr>
+            <p:ph type="body" idx="1"/>
+          </p:nvPr>
+        </p:nvSpPr>
+        <p:spPr/>
+        <p:txBody>
+          <a:bodyPr/>
+          <a:lstStyle/>
+          <a:p>
+            <a:r>
+              <a:rPr lang="en-US" dirty="0"/>
+              <a:t>21. Speaking · debate statements (5 min)
+EXTRA (5 min). SB 5. Statements one per click. Each group discusses; then one student must argue the OPPOSITE of what they think ('devil's advocate'). VIDEO 6 (Isata Kanneh-Mason): the video is not in our files – if you have English File Online Practice / the DVD, SB 6a–c work well here (key in SB key 6).</a:t>
+            </a:r>
+            <a:endParaRPr lang="en-US" dirty="0"/>
+          </a:p>
+        </p:txBody>
+      </p:sp>
+      <p:sp>
+        <p:nvSpPr>
+          <p:cNvPr id="4" name="Slide Number Placeholder 3"/>
+          <p:cNvSpPr>
+            <a:spLocks noGrp="1"/>
+          </p:cNvSpPr>
+          <p:nvPr>
+            <p:ph type="sldNum" sz="quarter" idx="10"/>
+          </p:nvPr>
+        </p:nvSpPr>
+        <p:spPr/>
+        <p:txBody>
+          <a:bodyPr/>
+          <a:lstStyle/>
+          <a:p>
+            <a:fld id="{F7021451-1387-4CA6-816F-3879F97B5CBC}" type="slidenum">
+              <a:rPr lang="en-US"/>
+              <a:t>21</a:t>
             </a:fld>
             <a:endParaRPr lang="en-US"/>
           </a:p>
@@ -22337,7 +22427,187 @@
       </p:grpSpPr>
       <p:sp>
         <p:nvSpPr>
-          <p:cNvPr id="3" name="bd_489"/>
+          <p:cNvPr id="3" name="dv_489"/>
+          <p:cNvSpPr/>
+          <p:nvPr/>
+        </p:nvSpPr>
+        <p:spPr>
+          <a:xfrm>
+            <a:off x="4023360" y="914400"/>
+            <a:ext cx="1097280" cy="914400"/>
+          </a:xfrm>
+          <a:prstGeom prst="rect">
+            <a:avLst/>
+          </a:prstGeom>
+          <a:noFill/>
+          <a:ln/>
+        </p:spPr>
+        <p:txBody>
+          <a:bodyPr wrap="square" lIns="0" tIns="0" rIns="0" bIns="0" rtlCol="0" anchor="ctr"/>
+          <a:lstStyle/>
+          <a:p>
+            <a:pPr algn="ctr" indent="0" marL="0">
+              <a:buNone/>
+            </a:pPr>
+            <a:r>
+              <a:rPr lang="en-US" sz="5400" dirty="0">
+                <a:solidFill>
+                  <a:srgbClr val="000000"/>
+                </a:solidFill>
+              </a:rPr>
+              <a:t>⭐</a:t>
+            </a:r>
+            <a:endParaRPr lang="en-US" sz="5400" dirty="0"/>
+          </a:p>
+        </p:txBody>
+      </p:sp>
+      <p:sp>
+        <p:nvSpPr>
+          <p:cNvPr id="4" name="dvt_490"/>
+          <p:cNvSpPr/>
+          <p:nvPr/>
+        </p:nvSpPr>
+        <p:spPr>
+          <a:xfrm>
+            <a:off x="914400" y="1828800"/>
+            <a:ext cx="7315200" cy="731520"/>
+          </a:xfrm>
+          <a:prstGeom prst="rect">
+            <a:avLst/>
+          </a:prstGeom>
+          <a:noFill/>
+          <a:ln/>
+        </p:spPr>
+        <p:txBody>
+          <a:bodyPr wrap="square" lIns="0" tIns="0" rIns="0" bIns="0" rtlCol="0" anchor="ctr"/>
+          <a:lstStyle/>
+          <a:p>
+            <a:pPr algn="ctr" indent="0" marL="0">
+              <a:buNone/>
+            </a:pPr>
+            <a:r>
+              <a:rPr lang="en-US" sz="3400" dirty="0">
+                <a:solidFill>
+                  <a:srgbClr val="1B2559"/>
+                </a:solidFill>
+                <a:latin typeface="Arial Rounded MT Bold" pitchFamily="34" charset="0"/>
+                <a:ea typeface="Arial Rounded MT Bold" pitchFamily="34" charset="-122"/>
+                <a:cs typeface="Arial Rounded MT Bold" pitchFamily="34" charset="-120"/>
+              </a:rPr>
+              <a:t>Optional extensions</a:t>
+            </a:r>
+            <a:endParaRPr lang="en-US" sz="3400" dirty="0"/>
+          </a:p>
+        </p:txBody>
+      </p:sp>
+      <p:sp>
+        <p:nvSpPr>
+          <p:cNvPr id="5" name="dvs_491"/>
+          <p:cNvSpPr/>
+          <p:nvPr/>
+        </p:nvSpPr>
+        <p:spPr>
+          <a:xfrm>
+            <a:off x="914400" y="2606040"/>
+            <a:ext cx="7315200" cy="457200"/>
+          </a:xfrm>
+          <a:prstGeom prst="rect">
+            <a:avLst/>
+          </a:prstGeom>
+          <a:noFill/>
+          <a:ln/>
+        </p:spPr>
+        <p:txBody>
+          <a:bodyPr wrap="square" lIns="0" tIns="0" rIns="0" bIns="0" rtlCol="0" anchor="ctr"/>
+          <a:lstStyle/>
+          <a:p>
+            <a:pPr algn="ctr" indent="0" marL="0">
+              <a:buNone/>
+            </a:pPr>
+            <a:r>
+              <a:rPr lang="en-US" sz="1250" i="1" dirty="0">
+                <a:solidFill>
+                  <a:srgbClr val="5B6785"/>
+                </a:solidFill>
+                <a:latin typeface="Segoe UI Semibold" pitchFamily="34" charset="0"/>
+                <a:ea typeface="Segoe UI Semibold" pitchFamily="34" charset="-122"/>
+                <a:cs typeface="Segoe UI Semibold" pitchFamily="34" charset="-120"/>
+              </a:rPr>
+              <a:t>Only if there's time – the lesson is finished. · Solo se c'è tempo – la lezione è finita.</a:t>
+            </a:r>
+            <a:endParaRPr lang="en-US" sz="1250" dirty="0"/>
+          </a:p>
+        </p:txBody>
+      </p:sp>
+      <p:pic>
+        <p:nvPicPr>
+          <p:cNvPr id="6" name="logo_492" descr="/home/claude/lls-course/v2/img/logo.png">    </p:cNvPr>
+          <p:cNvPicPr>
+            <a:picLocks noChangeAspect="1"/>
+          </p:cNvPicPr>
+          <p:nvPr/>
+        </p:nvPicPr>
+        <p:blipFill>
+          <a:blip r:embed="rId2"/>
+          <a:stretch>
+            <a:fillRect/>
+          </a:stretch>
+        </p:blipFill>
+        <p:spPr>
+          <a:xfrm>
+            <a:off x="8485632" y="4526280"/>
+            <a:ext cx="502920" cy="502920"/>
+          </a:xfrm>
+          <a:prstGeom prst="rect">
+            <a:avLst/>
+          </a:prstGeom>
+        </p:spPr>
+      </p:pic>
+    </p:spTree>
+  </p:cSld>
+  <p:clrMapOvr>
+    <a:masterClrMapping/>
+  </p:clrMapOvr>
+  <p:transition spd="med">
+    <p:push dir="l"/>
+  </p:transition>
+</p:sld>
+</file>
+
+<file path=ppt/slides/slide21.xml><?xml version="1.0" encoding="utf-8"?>
+<p:sld xmlns:a="http://schemas.openxmlformats.org/drawingml/2006/main" xmlns:r="http://schemas.openxmlformats.org/officeDocument/2006/relationships" xmlns:p="http://schemas.openxmlformats.org/presentationml/2006/main">
+  <p:cSld name="Slide 21">
+    <p:bg>
+      <p:bgPr>
+        <a:blipFill dpi="0" rotWithShape="1">
+          <a:blip r:embed="rId1">
+            <a:lum/>
+          </a:blip>
+          <a:srcRect/>
+          <a:stretch>
+            <a:fillRect/>
+          </a:stretch>
+        </a:blipFill>
+        <a:effectLst/>
+      </p:bgPr>
+    </p:bg>
+    <p:spTree>
+      <p:nvGrpSpPr>
+        <p:cNvPr id="2" name=""/>
+        <p:cNvGrpSpPr/>
+        <p:nvPr/>
+      </p:nvGrpSpPr>
+      <p:grpSpPr>
+        <a:xfrm>
+          <a:off x="0" y="0"/>
+          <a:ext cx="0" cy="0"/>
+          <a:chOff x="0" y="0"/>
+          <a:chExt cx="0" cy="0"/>
+        </a:xfrm>
+      </p:grpSpPr>
+      <p:sp>
+        <p:nvSpPr>
+          <p:cNvPr id="3" name="bd_493"/>
           <p:cNvSpPr/>
           <p:nvPr/>
         </p:nvSpPr>
@@ -22381,7 +22651,7 @@
                 <a:ea typeface="Arial Rounded MT Bold" pitchFamily="34" charset="-122"/>
                 <a:cs typeface="Arial Rounded MT Bold" pitchFamily="34" charset="-120"/>
               </a:rPr>
-              <a:t>20</a:t>
+              <a:t>21</a:t>
             </a:r>
             <a:endParaRPr lang="en-US" sz="2200" dirty="0"/>
           </a:p>
@@ -22389,7 +22659,7 @@
       </p:sp>
       <p:pic>
         <p:nvPicPr>
-          <p:cNvPr id="4" name="brY_490" descr="/home/claude/lls-course/v2/assets/brush-yellow.png">    </p:cNvPr>
+          <p:cNvPr id="4" name="brY_494" descr="/home/claude/lls-course/v2/assets/brush-yellow.png">    </p:cNvPr>
           <p:cNvPicPr>
             <a:picLocks noChangeAspect="1"/>
           </p:cNvPicPr>
@@ -22413,7 +22683,7 @@
       </p:pic>
       <p:sp>
         <p:nvSpPr>
-          <p:cNvPr id="5" name="title_491"/>
+          <p:cNvPr id="5" name="title_495"/>
           <p:cNvSpPr/>
           <p:nvPr/>
         </p:nvSpPr>
@@ -22454,7 +22724,7 @@
       </p:sp>
       <p:pic>
         <p:nvPicPr>
-          <p:cNvPr id="6" name="brP_492" descr="/home/claude/lls-course/v2/assets/brush-pink.png">    </p:cNvPr>
+          <p:cNvPr id="6" name="brP_496" descr="/home/claude/lls-course/v2/assets/brush-pink.png">    </p:cNvPr>
           <p:cNvPicPr>
             <a:picLocks noChangeAspect="1"/>
           </p:cNvPicPr>
@@ -22478,7 +22748,7 @@
       </p:pic>
       <p:sp>
         <p:nvSpPr>
-          <p:cNvPr id="7" name="ins_493"/>
+          <p:cNvPr id="7" name="ins_497"/>
           <p:cNvSpPr/>
           <p:nvPr/>
         </p:nvSpPr>
@@ -22519,7 +22789,7 @@
       </p:sp>
       <p:sp>
         <p:nvSpPr>
-          <p:cNvPr id="8" name="insIT_494"/>
+          <p:cNvPr id="8" name="insIT_498"/>
           <p:cNvSpPr/>
           <p:nvPr/>
         </p:nvSpPr>
@@ -22560,7 +22830,7 @@
       </p:sp>
       <p:sp>
         <p:nvSpPr>
-          <p:cNvPr id="9" name="cmd_495"/>
+          <p:cNvPr id="9" name="cmd_499"/>
           <p:cNvSpPr/>
           <p:nvPr/>
         </p:nvSpPr>
@@ -22641,7 +22911,7 @@
       </p:sp>
       <p:sp>
         <p:nvSpPr>
-          <p:cNvPr id="10" name="meta_496"/>
+          <p:cNvPr id="10" name="meta_500"/>
           <p:cNvSpPr/>
           <p:nvPr/>
         </p:nvSpPr>
@@ -22690,7 +22960,7 @@
       </p:sp>
       <p:sp>
         <p:nvSpPr>
-          <p:cNvPr id="11" name="tag_497"/>
+          <p:cNvPr id="11" name="tag_501"/>
           <p:cNvSpPr/>
           <p:nvPr/>
         </p:nvSpPr>
@@ -22753,7 +23023,7 @@
       </p:sp>
       <p:pic>
         <p:nvPicPr>
-          <p:cNvPr id="12" name="logo_498" descr="/home/claude/lls-course/v2/img/logo.png">    </p:cNvPr>
+          <p:cNvPr id="12" name="logo_502" descr="/home/claude/lls-course/v2/img/logo.png">    </p:cNvPr>
           <p:cNvPicPr>
             <a:picLocks noChangeAspect="1"/>
           </p:cNvPicPr>
@@ -22777,7 +23047,7 @@
       </p:pic>
       <p:sp>
         <p:nvSpPr>
-          <p:cNvPr id="13" name="foot_499"/>
+          <p:cNvPr id="13" name="foot_503"/>
           <p:cNvSpPr/>
           <p:nvPr/>
         </p:nvSpPr>
@@ -22816,61 +23086,54 @@
       </p:sp>
       <p:sp>
         <p:nvSpPr>
-          <p:cNvPr id="14" name="st_500"/>
-          <p:cNvSpPr/>
-          <p:nvPr/>
-        </p:nvSpPr>
-        <p:spPr>
-          <a:xfrm rot="-180000">
-            <a:off x="7315200" y="4773168"/>
-            <a:ext cx="1600200" cy="292608"/>
-          </a:xfrm>
-          <a:prstGeom prst="rect">
-            <a:avLst/>
+          <p:cNvPr id="14" name="ext_504"/>
+          <p:cNvSpPr/>
+          <p:nvPr/>
+        </p:nvSpPr>
+        <p:spPr>
+          <a:xfrm>
+            <a:off x="5120640" y="4727448"/>
+            <a:ext cx="3291840" cy="310896"/>
+          </a:xfrm>
+          <a:prstGeom prst="roundRect">
+            <a:avLst>
+              <a:gd name="adj" fmla="val 50000"/>
+            </a:avLst>
           </a:prstGeom>
           <a:solidFill>
-            <a:srgbClr val="FFE07A"/>
+            <a:srgbClr val="EEE8FB"/>
           </a:solidFill>
-          <a:ln>
+          <a:ln w="28575">
             <a:solidFill>
-              <a:srgbClr val="FFE07A"/>
+              <a:srgbClr val="CDBFF3"/>
             </a:solidFill>
           </a:ln>
-          <a:effectLst>
-            <a:outerShdw sx="100000" sy="100000" kx="0" ky="0" algn="bl" rotWithShape="0" blurRad="88900" dist="31750" dir="5400000">
-              <a:srgbClr val="1B2559">
-                <a:alpha val="15000"/>
-              </a:srgbClr>
-            </a:outerShdw>
-          </a:effectLst>
-        </p:spPr>
-        <p:txBody>
-          <a:bodyPr wrap="square" lIns="50800" tIns="50800" rIns="50800" bIns="50800" rtlCol="0" anchor="ctr">
-            <a:normAutofit/>
-          </a:bodyPr>
+        </p:spPr>
+        <p:txBody>
+          <a:bodyPr wrap="square" lIns="0" tIns="0" rIns="0" bIns="0" rtlCol="0" anchor="ctr"/>
           <a:lstStyle/>
           <a:p>
             <a:pPr algn="ctr" indent="0" marL="0">
               <a:buNone/>
             </a:pPr>
             <a:r>
-              <a:rPr lang="en-US" sz="900" dirty="0">
-                <a:solidFill>
-                  <a:srgbClr val="1B2559"/>
+              <a:rPr lang="en-US" sz="1050" dirty="0">
+                <a:solidFill>
+                  <a:srgbClr val="7B5CD6"/>
                 </a:solidFill>
                 <a:latin typeface="Arial Rounded MT Bold" pitchFamily="34" charset="0"/>
                 <a:ea typeface="Arial Rounded MT Bold" pitchFamily="34" charset="-122"/>
                 <a:cs typeface="Arial Rounded MT Bold" pitchFamily="34" charset="-120"/>
               </a:rPr>
-              <a:t>EXTRA · if there's time</a:t>
-            </a:r>
-            <a:endParaRPr lang="en-US" sz="900" dirty="0"/>
-          </a:p>
-        </p:txBody>
-      </p:sp>
-      <p:sp>
-        <p:nvSpPr>
-          <p:cNvPr id="15" name="cd_501"/>
+              <a:t>⭐ OPTIONAL EXTENSION · only if there's time</a:t>
+            </a:r>
+            <a:endParaRPr lang="en-US" sz="1050" dirty="0"/>
+          </a:p>
+        </p:txBody>
+      </p:sp>
+      <p:sp>
+        <p:nvSpPr>
+          <p:cNvPr id="15" name="cd_505"/>
           <p:cNvSpPr/>
           <p:nvPr/>
         </p:nvSpPr>
@@ -22904,7 +23167,7 @@
       </p:sp>
       <p:sp>
         <p:nvSpPr>
-          <p:cNvPr id="16" name="ii_502"/>
+          <p:cNvPr id="16" name="ii_506"/>
           <p:cNvSpPr/>
           <p:nvPr/>
         </p:nvSpPr>
@@ -22940,7 +23203,7 @@
       </p:sp>
       <p:sp>
         <p:nvSpPr>
-          <p:cNvPr id="17" name="ih_503"/>
+          <p:cNvPr id="17" name="ih_507"/>
           <p:cNvSpPr/>
           <p:nvPr/>
         </p:nvSpPr>
@@ -22979,7 +23242,7 @@
       </p:sp>
       <p:sp>
         <p:nvSpPr>
-          <p:cNvPr id="18" name="il_504"/>
+          <p:cNvPr id="18" name="il_508"/>
           <p:cNvSpPr/>
           <p:nvPr/>
         </p:nvSpPr>
@@ -23096,7 +23359,7 @@
       </p:sp>
       <p:sp>
         <p:nvSpPr>
-          <p:cNvPr id="19" name="R1_qb505"/>
+          <p:cNvPr id="19" name="R1_qb509"/>
           <p:cNvSpPr/>
           <p:nvPr/>
         </p:nvSpPr>
@@ -23148,7 +23411,7 @@
       </p:sp>
       <p:sp>
         <p:nvSpPr>
-          <p:cNvPr id="20" name="R1_sq506"/>
+          <p:cNvPr id="20" name="R1_sq510"/>
           <p:cNvSpPr/>
           <p:nvPr/>
         </p:nvSpPr>
@@ -23221,7 +23484,7 @@
       </p:sp>
       <p:sp>
         <p:nvSpPr>
-          <p:cNvPr id="21" name="R2_qb507"/>
+          <p:cNvPr id="21" name="R2_qb511"/>
           <p:cNvSpPr/>
           <p:nvPr/>
         </p:nvSpPr>
@@ -23273,7 +23536,7 @@
       </p:sp>
       <p:sp>
         <p:nvSpPr>
-          <p:cNvPr id="22" name="R2_sq508"/>
+          <p:cNvPr id="22" name="R2_sq512"/>
           <p:cNvSpPr/>
           <p:nvPr/>
         </p:nvSpPr>
@@ -23346,7 +23609,7 @@
       </p:sp>
       <p:sp>
         <p:nvSpPr>
-          <p:cNvPr id="23" name="R3_qb509"/>
+          <p:cNvPr id="23" name="R3_qb513"/>
           <p:cNvSpPr/>
           <p:nvPr/>
         </p:nvSpPr>
@@ -23398,7 +23661,7 @@
       </p:sp>
       <p:sp>
         <p:nvSpPr>
-          <p:cNvPr id="24" name="R3_sq510"/>
+          <p:cNvPr id="24" name="R3_sq514"/>
           <p:cNvSpPr/>
           <p:nvPr/>
         </p:nvSpPr>
@@ -23471,7 +23734,7 @@
       </p:sp>
       <p:sp>
         <p:nvSpPr>
-          <p:cNvPr id="25" name="R4_qb511"/>
+          <p:cNvPr id="25" name="R4_qb515"/>
           <p:cNvSpPr/>
           <p:nvPr/>
         </p:nvSpPr>
@@ -23523,7 +23786,7 @@
       </p:sp>
       <p:sp>
         <p:nvSpPr>
-          <p:cNvPr id="26" name="R4_sq512"/>
+          <p:cNvPr id="26" name="R4_sq516"/>
           <p:cNvSpPr/>
           <p:nvPr/>
         </p:nvSpPr>
@@ -23596,7 +23859,7 @@
       </p:sp>
       <p:sp>
         <p:nvSpPr>
-          <p:cNvPr id="27" name="R5_qb513"/>
+          <p:cNvPr id="27" name="R5_qb517"/>
           <p:cNvSpPr/>
           <p:nvPr/>
         </p:nvSpPr>
@@ -23648,7 +23911,7 @@
       </p:sp>
       <p:sp>
         <p:nvSpPr>
-          <p:cNvPr id="28" name="R5_sq514"/>
+          <p:cNvPr id="28" name="R5_sq518"/>
           <p:cNvSpPr/>
           <p:nvPr/>
         </p:nvSpPr>

</xml_diff>

<commit_message>
Stop at slide OR page (courses without slides); full A2 2B article; boxes drop lines that repeat the instruction
Co-Authored-By: Claude Opus 5.5 <noreply@anthropic.com>
Claude-Session: https://claude.ai/code/session_01WMhLn9wqKhsSQGNMWzVMPf
</commit_message>
<xml_diff>
--- a/materials/B2/B2_6B-2_Music_to_my_ears.pptx
+++ b/materials/B2/B2_6B-2_Music_to_my_ears.pptx
@@ -8938,11 +8938,11 @@
         <p:spPr>
           <a:xfrm>
             <a:off x="320040" y="1417320"/>
-            <a:ext cx="2788920" cy="3150616"/>
+            <a:ext cx="2788920" cy="2700528"/>
           </a:xfrm>
           <a:prstGeom prst="roundRect">
             <a:avLst>
-              <a:gd name="adj" fmla="val 4590"/>
+              <a:gd name="adj" fmla="val 4740"/>
             </a:avLst>
           </a:prstGeom>
           <a:solidFill>
@@ -9047,7 +9047,7 @@
         <p:spPr>
           <a:xfrm>
             <a:off x="886968" y="1911096"/>
-            <a:ext cx="2130552" cy="2583688"/>
+            <a:ext cx="2130552" cy="2133600"/>
           </a:xfrm>
           <a:prstGeom prst="rect">
             <a:avLst/>
@@ -9062,30 +9062,6 @@
           <a:lstStyle/>
           <a:p>
             <a:pPr marL="152400" indent="-152400">
-              <a:spcAft>
-                <a:spcPts val="200"/>
-              </a:spcAft>
-              <a:buSzPct val="100000"/>
-              <a:buChar char="•"/>
-            </a:pPr>
-            <a:r>
-              <a:rPr lang="en-US" sz="1100" dirty="0">
-                <a:solidFill>
-                  <a:srgbClr val="1B2559"/>
-                </a:solidFill>
-                <a:latin typeface="Segoe UI Semibold" pitchFamily="34" charset="0"/>
-                <a:ea typeface="Segoe UI Semibold" pitchFamily="34" charset="-122"/>
-                <a:cs typeface="Segoe UI Semibold" pitchFamily="34" charset="-120"/>
-              </a:rPr>
-              <a:t>1 minute: read your role and think of 2 reasons.</a:t>
-            </a:r>
-            <a:endParaRPr lang="en-US" sz="1100" dirty="0"/>
-          </a:p>
-          <a:p>
-            <a:pPr marL="152400" indent="-152400">
-              <a:spcBef>
-                <a:spcPts val="600"/>
-              </a:spcBef>
               <a:spcAft>
                 <a:spcPts val="200"/>
               </a:spcAft>

</xml_diff>

<commit_message>
Readings: answers highlighted in the text; easier word box for gap fills; Prepare 1A profiles slide before 'Who…?'
Co-Authored-By: Claude Opus 5.5 <noreply@anthropic.com>
Claude-Session: https://claude.ai/code/session_01WMhLn9wqKhsSQGNMWzVMPf
</commit_message>
<xml_diff>
--- a/materials/B2/B2_6B-2_Music_to_my_ears.pptx
+++ b/materials/B2/B2_6B-2_Music_to_my_ears.pptx
@@ -3527,7 +3527,7 @@
       </p:grpSpPr>
       <p:sp>
         <p:nvSpPr>
-          <p:cNvPr id="3" name="bd_229"/>
+          <p:cNvPr id="3" name="bd_230"/>
           <p:cNvSpPr/>
           <p:nvPr/>
         </p:nvSpPr>
@@ -3579,7 +3579,7 @@
       </p:sp>
       <p:pic>
         <p:nvPicPr>
-          <p:cNvPr id="4" name="brY_230" descr="/home/claude/lls-course/v2/assets/brush-yellow.png">    </p:cNvPr>
+          <p:cNvPr id="4" name="brY_231" descr="/home/claude/lls-course/v2/assets/brush-yellow.png">    </p:cNvPr>
           <p:cNvPicPr>
             <a:picLocks noChangeAspect="1"/>
           </p:cNvPicPr>
@@ -3603,7 +3603,7 @@
       </p:pic>
       <p:sp>
         <p:nvSpPr>
-          <p:cNvPr id="5" name="title_231"/>
+          <p:cNvPr id="5" name="title_232"/>
           <p:cNvSpPr/>
           <p:nvPr/>
         </p:nvSpPr>
@@ -3644,7 +3644,7 @@
       </p:sp>
       <p:pic>
         <p:nvPicPr>
-          <p:cNvPr id="6" name="brP_232" descr="/home/claude/lls-course/v2/assets/brush-pink.png">    </p:cNvPr>
+          <p:cNvPr id="6" name="brP_233" descr="/home/claude/lls-course/v2/assets/brush-pink.png">    </p:cNvPr>
           <p:cNvPicPr>
             <a:picLocks noChangeAspect="1"/>
           </p:cNvPicPr>
@@ -3668,7 +3668,7 @@
       </p:pic>
       <p:sp>
         <p:nvSpPr>
-          <p:cNvPr id="7" name="ins_233"/>
+          <p:cNvPr id="7" name="ins_234"/>
           <p:cNvSpPr/>
           <p:nvPr/>
         </p:nvSpPr>
@@ -3709,7 +3709,7 @@
       </p:sp>
       <p:sp>
         <p:nvSpPr>
-          <p:cNvPr id="8" name="insIT_234"/>
+          <p:cNvPr id="8" name="insIT_235"/>
           <p:cNvSpPr/>
           <p:nvPr/>
         </p:nvSpPr>
@@ -3750,7 +3750,7 @@
       </p:sp>
       <p:sp>
         <p:nvSpPr>
-          <p:cNvPr id="9" name="cmd_235"/>
+          <p:cNvPr id="9" name="cmd_236"/>
           <p:cNvSpPr/>
           <p:nvPr/>
         </p:nvSpPr>
@@ -3831,7 +3831,7 @@
       </p:sp>
       <p:sp>
         <p:nvSpPr>
-          <p:cNvPr id="10" name="meta_236"/>
+          <p:cNvPr id="10" name="meta_237"/>
           <p:cNvSpPr/>
           <p:nvPr/>
         </p:nvSpPr>
@@ -3880,7 +3880,7 @@
       </p:sp>
       <p:sp>
         <p:nvSpPr>
-          <p:cNvPr id="11" name="tag_237"/>
+          <p:cNvPr id="11" name="tag_238"/>
           <p:cNvSpPr/>
           <p:nvPr/>
         </p:nvSpPr>
@@ -3943,7 +3943,7 @@
       </p:sp>
       <p:pic>
         <p:nvPicPr>
-          <p:cNvPr id="12" name="logo_238" descr="/home/claude/lls-course/v2/img/logo.png">    </p:cNvPr>
+          <p:cNvPr id="12" name="logo_239" descr="/home/claude/lls-course/v2/img/logo.png">    </p:cNvPr>
           <p:cNvPicPr>
             <a:picLocks noChangeAspect="1"/>
           </p:cNvPicPr>
@@ -3967,7 +3967,7 @@
       </p:pic>
       <p:sp>
         <p:nvSpPr>
-          <p:cNvPr id="13" name="foot_239"/>
+          <p:cNvPr id="13" name="foot_240"/>
           <p:cNvSpPr/>
           <p:nvPr/>
         </p:nvSpPr>
@@ -4006,7 +4006,7 @@
       </p:sp>
       <p:sp>
         <p:nvSpPr>
-          <p:cNvPr id="14" name="cd_240"/>
+          <p:cNvPr id="14" name="cd_241"/>
           <p:cNvSpPr/>
           <p:nvPr/>
         </p:nvSpPr>
@@ -4040,7 +4040,7 @@
       </p:sp>
       <p:sp>
         <p:nvSpPr>
-          <p:cNvPr id="15" name="rd_241"/>
+          <p:cNvPr id="15" name="rd_242"/>
           <p:cNvSpPr/>
           <p:nvPr/>
         </p:nvSpPr>
@@ -4108,7 +4108,7 @@
       </p:sp>
       <p:sp>
         <p:nvSpPr>
-          <p:cNvPr id="16" name="rd_242"/>
+          <p:cNvPr id="16" name="rd_243"/>
           <p:cNvSpPr/>
           <p:nvPr/>
         </p:nvSpPr>
@@ -4176,7 +4176,7 @@
       </p:sp>
       <p:sp>
         <p:nvSpPr>
-          <p:cNvPr id="17" name="rdl_243"/>
+          <p:cNvPr id="17" name="rdl_244"/>
           <p:cNvSpPr/>
           <p:nvPr/>
         </p:nvSpPr>
@@ -4241,7 +4241,7 @@
       </p:grpSpPr>
       <p:sp>
         <p:nvSpPr>
-          <p:cNvPr id="3" name="bd_244"/>
+          <p:cNvPr id="3" name="bd_245"/>
           <p:cNvSpPr/>
           <p:nvPr/>
         </p:nvSpPr>
@@ -4293,7 +4293,7 @@
       </p:sp>
       <p:pic>
         <p:nvPicPr>
-          <p:cNvPr id="4" name="brY_245" descr="/home/claude/lls-course/v2/assets/brush-yellow.png">    </p:cNvPr>
+          <p:cNvPr id="4" name="brY_246" descr="/home/claude/lls-course/v2/assets/brush-yellow.png">    </p:cNvPr>
           <p:cNvPicPr>
             <a:picLocks noChangeAspect="1"/>
           </p:cNvPicPr>
@@ -4317,7 +4317,7 @@
       </p:pic>
       <p:sp>
         <p:nvSpPr>
-          <p:cNvPr id="5" name="title_246"/>
+          <p:cNvPr id="5" name="title_247"/>
           <p:cNvSpPr/>
           <p:nvPr/>
         </p:nvSpPr>
@@ -4358,7 +4358,7 @@
       </p:sp>
       <p:pic>
         <p:nvPicPr>
-          <p:cNvPr id="6" name="brP_247" descr="/home/claude/lls-course/v2/assets/brush-pink.png">    </p:cNvPr>
+          <p:cNvPr id="6" name="brP_248" descr="/home/claude/lls-course/v2/assets/brush-pink.png">    </p:cNvPr>
           <p:cNvPicPr>
             <a:picLocks noChangeAspect="1"/>
           </p:cNvPicPr>
@@ -4382,7 +4382,7 @@
       </p:pic>
       <p:sp>
         <p:nvSpPr>
-          <p:cNvPr id="7" name="ins_248"/>
+          <p:cNvPr id="7" name="ins_249"/>
           <p:cNvSpPr/>
           <p:nvPr/>
         </p:nvSpPr>
@@ -4423,7 +4423,7 @@
       </p:sp>
       <p:sp>
         <p:nvSpPr>
-          <p:cNvPr id="8" name="insIT_249"/>
+          <p:cNvPr id="8" name="insIT_250"/>
           <p:cNvSpPr/>
           <p:nvPr/>
         </p:nvSpPr>
@@ -4464,7 +4464,7 @@
       </p:sp>
       <p:sp>
         <p:nvSpPr>
-          <p:cNvPr id="9" name="cmd_250"/>
+          <p:cNvPr id="9" name="cmd_251"/>
           <p:cNvSpPr/>
           <p:nvPr/>
         </p:nvSpPr>
@@ -4570,7 +4570,7 @@
       </p:sp>
       <p:sp>
         <p:nvSpPr>
-          <p:cNvPr id="10" name="meta_251"/>
+          <p:cNvPr id="10" name="meta_252"/>
           <p:cNvSpPr/>
           <p:nvPr/>
         </p:nvSpPr>
@@ -4619,7 +4619,7 @@
       </p:sp>
       <p:sp>
         <p:nvSpPr>
-          <p:cNvPr id="11" name="tag_252"/>
+          <p:cNvPr id="11" name="tag_253"/>
           <p:cNvSpPr/>
           <p:nvPr/>
         </p:nvSpPr>
@@ -4682,7 +4682,7 @@
       </p:sp>
       <p:pic>
         <p:nvPicPr>
-          <p:cNvPr id="12" name="logo_253" descr="/home/claude/lls-course/v2/img/logo.png">    </p:cNvPr>
+          <p:cNvPr id="12" name="logo_254" descr="/home/claude/lls-course/v2/img/logo.png">    </p:cNvPr>
           <p:cNvPicPr>
             <a:picLocks noChangeAspect="1"/>
           </p:cNvPicPr>
@@ -4706,7 +4706,7 @@
       </p:pic>
       <p:sp>
         <p:nvSpPr>
-          <p:cNvPr id="13" name="foot_254"/>
+          <p:cNvPr id="13" name="foot_255"/>
           <p:cNvSpPr/>
           <p:nvPr/>
         </p:nvSpPr>
@@ -4745,7 +4745,7 @@
       </p:sp>
       <p:sp>
         <p:nvSpPr>
-          <p:cNvPr id="14" name="bd_255"/>
+          <p:cNvPr id="14" name="bd_256"/>
           <p:cNvSpPr/>
           <p:nvPr/>
         </p:nvSpPr>
@@ -4797,7 +4797,7 @@
       </p:sp>
       <p:sp>
         <p:nvSpPr>
-          <p:cNvPr id="15" name="q_256"/>
+          <p:cNvPr id="15" name="q_257"/>
           <p:cNvSpPr/>
           <p:nvPr/>
         </p:nvSpPr>
@@ -4846,7 +4846,7 @@
       </p:sp>
       <p:sp>
         <p:nvSpPr>
-          <p:cNvPr id="16" name="R1_chip257"/>
+          <p:cNvPr id="16" name="R1_chip258"/>
           <p:cNvSpPr/>
           <p:nvPr/>
         </p:nvSpPr>
@@ -4895,7 +4895,7 @@
       </p:sp>
       <p:sp>
         <p:nvSpPr>
-          <p:cNvPr id="17" name="bd_258"/>
+          <p:cNvPr id="17" name="bd_259"/>
           <p:cNvSpPr/>
           <p:nvPr/>
         </p:nvSpPr>
@@ -4947,7 +4947,7 @@
       </p:sp>
       <p:sp>
         <p:nvSpPr>
-          <p:cNvPr id="18" name="q_259"/>
+          <p:cNvPr id="18" name="q_260"/>
           <p:cNvSpPr/>
           <p:nvPr/>
         </p:nvSpPr>
@@ -4996,7 +4996,7 @@
       </p:sp>
       <p:sp>
         <p:nvSpPr>
-          <p:cNvPr id="19" name="R2_chip260"/>
+          <p:cNvPr id="19" name="R2_chip261"/>
           <p:cNvSpPr/>
           <p:nvPr/>
         </p:nvSpPr>
@@ -5045,7 +5045,7 @@
       </p:sp>
       <p:sp>
         <p:nvSpPr>
-          <p:cNvPr id="20" name="bd_261"/>
+          <p:cNvPr id="20" name="bd_262"/>
           <p:cNvSpPr/>
           <p:nvPr/>
         </p:nvSpPr>
@@ -5097,7 +5097,7 @@
       </p:sp>
       <p:sp>
         <p:nvSpPr>
-          <p:cNvPr id="21" name="q_262"/>
+          <p:cNvPr id="21" name="q_263"/>
           <p:cNvSpPr/>
           <p:nvPr/>
         </p:nvSpPr>
@@ -5146,7 +5146,7 @@
       </p:sp>
       <p:sp>
         <p:nvSpPr>
-          <p:cNvPr id="22" name="R3_chip263"/>
+          <p:cNvPr id="22" name="R3_chip264"/>
           <p:cNvSpPr/>
           <p:nvPr/>
         </p:nvSpPr>
@@ -5195,7 +5195,7 @@
       </p:sp>
       <p:sp>
         <p:nvSpPr>
-          <p:cNvPr id="23" name="bd_264"/>
+          <p:cNvPr id="23" name="bd_265"/>
           <p:cNvSpPr/>
           <p:nvPr/>
         </p:nvSpPr>
@@ -5247,7 +5247,7 @@
       </p:sp>
       <p:sp>
         <p:nvSpPr>
-          <p:cNvPr id="24" name="q_265"/>
+          <p:cNvPr id="24" name="q_266"/>
           <p:cNvSpPr/>
           <p:nvPr/>
         </p:nvSpPr>
@@ -5296,7 +5296,7 @@
       </p:sp>
       <p:sp>
         <p:nvSpPr>
-          <p:cNvPr id="25" name="R4_chip266"/>
+          <p:cNvPr id="25" name="R4_chip267"/>
           <p:cNvSpPr/>
           <p:nvPr/>
         </p:nvSpPr>
@@ -5345,7 +5345,7 @@
       </p:sp>
       <p:sp>
         <p:nvSpPr>
-          <p:cNvPr id="26" name="bd_267"/>
+          <p:cNvPr id="26" name="bd_268"/>
           <p:cNvSpPr/>
           <p:nvPr/>
         </p:nvSpPr>
@@ -5397,7 +5397,7 @@
       </p:sp>
       <p:sp>
         <p:nvSpPr>
-          <p:cNvPr id="27" name="q_268"/>
+          <p:cNvPr id="27" name="q_269"/>
           <p:cNvSpPr/>
           <p:nvPr/>
         </p:nvSpPr>
@@ -5446,7 +5446,7 @@
       </p:sp>
       <p:sp>
         <p:nvSpPr>
-          <p:cNvPr id="28" name="R5_chip269"/>
+          <p:cNvPr id="28" name="R5_chip270"/>
           <p:cNvSpPr/>
           <p:nvPr/>
         </p:nvSpPr>
@@ -5495,7 +5495,7 @@
       </p:sp>
       <p:sp>
         <p:nvSpPr>
-          <p:cNvPr id="29" name="bd_270"/>
+          <p:cNvPr id="29" name="bd_271"/>
           <p:cNvSpPr/>
           <p:nvPr/>
         </p:nvSpPr>
@@ -5547,7 +5547,7 @@
       </p:sp>
       <p:sp>
         <p:nvSpPr>
-          <p:cNvPr id="30" name="q_271"/>
+          <p:cNvPr id="30" name="q_272"/>
           <p:cNvSpPr/>
           <p:nvPr/>
         </p:nvSpPr>
@@ -5596,7 +5596,7 @@
       </p:sp>
       <p:sp>
         <p:nvSpPr>
-          <p:cNvPr id="31" name="R6_chip272"/>
+          <p:cNvPr id="31" name="R6_chip273"/>
           <p:cNvSpPr/>
           <p:nvPr/>
         </p:nvSpPr>
@@ -5645,7 +5645,7 @@
       </p:sp>
       <p:sp>
         <p:nvSpPr>
-          <p:cNvPr id="32" name="bd_273"/>
+          <p:cNvPr id="32" name="bd_274"/>
           <p:cNvSpPr/>
           <p:nvPr/>
         </p:nvSpPr>
@@ -5697,7 +5697,7 @@
       </p:sp>
       <p:sp>
         <p:nvSpPr>
-          <p:cNvPr id="33" name="q_274"/>
+          <p:cNvPr id="33" name="q_275"/>
           <p:cNvSpPr/>
           <p:nvPr/>
         </p:nvSpPr>
@@ -5746,7 +5746,7 @@
       </p:sp>
       <p:sp>
         <p:nvSpPr>
-          <p:cNvPr id="34" name="R7_chip275"/>
+          <p:cNvPr id="34" name="R7_chip276"/>
           <p:cNvSpPr/>
           <p:nvPr/>
         </p:nvSpPr>
@@ -5795,7 +5795,7 @@
       </p:sp>
       <p:sp>
         <p:nvSpPr>
-          <p:cNvPr id="35" name="bd_276"/>
+          <p:cNvPr id="35" name="bd_277"/>
           <p:cNvSpPr/>
           <p:nvPr/>
         </p:nvSpPr>
@@ -5847,7 +5847,7 @@
       </p:sp>
       <p:sp>
         <p:nvSpPr>
-          <p:cNvPr id="36" name="q_277"/>
+          <p:cNvPr id="36" name="q_278"/>
           <p:cNvSpPr/>
           <p:nvPr/>
         </p:nvSpPr>
@@ -5896,7 +5896,7 @@
       </p:sp>
       <p:sp>
         <p:nvSpPr>
-          <p:cNvPr id="37" name="R8_chip278"/>
+          <p:cNvPr id="37" name="R8_chip279"/>
           <p:cNvSpPr/>
           <p:nvPr/>
         </p:nvSpPr>
@@ -6441,7 +6441,7 @@
       </p:grpSpPr>
       <p:sp>
         <p:nvSpPr>
-          <p:cNvPr id="3" name="bd_279"/>
+          <p:cNvPr id="3" name="bd_280"/>
           <p:cNvSpPr/>
           <p:nvPr/>
         </p:nvSpPr>
@@ -6493,7 +6493,7 @@
       </p:sp>
       <p:pic>
         <p:nvPicPr>
-          <p:cNvPr id="4" name="brY_280" descr="/home/claude/lls-course/v2/assets/brush-yellow.png">    </p:cNvPr>
+          <p:cNvPr id="4" name="brY_281" descr="/home/claude/lls-course/v2/assets/brush-yellow.png">    </p:cNvPr>
           <p:cNvPicPr>
             <a:picLocks noChangeAspect="1"/>
           </p:cNvPicPr>
@@ -6517,7 +6517,7 @@
       </p:pic>
       <p:sp>
         <p:nvSpPr>
-          <p:cNvPr id="5" name="title_281"/>
+          <p:cNvPr id="5" name="title_282"/>
           <p:cNvSpPr/>
           <p:nvPr/>
         </p:nvSpPr>
@@ -6558,7 +6558,7 @@
       </p:sp>
       <p:pic>
         <p:nvPicPr>
-          <p:cNvPr id="6" name="brP_282" descr="/home/claude/lls-course/v2/assets/brush-pink.png">    </p:cNvPr>
+          <p:cNvPr id="6" name="brP_283" descr="/home/claude/lls-course/v2/assets/brush-pink.png">    </p:cNvPr>
           <p:cNvPicPr>
             <a:picLocks noChangeAspect="1"/>
           </p:cNvPicPr>
@@ -6582,7 +6582,7 @@
       </p:pic>
       <p:sp>
         <p:nvSpPr>
-          <p:cNvPr id="7" name="ins_283"/>
+          <p:cNvPr id="7" name="ins_284"/>
           <p:cNvSpPr/>
           <p:nvPr/>
         </p:nvSpPr>
@@ -6623,7 +6623,7 @@
       </p:sp>
       <p:sp>
         <p:nvSpPr>
-          <p:cNvPr id="8" name="insIT_284"/>
+          <p:cNvPr id="8" name="insIT_285"/>
           <p:cNvSpPr/>
           <p:nvPr/>
         </p:nvSpPr>
@@ -6664,7 +6664,7 @@
       </p:sp>
       <p:sp>
         <p:nvSpPr>
-          <p:cNvPr id="9" name="cmd_285"/>
+          <p:cNvPr id="9" name="cmd_286"/>
           <p:cNvSpPr/>
           <p:nvPr/>
         </p:nvSpPr>
@@ -6745,7 +6745,7 @@
       </p:sp>
       <p:sp>
         <p:nvSpPr>
-          <p:cNvPr id="10" name="meta_286"/>
+          <p:cNvPr id="10" name="meta_287"/>
           <p:cNvSpPr/>
           <p:nvPr/>
         </p:nvSpPr>
@@ -6794,7 +6794,7 @@
       </p:sp>
       <p:sp>
         <p:nvSpPr>
-          <p:cNvPr id="11" name="tag_287"/>
+          <p:cNvPr id="11" name="tag_288"/>
           <p:cNvSpPr/>
           <p:nvPr/>
         </p:nvSpPr>
@@ -6857,7 +6857,7 @@
       </p:sp>
       <p:pic>
         <p:nvPicPr>
-          <p:cNvPr id="12" name="logo_288" descr="/home/claude/lls-course/v2/img/logo.png">    </p:cNvPr>
+          <p:cNvPr id="12" name="logo_289" descr="/home/claude/lls-course/v2/img/logo.png">    </p:cNvPr>
           <p:cNvPicPr>
             <a:picLocks noChangeAspect="1"/>
           </p:cNvPicPr>
@@ -6881,7 +6881,7 @@
       </p:pic>
       <p:sp>
         <p:nvSpPr>
-          <p:cNvPr id="13" name="foot_289"/>
+          <p:cNvPr id="13" name="foot_290"/>
           <p:cNvSpPr/>
           <p:nvPr/>
         </p:nvSpPr>
@@ -6920,7 +6920,7 @@
       </p:sp>
       <p:sp>
         <p:nvSpPr>
-          <p:cNvPr id="14" name="bd_290"/>
+          <p:cNvPr id="14" name="bd_291"/>
           <p:cNvSpPr/>
           <p:nvPr/>
         </p:nvSpPr>
@@ -6972,7 +6972,7 @@
       </p:sp>
       <p:sp>
         <p:nvSpPr>
-          <p:cNvPr id="15" name="q_291"/>
+          <p:cNvPr id="15" name="q_292"/>
           <p:cNvSpPr/>
           <p:nvPr/>
         </p:nvSpPr>
@@ -7021,7 +7021,7 @@
       </p:sp>
       <p:sp>
         <p:nvSpPr>
-          <p:cNvPr id="16" name="R1_chip292"/>
+          <p:cNvPr id="16" name="R1_chip293"/>
           <p:cNvSpPr/>
           <p:nvPr/>
         </p:nvSpPr>
@@ -7101,7 +7101,7 @@
       </p:sp>
       <p:sp>
         <p:nvSpPr>
-          <p:cNvPr id="17" name="bd_293"/>
+          <p:cNvPr id="17" name="bd_294"/>
           <p:cNvSpPr/>
           <p:nvPr/>
         </p:nvSpPr>
@@ -7153,7 +7153,7 @@
       </p:sp>
       <p:sp>
         <p:nvSpPr>
-          <p:cNvPr id="18" name="q_294"/>
+          <p:cNvPr id="18" name="q_295"/>
           <p:cNvSpPr/>
           <p:nvPr/>
         </p:nvSpPr>
@@ -7202,7 +7202,7 @@
       </p:sp>
       <p:sp>
         <p:nvSpPr>
-          <p:cNvPr id="19" name="R2_chip295"/>
+          <p:cNvPr id="19" name="R2_chip296"/>
           <p:cNvSpPr/>
           <p:nvPr/>
         </p:nvSpPr>
@@ -7282,7 +7282,7 @@
       </p:sp>
       <p:sp>
         <p:nvSpPr>
-          <p:cNvPr id="20" name="bd_296"/>
+          <p:cNvPr id="20" name="bd_297"/>
           <p:cNvSpPr/>
           <p:nvPr/>
         </p:nvSpPr>
@@ -7334,7 +7334,7 @@
       </p:sp>
       <p:sp>
         <p:nvSpPr>
-          <p:cNvPr id="21" name="q_297"/>
+          <p:cNvPr id="21" name="q_298"/>
           <p:cNvSpPr/>
           <p:nvPr/>
         </p:nvSpPr>
@@ -7383,7 +7383,7 @@
       </p:sp>
       <p:sp>
         <p:nvSpPr>
-          <p:cNvPr id="22" name="R3_chip298"/>
+          <p:cNvPr id="22" name="R3_chip299"/>
           <p:cNvSpPr/>
           <p:nvPr/>
         </p:nvSpPr>
@@ -7463,7 +7463,7 @@
       </p:sp>
       <p:sp>
         <p:nvSpPr>
-          <p:cNvPr id="23" name="bd_299"/>
+          <p:cNvPr id="23" name="bd_300"/>
           <p:cNvSpPr/>
           <p:nvPr/>
         </p:nvSpPr>
@@ -7515,7 +7515,7 @@
       </p:sp>
       <p:sp>
         <p:nvSpPr>
-          <p:cNvPr id="24" name="q_300"/>
+          <p:cNvPr id="24" name="q_301"/>
           <p:cNvSpPr/>
           <p:nvPr/>
         </p:nvSpPr>
@@ -7564,7 +7564,7 @@
       </p:sp>
       <p:sp>
         <p:nvSpPr>
-          <p:cNvPr id="25" name="R4_chip301"/>
+          <p:cNvPr id="25" name="R4_chip302"/>
           <p:cNvSpPr/>
           <p:nvPr/>
         </p:nvSpPr>
@@ -7644,7 +7644,7 @@
       </p:sp>
       <p:sp>
         <p:nvSpPr>
-          <p:cNvPr id="26" name="bd_302"/>
+          <p:cNvPr id="26" name="bd_303"/>
           <p:cNvSpPr/>
           <p:nvPr/>
         </p:nvSpPr>
@@ -7696,7 +7696,7 @@
       </p:sp>
       <p:sp>
         <p:nvSpPr>
-          <p:cNvPr id="27" name="q_303"/>
+          <p:cNvPr id="27" name="q_304"/>
           <p:cNvSpPr/>
           <p:nvPr/>
         </p:nvSpPr>
@@ -7745,7 +7745,7 @@
       </p:sp>
       <p:sp>
         <p:nvSpPr>
-          <p:cNvPr id="28" name="R5_chip304"/>
+          <p:cNvPr id="28" name="R5_chip305"/>
           <p:cNvSpPr/>
           <p:nvPr/>
         </p:nvSpPr>
@@ -7825,7 +7825,7 @@
       </p:sp>
       <p:sp>
         <p:nvSpPr>
-          <p:cNvPr id="29" name="bd_305"/>
+          <p:cNvPr id="29" name="bd_306"/>
           <p:cNvSpPr/>
           <p:nvPr/>
         </p:nvSpPr>
@@ -7877,7 +7877,7 @@
       </p:sp>
       <p:sp>
         <p:nvSpPr>
-          <p:cNvPr id="30" name="q_306"/>
+          <p:cNvPr id="30" name="q_307"/>
           <p:cNvSpPr/>
           <p:nvPr/>
         </p:nvSpPr>
@@ -7926,7 +7926,7 @@
       </p:sp>
       <p:sp>
         <p:nvSpPr>
-          <p:cNvPr id="31" name="R6_chip307"/>
+          <p:cNvPr id="31" name="R6_chip308"/>
           <p:cNvSpPr/>
           <p:nvPr/>
         </p:nvSpPr>
@@ -8427,7 +8427,7 @@
       </p:grpSpPr>
       <p:sp>
         <p:nvSpPr>
-          <p:cNvPr id="3" name="bd_308"/>
+          <p:cNvPr id="3" name="bd_309"/>
           <p:cNvSpPr/>
           <p:nvPr/>
         </p:nvSpPr>
@@ -8479,7 +8479,7 @@
       </p:sp>
       <p:pic>
         <p:nvPicPr>
-          <p:cNvPr id="4" name="brY_309" descr="/home/claude/lls-course/v2/assets/brush-yellow.png">    </p:cNvPr>
+          <p:cNvPr id="4" name="brY_310" descr="/home/claude/lls-course/v2/assets/brush-yellow.png">    </p:cNvPr>
           <p:cNvPicPr>
             <a:picLocks noChangeAspect="1"/>
           </p:cNvPicPr>
@@ -8503,7 +8503,7 @@
       </p:pic>
       <p:sp>
         <p:nvSpPr>
-          <p:cNvPr id="5" name="title_310"/>
+          <p:cNvPr id="5" name="title_311"/>
           <p:cNvSpPr/>
           <p:nvPr/>
         </p:nvSpPr>
@@ -8544,7 +8544,7 @@
       </p:sp>
       <p:pic>
         <p:nvPicPr>
-          <p:cNvPr id="6" name="brP_311" descr="/home/claude/lls-course/v2/assets/brush-pink.png">    </p:cNvPr>
+          <p:cNvPr id="6" name="brP_312" descr="/home/claude/lls-course/v2/assets/brush-pink.png">    </p:cNvPr>
           <p:cNvPicPr>
             <a:picLocks noChangeAspect="1"/>
           </p:cNvPicPr>
@@ -8568,7 +8568,7 @@
       </p:pic>
       <p:sp>
         <p:nvSpPr>
-          <p:cNvPr id="7" name="ins_312"/>
+          <p:cNvPr id="7" name="ins_313"/>
           <p:cNvSpPr/>
           <p:nvPr/>
         </p:nvSpPr>
@@ -8609,7 +8609,7 @@
       </p:sp>
       <p:sp>
         <p:nvSpPr>
-          <p:cNvPr id="8" name="insIT_313"/>
+          <p:cNvPr id="8" name="insIT_314"/>
           <p:cNvSpPr/>
           <p:nvPr/>
         </p:nvSpPr>
@@ -8650,7 +8650,7 @@
       </p:sp>
       <p:sp>
         <p:nvSpPr>
-          <p:cNvPr id="9" name="cmd_314"/>
+          <p:cNvPr id="9" name="cmd_315"/>
           <p:cNvSpPr/>
           <p:nvPr/>
         </p:nvSpPr>
@@ -8756,7 +8756,7 @@
       </p:sp>
       <p:sp>
         <p:nvSpPr>
-          <p:cNvPr id="10" name="meta_315"/>
+          <p:cNvPr id="10" name="meta_316"/>
           <p:cNvSpPr/>
           <p:nvPr/>
         </p:nvSpPr>
@@ -8805,7 +8805,7 @@
       </p:sp>
       <p:sp>
         <p:nvSpPr>
-          <p:cNvPr id="11" name="tag_316"/>
+          <p:cNvPr id="11" name="tag_317"/>
           <p:cNvSpPr/>
           <p:nvPr/>
         </p:nvSpPr>
@@ -8868,7 +8868,7 @@
       </p:sp>
       <p:pic>
         <p:nvPicPr>
-          <p:cNvPr id="12" name="logo_317" descr="/home/claude/lls-course/v2/img/logo.png">    </p:cNvPr>
+          <p:cNvPr id="12" name="logo_318" descr="/home/claude/lls-course/v2/img/logo.png">    </p:cNvPr>
           <p:cNvPicPr>
             <a:picLocks noChangeAspect="1"/>
           </p:cNvPicPr>
@@ -8892,7 +8892,7 @@
       </p:pic>
       <p:sp>
         <p:nvSpPr>
-          <p:cNvPr id="13" name="foot_318"/>
+          <p:cNvPr id="13" name="foot_319"/>
           <p:cNvSpPr/>
           <p:nvPr/>
         </p:nvSpPr>
@@ -8931,7 +8931,7 @@
       </p:sp>
       <p:sp>
         <p:nvSpPr>
-          <p:cNvPr id="14" name="cd_319"/>
+          <p:cNvPr id="14" name="cd_320"/>
           <p:cNvSpPr/>
           <p:nvPr/>
         </p:nvSpPr>
@@ -8965,7 +8965,7 @@
       </p:sp>
       <p:sp>
         <p:nvSpPr>
-          <p:cNvPr id="15" name="ii_320"/>
+          <p:cNvPr id="15" name="ii_321"/>
           <p:cNvSpPr/>
           <p:nvPr/>
         </p:nvSpPr>
@@ -9001,7 +9001,7 @@
       </p:sp>
       <p:sp>
         <p:nvSpPr>
-          <p:cNvPr id="16" name="ih_321"/>
+          <p:cNvPr id="16" name="ih_322"/>
           <p:cNvSpPr/>
           <p:nvPr/>
         </p:nvSpPr>
@@ -9040,7 +9040,7 @@
       </p:sp>
       <p:sp>
         <p:nvSpPr>
-          <p:cNvPr id="17" name="il_322"/>
+          <p:cNvPr id="17" name="il_323"/>
           <p:cNvSpPr/>
           <p:nvPr/>
         </p:nvSpPr>
@@ -9157,7 +9157,7 @@
       </p:sp>
       <p:sp>
         <p:nvSpPr>
-          <p:cNvPr id="18" name="R1_qb323"/>
+          <p:cNvPr id="18" name="R1_qb324"/>
           <p:cNvSpPr/>
           <p:nvPr/>
         </p:nvSpPr>
@@ -9209,7 +9209,7 @@
       </p:sp>
       <p:sp>
         <p:nvSpPr>
-          <p:cNvPr id="19" name="R1_sq324"/>
+          <p:cNvPr id="19" name="R1_sq325"/>
           <p:cNvSpPr/>
           <p:nvPr/>
         </p:nvSpPr>
@@ -9282,7 +9282,7 @@
       </p:sp>
       <p:sp>
         <p:nvSpPr>
-          <p:cNvPr id="20" name="R2_qb325"/>
+          <p:cNvPr id="20" name="R2_qb326"/>
           <p:cNvSpPr/>
           <p:nvPr/>
         </p:nvSpPr>
@@ -9334,7 +9334,7 @@
       </p:sp>
       <p:sp>
         <p:nvSpPr>
-          <p:cNvPr id="21" name="R2_sq326"/>
+          <p:cNvPr id="21" name="R2_sq327"/>
           <p:cNvSpPr/>
           <p:nvPr/>
         </p:nvSpPr>
@@ -9407,7 +9407,7 @@
       </p:sp>
       <p:sp>
         <p:nvSpPr>
-          <p:cNvPr id="22" name="R3_qb327"/>
+          <p:cNvPr id="22" name="R3_qb328"/>
           <p:cNvSpPr/>
           <p:nvPr/>
         </p:nvSpPr>
@@ -9459,7 +9459,7 @@
       </p:sp>
       <p:sp>
         <p:nvSpPr>
-          <p:cNvPr id="23" name="R3_sq328"/>
+          <p:cNvPr id="23" name="R3_sq329"/>
           <p:cNvSpPr/>
           <p:nvPr/>
         </p:nvSpPr>
@@ -9532,7 +9532,7 @@
       </p:sp>
       <p:sp>
         <p:nvSpPr>
-          <p:cNvPr id="24" name="R4_qb329"/>
+          <p:cNvPr id="24" name="R4_qb330"/>
           <p:cNvSpPr/>
           <p:nvPr/>
         </p:nvSpPr>
@@ -9584,7 +9584,7 @@
       </p:sp>
       <p:sp>
         <p:nvSpPr>
-          <p:cNvPr id="25" name="R4_sq330"/>
+          <p:cNvPr id="25" name="R4_sq331"/>
           <p:cNvSpPr/>
           <p:nvPr/>
         </p:nvSpPr>
@@ -10081,7 +10081,7 @@
       </p:grpSpPr>
       <p:sp>
         <p:nvSpPr>
-          <p:cNvPr id="3" name="bd_331"/>
+          <p:cNvPr id="3" name="bd_332"/>
           <p:cNvSpPr/>
           <p:nvPr/>
         </p:nvSpPr>
@@ -10133,7 +10133,7 @@
       </p:sp>
       <p:pic>
         <p:nvPicPr>
-          <p:cNvPr id="4" name="brY_332" descr="/home/claude/lls-course/v2/assets/brush-yellow.png">    </p:cNvPr>
+          <p:cNvPr id="4" name="brY_333" descr="/home/claude/lls-course/v2/assets/brush-yellow.png">    </p:cNvPr>
           <p:cNvPicPr>
             <a:picLocks noChangeAspect="1"/>
           </p:cNvPicPr>
@@ -10157,7 +10157,7 @@
       </p:pic>
       <p:sp>
         <p:nvSpPr>
-          <p:cNvPr id="5" name="title_333"/>
+          <p:cNvPr id="5" name="title_334"/>
           <p:cNvSpPr/>
           <p:nvPr/>
         </p:nvSpPr>
@@ -10198,7 +10198,7 @@
       </p:sp>
       <p:pic>
         <p:nvPicPr>
-          <p:cNvPr id="6" name="brP_334" descr="/home/claude/lls-course/v2/assets/brush-pink.png">    </p:cNvPr>
+          <p:cNvPr id="6" name="brP_335" descr="/home/claude/lls-course/v2/assets/brush-pink.png">    </p:cNvPr>
           <p:cNvPicPr>
             <a:picLocks noChangeAspect="1"/>
           </p:cNvPicPr>
@@ -10222,7 +10222,7 @@
       </p:pic>
       <p:sp>
         <p:nvSpPr>
-          <p:cNvPr id="7" name="ins_335"/>
+          <p:cNvPr id="7" name="ins_336"/>
           <p:cNvSpPr/>
           <p:nvPr/>
         </p:nvSpPr>
@@ -10263,7 +10263,7 @@
       </p:sp>
       <p:sp>
         <p:nvSpPr>
-          <p:cNvPr id="8" name="insIT_336"/>
+          <p:cNvPr id="8" name="insIT_337"/>
           <p:cNvSpPr/>
           <p:nvPr/>
         </p:nvSpPr>
@@ -10304,7 +10304,7 @@
       </p:sp>
       <p:sp>
         <p:nvSpPr>
-          <p:cNvPr id="9" name="cmd_337"/>
+          <p:cNvPr id="9" name="cmd_338"/>
           <p:cNvSpPr/>
           <p:nvPr/>
         </p:nvSpPr>
@@ -10385,7 +10385,7 @@
       </p:sp>
       <p:sp>
         <p:nvSpPr>
-          <p:cNvPr id="10" name="meta_338"/>
+          <p:cNvPr id="10" name="meta_339"/>
           <p:cNvSpPr/>
           <p:nvPr/>
         </p:nvSpPr>
@@ -10434,7 +10434,7 @@
       </p:sp>
       <p:sp>
         <p:nvSpPr>
-          <p:cNvPr id="11" name="tag_339"/>
+          <p:cNvPr id="11" name="tag_340"/>
           <p:cNvSpPr/>
           <p:nvPr/>
         </p:nvSpPr>
@@ -10497,7 +10497,7 @@
       </p:sp>
       <p:pic>
         <p:nvPicPr>
-          <p:cNvPr id="12" name="logo_340" descr="/home/claude/lls-course/v2/img/logo.png">    </p:cNvPr>
+          <p:cNvPr id="12" name="logo_341" descr="/home/claude/lls-course/v2/img/logo.png">    </p:cNvPr>
           <p:cNvPicPr>
             <a:picLocks noChangeAspect="1"/>
           </p:cNvPicPr>
@@ -10521,7 +10521,7 @@
       </p:pic>
       <p:sp>
         <p:nvSpPr>
-          <p:cNvPr id="13" name="foot_341"/>
+          <p:cNvPr id="13" name="foot_342"/>
           <p:cNvSpPr/>
           <p:nvPr/>
         </p:nvSpPr>
@@ -10560,7 +10560,7 @@
       </p:sp>
       <p:sp>
         <p:nvSpPr>
-          <p:cNvPr id="14" name="cd_342"/>
+          <p:cNvPr id="14" name="cd_343"/>
           <p:cNvSpPr/>
           <p:nvPr/>
         </p:nvSpPr>
@@ -10594,7 +10594,7 @@
       </p:sp>
       <p:sp>
         <p:nvSpPr>
-          <p:cNvPr id="15" name="ii_343"/>
+          <p:cNvPr id="15" name="ii_344"/>
           <p:cNvSpPr/>
           <p:nvPr/>
         </p:nvSpPr>
@@ -10630,7 +10630,7 @@
       </p:sp>
       <p:sp>
         <p:nvSpPr>
-          <p:cNvPr id="16" name="ih_344"/>
+          <p:cNvPr id="16" name="ih_345"/>
           <p:cNvSpPr/>
           <p:nvPr/>
         </p:nvSpPr>
@@ -10669,7 +10669,7 @@
       </p:sp>
       <p:sp>
         <p:nvSpPr>
-          <p:cNvPr id="17" name="il_345"/>
+          <p:cNvPr id="17" name="il_346"/>
           <p:cNvSpPr/>
           <p:nvPr/>
         </p:nvSpPr>
@@ -10834,7 +10834,7 @@
       </p:sp>
       <p:sp>
         <p:nvSpPr>
-          <p:cNvPr id="18" name="R1_qb346"/>
+          <p:cNvPr id="18" name="R1_qb347"/>
           <p:cNvSpPr/>
           <p:nvPr/>
         </p:nvSpPr>
@@ -10886,7 +10886,7 @@
       </p:sp>
       <p:sp>
         <p:nvSpPr>
-          <p:cNvPr id="19" name="R1_sq347"/>
+          <p:cNvPr id="19" name="R1_sq348"/>
           <p:cNvSpPr/>
           <p:nvPr/>
         </p:nvSpPr>
@@ -10959,7 +10959,7 @@
       </p:sp>
       <p:sp>
         <p:nvSpPr>
-          <p:cNvPr id="20" name="R2_qb348"/>
+          <p:cNvPr id="20" name="R2_qb349"/>
           <p:cNvSpPr/>
           <p:nvPr/>
         </p:nvSpPr>
@@ -11011,7 +11011,7 @@
       </p:sp>
       <p:sp>
         <p:nvSpPr>
-          <p:cNvPr id="21" name="R2_sq349"/>
+          <p:cNvPr id="21" name="R2_sq350"/>
           <p:cNvSpPr/>
           <p:nvPr/>
         </p:nvSpPr>
@@ -11084,7 +11084,7 @@
       </p:sp>
       <p:sp>
         <p:nvSpPr>
-          <p:cNvPr id="22" name="R3_qb350"/>
+          <p:cNvPr id="22" name="R3_qb351"/>
           <p:cNvSpPr/>
           <p:nvPr/>
         </p:nvSpPr>
@@ -11136,7 +11136,7 @@
       </p:sp>
       <p:sp>
         <p:nvSpPr>
-          <p:cNvPr id="23" name="R3_sq351"/>
+          <p:cNvPr id="23" name="R3_sq352"/>
           <p:cNvSpPr/>
           <p:nvPr/>
         </p:nvSpPr>
@@ -11209,7 +11209,7 @@
       </p:sp>
       <p:sp>
         <p:nvSpPr>
-          <p:cNvPr id="24" name="R4_qb352"/>
+          <p:cNvPr id="24" name="R4_qb353"/>
           <p:cNvSpPr/>
           <p:nvPr/>
         </p:nvSpPr>
@@ -11261,7 +11261,7 @@
       </p:sp>
       <p:sp>
         <p:nvSpPr>
-          <p:cNvPr id="25" name="R4_sq353"/>
+          <p:cNvPr id="25" name="R4_sq354"/>
           <p:cNvSpPr/>
           <p:nvPr/>
         </p:nvSpPr>
@@ -11334,7 +11334,7 @@
       </p:sp>
       <p:sp>
         <p:nvSpPr>
-          <p:cNvPr id="26" name="R5_qb354"/>
+          <p:cNvPr id="26" name="R5_qb355"/>
           <p:cNvSpPr/>
           <p:nvPr/>
         </p:nvSpPr>
@@ -11386,7 +11386,7 @@
       </p:sp>
       <p:sp>
         <p:nvSpPr>
-          <p:cNvPr id="27" name="R5_sq355"/>
+          <p:cNvPr id="27" name="R5_sq356"/>
           <p:cNvSpPr/>
           <p:nvPr/>
         </p:nvSpPr>
@@ -11971,7 +11971,7 @@
       </p:grpSpPr>
       <p:sp>
         <p:nvSpPr>
-          <p:cNvPr id="3" name="bd_356"/>
+          <p:cNvPr id="3" name="bd_357"/>
           <p:cNvSpPr/>
           <p:nvPr/>
         </p:nvSpPr>
@@ -12023,7 +12023,7 @@
       </p:sp>
       <p:pic>
         <p:nvPicPr>
-          <p:cNvPr id="4" name="brY_357" descr="/home/claude/lls-course/v2/assets/brush-yellow.png">    </p:cNvPr>
+          <p:cNvPr id="4" name="brY_358" descr="/home/claude/lls-course/v2/assets/brush-yellow.png">    </p:cNvPr>
           <p:cNvPicPr>
             <a:picLocks noChangeAspect="1"/>
           </p:cNvPicPr>
@@ -12047,7 +12047,7 @@
       </p:pic>
       <p:sp>
         <p:nvSpPr>
-          <p:cNvPr id="5" name="title_358"/>
+          <p:cNvPr id="5" name="title_359"/>
           <p:cNvSpPr/>
           <p:nvPr/>
         </p:nvSpPr>
@@ -12088,7 +12088,7 @@
       </p:sp>
       <p:pic>
         <p:nvPicPr>
-          <p:cNvPr id="6" name="brP_359" descr="/home/claude/lls-course/v2/assets/brush-pink.png">    </p:cNvPr>
+          <p:cNvPr id="6" name="brP_360" descr="/home/claude/lls-course/v2/assets/brush-pink.png">    </p:cNvPr>
           <p:cNvPicPr>
             <a:picLocks noChangeAspect="1"/>
           </p:cNvPicPr>
@@ -12112,7 +12112,7 @@
       </p:pic>
       <p:sp>
         <p:nvSpPr>
-          <p:cNvPr id="7" name="ins_360"/>
+          <p:cNvPr id="7" name="ins_361"/>
           <p:cNvSpPr/>
           <p:nvPr/>
         </p:nvSpPr>
@@ -12153,7 +12153,7 @@
       </p:sp>
       <p:sp>
         <p:nvSpPr>
-          <p:cNvPr id="8" name="insIT_361"/>
+          <p:cNvPr id="8" name="insIT_362"/>
           <p:cNvSpPr/>
           <p:nvPr/>
         </p:nvSpPr>
@@ -12194,7 +12194,7 @@
       </p:sp>
       <p:sp>
         <p:nvSpPr>
-          <p:cNvPr id="9" name="cmd_362"/>
+          <p:cNvPr id="9" name="cmd_363"/>
           <p:cNvSpPr/>
           <p:nvPr/>
         </p:nvSpPr>
@@ -12300,7 +12300,7 @@
       </p:sp>
       <p:sp>
         <p:nvSpPr>
-          <p:cNvPr id="10" name="meta_363"/>
+          <p:cNvPr id="10" name="meta_364"/>
           <p:cNvSpPr/>
           <p:nvPr/>
         </p:nvSpPr>
@@ -12349,7 +12349,7 @@
       </p:sp>
       <p:sp>
         <p:nvSpPr>
-          <p:cNvPr id="11" name="tag_364"/>
+          <p:cNvPr id="11" name="tag_365"/>
           <p:cNvSpPr/>
           <p:nvPr/>
         </p:nvSpPr>
@@ -12412,7 +12412,7 @@
       </p:sp>
       <p:pic>
         <p:nvPicPr>
-          <p:cNvPr id="12" name="logo_365" descr="/home/claude/lls-course/v2/img/logo.png">    </p:cNvPr>
+          <p:cNvPr id="12" name="logo_366" descr="/home/claude/lls-course/v2/img/logo.png">    </p:cNvPr>
           <p:cNvPicPr>
             <a:picLocks noChangeAspect="1"/>
           </p:cNvPicPr>
@@ -12436,7 +12436,7 @@
       </p:pic>
       <p:sp>
         <p:nvSpPr>
-          <p:cNvPr id="13" name="foot_366"/>
+          <p:cNvPr id="13" name="foot_367"/>
           <p:cNvSpPr/>
           <p:nvPr/>
         </p:nvSpPr>
@@ -12475,7 +12475,7 @@
       </p:sp>
       <p:sp>
         <p:nvSpPr>
-          <p:cNvPr id="14" name="pf_367"/>
+          <p:cNvPr id="14" name="pf_368"/>
           <p:cNvSpPr/>
           <p:nvPr/>
         </p:nvSpPr>
@@ -12509,7 +12509,7 @@
       </p:sp>
       <p:pic>
         <p:nvPicPr>
-          <p:cNvPr id="15" name="ph_368" descr="/home/claude/lls-course/v2/cache/b2_6b2_giulia_jpg_268x286_31.png">    </p:cNvPr>
+          <p:cNvPr id="15" name="ph_369" descr="/home/claude/lls-course/v2/cache/b2_6b2_giulia_jpg_268x286_31.png">    </p:cNvPr>
           <p:cNvPicPr>
             <a:picLocks noChangeAspect="1"/>
           </p:cNvPicPr>
@@ -12533,7 +12533,7 @@
       </p:pic>
       <p:sp>
         <p:nvSpPr>
-          <p:cNvPr id="16" name="cd_369"/>
+          <p:cNvPr id="16" name="cd_370"/>
           <p:cNvSpPr/>
           <p:nvPr/>
         </p:nvSpPr>
@@ -12567,7 +12567,7 @@
       </p:sp>
       <p:sp>
         <p:nvSpPr>
-          <p:cNvPr id="17" name="ii_370"/>
+          <p:cNvPr id="17" name="ii_371"/>
           <p:cNvSpPr/>
           <p:nvPr/>
         </p:nvSpPr>
@@ -12603,7 +12603,7 @@
       </p:sp>
       <p:sp>
         <p:nvSpPr>
-          <p:cNvPr id="18" name="ih_371"/>
+          <p:cNvPr id="18" name="ih_372"/>
           <p:cNvSpPr/>
           <p:nvPr/>
         </p:nvSpPr>
@@ -12642,7 +12642,7 @@
       </p:sp>
       <p:sp>
         <p:nvSpPr>
-          <p:cNvPr id="19" name="il_372"/>
+          <p:cNvPr id="19" name="il_373"/>
           <p:cNvSpPr/>
           <p:nvPr/>
         </p:nvSpPr>
@@ -12778,7 +12778,7 @@
       </p:sp>
       <p:sp>
         <p:nvSpPr>
-          <p:cNvPr id="20" name="R1_sb373"/>
+          <p:cNvPr id="20" name="R1_sb374"/>
           <p:cNvSpPr/>
           <p:nvPr/>
         </p:nvSpPr>
@@ -12830,7 +12830,7 @@
       </p:sp>
       <p:sp>
         <p:nvSpPr>
-          <p:cNvPr id="21" name="R1_sl374"/>
+          <p:cNvPr id="21" name="R1_sl375"/>
           <p:cNvSpPr/>
           <p:nvPr/>
         </p:nvSpPr>
@@ -12963,7 +12963,7 @@
       </p:sp>
       <p:sp>
         <p:nvSpPr>
-          <p:cNvPr id="22" name="R2_sb375"/>
+          <p:cNvPr id="22" name="R2_sb376"/>
           <p:cNvSpPr/>
           <p:nvPr/>
         </p:nvSpPr>
@@ -13015,7 +13015,7 @@
       </p:sp>
       <p:sp>
         <p:nvSpPr>
-          <p:cNvPr id="23" name="R2_sl376"/>
+          <p:cNvPr id="23" name="R2_sl377"/>
           <p:cNvSpPr/>
           <p:nvPr/>
         </p:nvSpPr>
@@ -13179,7 +13179,7 @@
       </p:sp>
       <p:sp>
         <p:nvSpPr>
-          <p:cNvPr id="24" name="R3_sb377"/>
+          <p:cNvPr id="24" name="R3_sb378"/>
           <p:cNvSpPr/>
           <p:nvPr/>
         </p:nvSpPr>
@@ -13231,7 +13231,7 @@
       </p:sp>
       <p:sp>
         <p:nvSpPr>
-          <p:cNvPr id="25" name="R3_sl378"/>
+          <p:cNvPr id="25" name="R3_sl379"/>
           <p:cNvSpPr/>
           <p:nvPr/>
         </p:nvSpPr>
@@ -13364,7 +13364,7 @@
       </p:sp>
       <p:sp>
         <p:nvSpPr>
-          <p:cNvPr id="26" name="R4_sb379"/>
+          <p:cNvPr id="26" name="R4_sb380"/>
           <p:cNvSpPr/>
           <p:nvPr/>
         </p:nvSpPr>
@@ -13416,7 +13416,7 @@
       </p:sp>
       <p:sp>
         <p:nvSpPr>
-          <p:cNvPr id="27" name="R4_sl380"/>
+          <p:cNvPr id="27" name="R4_sl381"/>
           <p:cNvSpPr/>
           <p:nvPr/>
         </p:nvSpPr>
@@ -13549,7 +13549,7 @@
       </p:sp>
       <p:sp>
         <p:nvSpPr>
-          <p:cNvPr id="28" name="R5_sb381"/>
+          <p:cNvPr id="28" name="R5_sb382"/>
           <p:cNvSpPr/>
           <p:nvPr/>
         </p:nvSpPr>
@@ -13601,7 +13601,7 @@
       </p:sp>
       <p:sp>
         <p:nvSpPr>
-          <p:cNvPr id="29" name="R5_sl382"/>
+          <p:cNvPr id="29" name="R5_sl383"/>
           <p:cNvSpPr/>
           <p:nvPr/>
         </p:nvSpPr>
@@ -13703,7 +13703,7 @@
       </p:sp>
       <p:sp>
         <p:nvSpPr>
-          <p:cNvPr id="30" name="R6_sb383"/>
+          <p:cNvPr id="30" name="R6_sb384"/>
           <p:cNvSpPr/>
           <p:nvPr/>
         </p:nvSpPr>
@@ -13755,7 +13755,7 @@
       </p:sp>
       <p:sp>
         <p:nvSpPr>
-          <p:cNvPr id="31" name="R6_sl384"/>
+          <p:cNvPr id="31" name="R6_sl385"/>
           <p:cNvSpPr/>
           <p:nvPr/>
         </p:nvSpPr>
@@ -14457,7 +14457,7 @@
       </p:grpSpPr>
       <p:sp>
         <p:nvSpPr>
-          <p:cNvPr id="3" name="bd_385"/>
+          <p:cNvPr id="3" name="bd_386"/>
           <p:cNvSpPr/>
           <p:nvPr/>
         </p:nvSpPr>
@@ -14509,7 +14509,7 @@
       </p:sp>
       <p:pic>
         <p:nvPicPr>
-          <p:cNvPr id="4" name="brY_386" descr="/home/claude/lls-course/v2/assets/brush-yellow.png">    </p:cNvPr>
+          <p:cNvPr id="4" name="brY_387" descr="/home/claude/lls-course/v2/assets/brush-yellow.png">    </p:cNvPr>
           <p:cNvPicPr>
             <a:picLocks noChangeAspect="1"/>
           </p:cNvPicPr>
@@ -14533,7 +14533,7 @@
       </p:pic>
       <p:sp>
         <p:nvSpPr>
-          <p:cNvPr id="5" name="title_387"/>
+          <p:cNvPr id="5" name="title_388"/>
           <p:cNvSpPr/>
           <p:nvPr/>
         </p:nvSpPr>
@@ -14574,7 +14574,7 @@
       </p:sp>
       <p:pic>
         <p:nvPicPr>
-          <p:cNvPr id="6" name="brP_388" descr="/home/claude/lls-course/v2/assets/brush-pink.png">    </p:cNvPr>
+          <p:cNvPr id="6" name="brP_389" descr="/home/claude/lls-course/v2/assets/brush-pink.png">    </p:cNvPr>
           <p:cNvPicPr>
             <a:picLocks noChangeAspect="1"/>
           </p:cNvPicPr>
@@ -14598,7 +14598,7 @@
       </p:pic>
       <p:sp>
         <p:nvSpPr>
-          <p:cNvPr id="7" name="ins_389"/>
+          <p:cNvPr id="7" name="ins_390"/>
           <p:cNvSpPr/>
           <p:nvPr/>
         </p:nvSpPr>
@@ -14639,7 +14639,7 @@
       </p:sp>
       <p:sp>
         <p:nvSpPr>
-          <p:cNvPr id="8" name="insIT_390"/>
+          <p:cNvPr id="8" name="insIT_391"/>
           <p:cNvSpPr/>
           <p:nvPr/>
         </p:nvSpPr>
@@ -14680,7 +14680,7 @@
       </p:sp>
       <p:sp>
         <p:nvSpPr>
-          <p:cNvPr id="9" name="cmd_391"/>
+          <p:cNvPr id="9" name="cmd_392"/>
           <p:cNvSpPr/>
           <p:nvPr/>
         </p:nvSpPr>
@@ -14761,7 +14761,7 @@
       </p:sp>
       <p:sp>
         <p:nvSpPr>
-          <p:cNvPr id="10" name="meta_392"/>
+          <p:cNvPr id="10" name="meta_393"/>
           <p:cNvSpPr/>
           <p:nvPr/>
         </p:nvSpPr>
@@ -14810,7 +14810,7 @@
       </p:sp>
       <p:sp>
         <p:nvSpPr>
-          <p:cNvPr id="11" name="tag_393"/>
+          <p:cNvPr id="11" name="tag_394"/>
           <p:cNvSpPr/>
           <p:nvPr/>
         </p:nvSpPr>
@@ -14873,7 +14873,7 @@
       </p:sp>
       <p:pic>
         <p:nvPicPr>
-          <p:cNvPr id="12" name="logo_394" descr="/home/claude/lls-course/v2/img/logo.png">    </p:cNvPr>
+          <p:cNvPr id="12" name="logo_395" descr="/home/claude/lls-course/v2/img/logo.png">    </p:cNvPr>
           <p:cNvPicPr>
             <a:picLocks noChangeAspect="1"/>
           </p:cNvPicPr>
@@ -14897,7 +14897,7 @@
       </p:pic>
       <p:sp>
         <p:nvSpPr>
-          <p:cNvPr id="13" name="foot_395"/>
+          <p:cNvPr id="13" name="foot_396"/>
           <p:cNvSpPr/>
           <p:nvPr/>
         </p:nvSpPr>
@@ -14936,7 +14936,7 @@
       </p:sp>
       <p:sp>
         <p:nvSpPr>
-          <p:cNvPr id="14" name="R1_sb396"/>
+          <p:cNvPr id="14" name="R1_sb397"/>
           <p:cNvSpPr/>
           <p:nvPr/>
         </p:nvSpPr>
@@ -14988,7 +14988,7 @@
       </p:sp>
       <p:sp>
         <p:nvSpPr>
-          <p:cNvPr id="15" name="R1_sl397"/>
+          <p:cNvPr id="15" name="R1_sl398"/>
           <p:cNvSpPr/>
           <p:nvPr/>
         </p:nvSpPr>
@@ -15042,7 +15042,7 @@
       </p:sp>
       <p:sp>
         <p:nvSpPr>
-          <p:cNvPr id="16" name="R2_sb398"/>
+          <p:cNvPr id="16" name="R2_sb399"/>
           <p:cNvSpPr/>
           <p:nvPr/>
         </p:nvSpPr>
@@ -15094,7 +15094,7 @@
       </p:sp>
       <p:sp>
         <p:nvSpPr>
-          <p:cNvPr id="17" name="R2_sl399"/>
+          <p:cNvPr id="17" name="R2_sl400"/>
           <p:cNvSpPr/>
           <p:nvPr/>
         </p:nvSpPr>
@@ -15148,7 +15148,7 @@
       </p:sp>
       <p:sp>
         <p:nvSpPr>
-          <p:cNvPr id="18" name="R3_sb400"/>
+          <p:cNvPr id="18" name="R3_sb401"/>
           <p:cNvSpPr/>
           <p:nvPr/>
         </p:nvSpPr>
@@ -15200,7 +15200,7 @@
       </p:sp>
       <p:sp>
         <p:nvSpPr>
-          <p:cNvPr id="19" name="R3_sl401"/>
+          <p:cNvPr id="19" name="R3_sl402"/>
           <p:cNvSpPr/>
           <p:nvPr/>
         </p:nvSpPr>
@@ -15254,7 +15254,7 @@
       </p:sp>
       <p:sp>
         <p:nvSpPr>
-          <p:cNvPr id="20" name="R4_sb402"/>
+          <p:cNvPr id="20" name="R4_sb403"/>
           <p:cNvSpPr/>
           <p:nvPr/>
         </p:nvSpPr>
@@ -15306,7 +15306,7 @@
       </p:sp>
       <p:sp>
         <p:nvSpPr>
-          <p:cNvPr id="21" name="R4_sl403"/>
+          <p:cNvPr id="21" name="R4_sl404"/>
           <p:cNvSpPr/>
           <p:nvPr/>
         </p:nvSpPr>
@@ -15360,7 +15360,7 @@
       </p:sp>
       <p:sp>
         <p:nvSpPr>
-          <p:cNvPr id="22" name="R5_sb404"/>
+          <p:cNvPr id="22" name="R5_sb405"/>
           <p:cNvSpPr/>
           <p:nvPr/>
         </p:nvSpPr>
@@ -15412,7 +15412,7 @@
       </p:sp>
       <p:sp>
         <p:nvSpPr>
-          <p:cNvPr id="23" name="R5_sl405"/>
+          <p:cNvPr id="23" name="R5_sl406"/>
           <p:cNvSpPr/>
           <p:nvPr/>
         </p:nvSpPr>
@@ -15466,7 +15466,7 @@
       </p:sp>
       <p:sp>
         <p:nvSpPr>
-          <p:cNvPr id="24" name="R6_sb406"/>
+          <p:cNvPr id="24" name="R6_sb407"/>
           <p:cNvSpPr/>
           <p:nvPr/>
         </p:nvSpPr>
@@ -15518,7 +15518,7 @@
       </p:sp>
       <p:sp>
         <p:nvSpPr>
-          <p:cNvPr id="25" name="R6_sl407"/>
+          <p:cNvPr id="25" name="R6_sl408"/>
           <p:cNvSpPr/>
           <p:nvPr/>
         </p:nvSpPr>
@@ -16172,7 +16172,7 @@
       </p:grpSpPr>
       <p:sp>
         <p:nvSpPr>
-          <p:cNvPr id="3" name="bd_408"/>
+          <p:cNvPr id="3" name="bd_409"/>
           <p:cNvSpPr/>
           <p:nvPr/>
         </p:nvSpPr>
@@ -16224,7 +16224,7 @@
       </p:sp>
       <p:pic>
         <p:nvPicPr>
-          <p:cNvPr id="4" name="brY_409" descr="/home/claude/lls-course/v2/assets/brush-yellow.png">    </p:cNvPr>
+          <p:cNvPr id="4" name="brY_410" descr="/home/claude/lls-course/v2/assets/brush-yellow.png">    </p:cNvPr>
           <p:cNvPicPr>
             <a:picLocks noChangeAspect="1"/>
           </p:cNvPicPr>
@@ -16248,7 +16248,7 @@
       </p:pic>
       <p:sp>
         <p:nvSpPr>
-          <p:cNvPr id="5" name="title_410"/>
+          <p:cNvPr id="5" name="title_411"/>
           <p:cNvSpPr/>
           <p:nvPr/>
         </p:nvSpPr>
@@ -16289,7 +16289,7 @@
       </p:sp>
       <p:pic>
         <p:nvPicPr>
-          <p:cNvPr id="6" name="brP_411" descr="/home/claude/lls-course/v2/assets/brush-pink.png">    </p:cNvPr>
+          <p:cNvPr id="6" name="brP_412" descr="/home/claude/lls-course/v2/assets/brush-pink.png">    </p:cNvPr>
           <p:cNvPicPr>
             <a:picLocks noChangeAspect="1"/>
           </p:cNvPicPr>
@@ -16313,7 +16313,7 @@
       </p:pic>
       <p:sp>
         <p:nvSpPr>
-          <p:cNvPr id="7" name="ins_412"/>
+          <p:cNvPr id="7" name="ins_413"/>
           <p:cNvSpPr/>
           <p:nvPr/>
         </p:nvSpPr>
@@ -16354,7 +16354,7 @@
       </p:sp>
       <p:sp>
         <p:nvSpPr>
-          <p:cNvPr id="8" name="insIT_413"/>
+          <p:cNvPr id="8" name="insIT_414"/>
           <p:cNvSpPr/>
           <p:nvPr/>
         </p:nvSpPr>
@@ -16395,7 +16395,7 @@
       </p:sp>
       <p:sp>
         <p:nvSpPr>
-          <p:cNvPr id="9" name="cmd_414"/>
+          <p:cNvPr id="9" name="cmd_415"/>
           <p:cNvSpPr/>
           <p:nvPr/>
         </p:nvSpPr>
@@ -16476,7 +16476,7 @@
       </p:sp>
       <p:sp>
         <p:nvSpPr>
-          <p:cNvPr id="10" name="meta_415"/>
+          <p:cNvPr id="10" name="meta_416"/>
           <p:cNvSpPr/>
           <p:nvPr/>
         </p:nvSpPr>
@@ -16525,7 +16525,7 @@
       </p:sp>
       <p:sp>
         <p:nvSpPr>
-          <p:cNvPr id="11" name="tag_416"/>
+          <p:cNvPr id="11" name="tag_417"/>
           <p:cNvSpPr/>
           <p:nvPr/>
         </p:nvSpPr>
@@ -16588,7 +16588,7 @@
       </p:sp>
       <p:pic>
         <p:nvPicPr>
-          <p:cNvPr id="12" name="logo_417" descr="/home/claude/lls-course/v2/img/logo.png">    </p:cNvPr>
+          <p:cNvPr id="12" name="logo_418" descr="/home/claude/lls-course/v2/img/logo.png">    </p:cNvPr>
           <p:cNvPicPr>
             <a:picLocks noChangeAspect="1"/>
           </p:cNvPicPr>
@@ -16612,7 +16612,7 @@
       </p:pic>
       <p:sp>
         <p:nvSpPr>
-          <p:cNvPr id="13" name="foot_418"/>
+          <p:cNvPr id="13" name="foot_419"/>
           <p:cNvSpPr/>
           <p:nvPr/>
         </p:nvSpPr>
@@ -16651,7 +16651,7 @@
       </p:sp>
       <p:sp>
         <p:nvSpPr>
-          <p:cNvPr id="14" name="cd_419"/>
+          <p:cNvPr id="14" name="cd_420"/>
           <p:cNvSpPr/>
           <p:nvPr/>
         </p:nvSpPr>
@@ -16685,7 +16685,7 @@
       </p:sp>
       <p:sp>
         <p:nvSpPr>
-          <p:cNvPr id="15" name="ii_420"/>
+          <p:cNvPr id="15" name="ii_421"/>
           <p:cNvSpPr/>
           <p:nvPr/>
         </p:nvSpPr>
@@ -16721,7 +16721,7 @@
       </p:sp>
       <p:sp>
         <p:nvSpPr>
-          <p:cNvPr id="16" name="ih_421"/>
+          <p:cNvPr id="16" name="ih_422"/>
           <p:cNvSpPr/>
           <p:nvPr/>
         </p:nvSpPr>
@@ -16760,7 +16760,7 @@
       </p:sp>
       <p:sp>
         <p:nvSpPr>
-          <p:cNvPr id="17" name="il_422"/>
+          <p:cNvPr id="17" name="il_423"/>
           <p:cNvSpPr/>
           <p:nvPr/>
         </p:nvSpPr>
@@ -16877,7 +16877,7 @@
       </p:sp>
       <p:sp>
         <p:nvSpPr>
-          <p:cNvPr id="18" name="st_423"/>
+          <p:cNvPr id="18" name="st_424"/>
           <p:cNvSpPr/>
           <p:nvPr/>
         </p:nvSpPr>
@@ -16948,7 +16948,7 @@
       </p:sp>
       <p:sp>
         <p:nvSpPr>
-          <p:cNvPr id="19" name="bd_424"/>
+          <p:cNvPr id="19" name="bd_425"/>
           <p:cNvSpPr/>
           <p:nvPr/>
         </p:nvSpPr>
@@ -17000,7 +17000,7 @@
       </p:sp>
       <p:sp>
         <p:nvSpPr>
-          <p:cNvPr id="20" name="gq_425"/>
+          <p:cNvPr id="20" name="gq_426"/>
           <p:cNvSpPr/>
           <p:nvPr/>
         </p:nvSpPr>
@@ -17049,7 +17049,7 @@
       </p:sp>
       <p:sp>
         <p:nvSpPr>
-          <p:cNvPr id="21" name="chip_426"/>
+          <p:cNvPr id="21" name="chip_427"/>
           <p:cNvSpPr/>
           <p:nvPr/>
         </p:nvSpPr>
@@ -17098,7 +17098,7 @@
       </p:sp>
       <p:sp>
         <p:nvSpPr>
-          <p:cNvPr id="22" name="bd_427"/>
+          <p:cNvPr id="22" name="bd_428"/>
           <p:cNvSpPr/>
           <p:nvPr/>
         </p:nvSpPr>
@@ -17150,7 +17150,7 @@
       </p:sp>
       <p:sp>
         <p:nvSpPr>
-          <p:cNvPr id="23" name="gq_428"/>
+          <p:cNvPr id="23" name="gq_429"/>
           <p:cNvSpPr/>
           <p:nvPr/>
         </p:nvSpPr>
@@ -17199,7 +17199,7 @@
       </p:sp>
       <p:sp>
         <p:nvSpPr>
-          <p:cNvPr id="24" name="R1_chip429"/>
+          <p:cNvPr id="24" name="R1_chip430"/>
           <p:cNvSpPr/>
           <p:nvPr/>
         </p:nvSpPr>
@@ -17248,7 +17248,7 @@
       </p:sp>
       <p:sp>
         <p:nvSpPr>
-          <p:cNvPr id="25" name="bd_430"/>
+          <p:cNvPr id="25" name="bd_431"/>
           <p:cNvSpPr/>
           <p:nvPr/>
         </p:nvSpPr>
@@ -17300,7 +17300,7 @@
       </p:sp>
       <p:sp>
         <p:nvSpPr>
-          <p:cNvPr id="26" name="gq_431"/>
+          <p:cNvPr id="26" name="gq_432"/>
           <p:cNvSpPr/>
           <p:nvPr/>
         </p:nvSpPr>
@@ -17349,7 +17349,7 @@
       </p:sp>
       <p:sp>
         <p:nvSpPr>
-          <p:cNvPr id="27" name="R2_chip432"/>
+          <p:cNvPr id="27" name="R2_chip433"/>
           <p:cNvSpPr/>
           <p:nvPr/>
         </p:nvSpPr>
@@ -17398,7 +17398,7 @@
       </p:sp>
       <p:sp>
         <p:nvSpPr>
-          <p:cNvPr id="28" name="bd_433"/>
+          <p:cNvPr id="28" name="bd_434"/>
           <p:cNvSpPr/>
           <p:nvPr/>
         </p:nvSpPr>
@@ -17450,7 +17450,7 @@
       </p:sp>
       <p:sp>
         <p:nvSpPr>
-          <p:cNvPr id="29" name="gq_434"/>
+          <p:cNvPr id="29" name="gq_435"/>
           <p:cNvSpPr/>
           <p:nvPr/>
         </p:nvSpPr>
@@ -17499,7 +17499,7 @@
       </p:sp>
       <p:sp>
         <p:nvSpPr>
-          <p:cNvPr id="30" name="R3_chip435"/>
+          <p:cNvPr id="30" name="R3_chip436"/>
           <p:cNvSpPr/>
           <p:nvPr/>
         </p:nvSpPr>
@@ -17779,7 +17779,7 @@
       </p:grpSpPr>
       <p:sp>
         <p:nvSpPr>
-          <p:cNvPr id="3" name="bd_436"/>
+          <p:cNvPr id="3" name="bd_437"/>
           <p:cNvSpPr/>
           <p:nvPr/>
         </p:nvSpPr>
@@ -17831,7 +17831,7 @@
       </p:sp>
       <p:pic>
         <p:nvPicPr>
-          <p:cNvPr id="4" name="brY_437" descr="/home/claude/lls-course/v2/assets/brush-yellow.png">    </p:cNvPr>
+          <p:cNvPr id="4" name="brY_438" descr="/home/claude/lls-course/v2/assets/brush-yellow.png">    </p:cNvPr>
           <p:cNvPicPr>
             <a:picLocks noChangeAspect="1"/>
           </p:cNvPicPr>
@@ -17855,7 +17855,7 @@
       </p:pic>
       <p:sp>
         <p:nvSpPr>
-          <p:cNvPr id="5" name="title_438"/>
+          <p:cNvPr id="5" name="title_439"/>
           <p:cNvSpPr/>
           <p:nvPr/>
         </p:nvSpPr>
@@ -17896,7 +17896,7 @@
       </p:sp>
       <p:pic>
         <p:nvPicPr>
-          <p:cNvPr id="6" name="brP_439" descr="/home/claude/lls-course/v2/assets/brush-pink.png">    </p:cNvPr>
+          <p:cNvPr id="6" name="brP_440" descr="/home/claude/lls-course/v2/assets/brush-pink.png">    </p:cNvPr>
           <p:cNvPicPr>
             <a:picLocks noChangeAspect="1"/>
           </p:cNvPicPr>
@@ -17920,7 +17920,7 @@
       </p:pic>
       <p:sp>
         <p:nvSpPr>
-          <p:cNvPr id="7" name="ins_440"/>
+          <p:cNvPr id="7" name="ins_441"/>
           <p:cNvSpPr/>
           <p:nvPr/>
         </p:nvSpPr>
@@ -17961,7 +17961,7 @@
       </p:sp>
       <p:sp>
         <p:nvSpPr>
-          <p:cNvPr id="8" name="insIT_441"/>
+          <p:cNvPr id="8" name="insIT_442"/>
           <p:cNvSpPr/>
           <p:nvPr/>
         </p:nvSpPr>
@@ -18002,7 +18002,7 @@
       </p:sp>
       <p:sp>
         <p:nvSpPr>
-          <p:cNvPr id="9" name="meta_442"/>
+          <p:cNvPr id="9" name="meta_443"/>
           <p:cNvSpPr/>
           <p:nvPr/>
         </p:nvSpPr>
@@ -18051,7 +18051,7 @@
       </p:sp>
       <p:sp>
         <p:nvSpPr>
-          <p:cNvPr id="10" name="tag_443"/>
+          <p:cNvPr id="10" name="tag_444"/>
           <p:cNvSpPr/>
           <p:nvPr/>
         </p:nvSpPr>
@@ -18114,7 +18114,7 @@
       </p:sp>
       <p:pic>
         <p:nvPicPr>
-          <p:cNvPr id="11" name="logo_444" descr="/home/claude/lls-course/v2/img/logo.png">    </p:cNvPr>
+          <p:cNvPr id="11" name="logo_445" descr="/home/claude/lls-course/v2/img/logo.png">    </p:cNvPr>
           <p:cNvPicPr>
             <a:picLocks noChangeAspect="1"/>
           </p:cNvPicPr>
@@ -18138,7 +18138,7 @@
       </p:pic>
       <p:sp>
         <p:nvSpPr>
-          <p:cNvPr id="12" name="foot_445"/>
+          <p:cNvPr id="12" name="foot_446"/>
           <p:cNvSpPr/>
           <p:nvPr/>
         </p:nvSpPr>
@@ -18177,7 +18177,7 @@
       </p:sp>
       <p:sp>
         <p:nvSpPr>
-          <p:cNvPr id="13" name="bd_446"/>
+          <p:cNvPr id="13" name="bd_447"/>
           <p:cNvSpPr/>
           <p:nvPr/>
         </p:nvSpPr>
@@ -18229,7 +18229,7 @@
       </p:sp>
       <p:sp>
         <p:nvSpPr>
-          <p:cNvPr id="14" name="rt_447"/>
+          <p:cNvPr id="14" name="rt_448"/>
           <p:cNvSpPr/>
           <p:nvPr/>
         </p:nvSpPr>
@@ -18285,7 +18285,7 @@
       </p:sp>
       <p:sp>
         <p:nvSpPr>
-          <p:cNvPr id="15" name="bd_448"/>
+          <p:cNvPr id="15" name="bd_449"/>
           <p:cNvSpPr/>
           <p:nvPr/>
         </p:nvSpPr>
@@ -18337,7 +18337,7 @@
       </p:sp>
       <p:sp>
         <p:nvSpPr>
-          <p:cNvPr id="16" name="rt_449"/>
+          <p:cNvPr id="16" name="rt_450"/>
           <p:cNvSpPr/>
           <p:nvPr/>
         </p:nvSpPr>
@@ -18393,7 +18393,7 @@
       </p:sp>
       <p:sp>
         <p:nvSpPr>
-          <p:cNvPr id="17" name="bd_450"/>
+          <p:cNvPr id="17" name="bd_451"/>
           <p:cNvSpPr/>
           <p:nvPr/>
         </p:nvSpPr>
@@ -18445,7 +18445,7 @@
       </p:sp>
       <p:sp>
         <p:nvSpPr>
-          <p:cNvPr id="18" name="rt_451"/>
+          <p:cNvPr id="18" name="rt_452"/>
           <p:cNvSpPr/>
           <p:nvPr/>
         </p:nvSpPr>
@@ -18501,7 +18501,7 @@
       </p:sp>
       <p:sp>
         <p:nvSpPr>
-          <p:cNvPr id="19" name="cd_452"/>
+          <p:cNvPr id="19" name="cd_453"/>
           <p:cNvSpPr/>
           <p:nvPr/>
         </p:nvSpPr>
@@ -18535,7 +18535,7 @@
       </p:sp>
       <p:sp>
         <p:nvSpPr>
-          <p:cNvPr id="20" name="ii_453"/>
+          <p:cNvPr id="20" name="ii_454"/>
           <p:cNvSpPr/>
           <p:nvPr/>
         </p:nvSpPr>
@@ -18571,7 +18571,7 @@
       </p:sp>
       <p:sp>
         <p:nvSpPr>
-          <p:cNvPr id="21" name="ih_454"/>
+          <p:cNvPr id="21" name="ih_455"/>
           <p:cNvSpPr/>
           <p:nvPr/>
         </p:nvSpPr>
@@ -18610,7 +18610,7 @@
       </p:sp>
       <p:sp>
         <p:nvSpPr>
-          <p:cNvPr id="22" name="il_455"/>
+          <p:cNvPr id="22" name="il_456"/>
           <p:cNvSpPr/>
           <p:nvPr/>
         </p:nvSpPr>
@@ -18679,7 +18679,7 @@
       </p:sp>
       <p:sp>
         <p:nvSpPr>
-          <p:cNvPr id="23" name="st_456"/>
+          <p:cNvPr id="23" name="st_457"/>
           <p:cNvSpPr/>
           <p:nvPr/>
         </p:nvSpPr>
@@ -18775,7 +18775,7 @@
       </p:grpSpPr>
       <p:sp>
         <p:nvSpPr>
-          <p:cNvPr id="3" name="bd_457"/>
+          <p:cNvPr id="3" name="bd_458"/>
           <p:cNvSpPr/>
           <p:nvPr/>
         </p:nvSpPr>
@@ -18827,7 +18827,7 @@
       </p:sp>
       <p:pic>
         <p:nvPicPr>
-          <p:cNvPr id="4" name="brY_458" descr="/home/claude/lls-course/v2/assets/brush-yellow.png">    </p:cNvPr>
+          <p:cNvPr id="4" name="brY_459" descr="/home/claude/lls-course/v2/assets/brush-yellow.png">    </p:cNvPr>
           <p:cNvPicPr>
             <a:picLocks noChangeAspect="1"/>
           </p:cNvPicPr>
@@ -18851,7 +18851,7 @@
       </p:pic>
       <p:sp>
         <p:nvSpPr>
-          <p:cNvPr id="5" name="title_459"/>
+          <p:cNvPr id="5" name="title_460"/>
           <p:cNvSpPr/>
           <p:nvPr/>
         </p:nvSpPr>
@@ -18892,7 +18892,7 @@
       </p:sp>
       <p:pic>
         <p:nvPicPr>
-          <p:cNvPr id="6" name="brP_460" descr="/home/claude/lls-course/v2/assets/brush-pink.png">    </p:cNvPr>
+          <p:cNvPr id="6" name="brP_461" descr="/home/claude/lls-course/v2/assets/brush-pink.png">    </p:cNvPr>
           <p:cNvPicPr>
             <a:picLocks noChangeAspect="1"/>
           </p:cNvPicPr>
@@ -18916,7 +18916,7 @@
       </p:pic>
       <p:sp>
         <p:nvSpPr>
-          <p:cNvPr id="7" name="ins_461"/>
+          <p:cNvPr id="7" name="ins_462"/>
           <p:cNvSpPr/>
           <p:nvPr/>
         </p:nvSpPr>
@@ -18957,7 +18957,7 @@
       </p:sp>
       <p:sp>
         <p:nvSpPr>
-          <p:cNvPr id="8" name="insIT_462"/>
+          <p:cNvPr id="8" name="insIT_463"/>
           <p:cNvSpPr/>
           <p:nvPr/>
         </p:nvSpPr>
@@ -18998,7 +18998,7 @@
       </p:sp>
       <p:sp>
         <p:nvSpPr>
-          <p:cNvPr id="9" name="cmd_463"/>
+          <p:cNvPr id="9" name="cmd_464"/>
           <p:cNvSpPr/>
           <p:nvPr/>
         </p:nvSpPr>
@@ -19079,7 +19079,7 @@
       </p:sp>
       <p:sp>
         <p:nvSpPr>
-          <p:cNvPr id="10" name="meta_464"/>
+          <p:cNvPr id="10" name="meta_465"/>
           <p:cNvSpPr/>
           <p:nvPr/>
         </p:nvSpPr>
@@ -19128,7 +19128,7 @@
       </p:sp>
       <p:sp>
         <p:nvSpPr>
-          <p:cNvPr id="11" name="tag_465"/>
+          <p:cNvPr id="11" name="tag_466"/>
           <p:cNvSpPr/>
           <p:nvPr/>
         </p:nvSpPr>
@@ -19191,7 +19191,7 @@
       </p:sp>
       <p:pic>
         <p:nvPicPr>
-          <p:cNvPr id="12" name="logo_466" descr="/home/claude/lls-course/v2/img/logo.png">    </p:cNvPr>
+          <p:cNvPr id="12" name="logo_467" descr="/home/claude/lls-course/v2/img/logo.png">    </p:cNvPr>
           <p:cNvPicPr>
             <a:picLocks noChangeAspect="1"/>
           </p:cNvPicPr>
@@ -19215,7 +19215,7 @@
       </p:pic>
       <p:sp>
         <p:nvSpPr>
-          <p:cNvPr id="13" name="foot_467"/>
+          <p:cNvPr id="13" name="foot_468"/>
           <p:cNvSpPr/>
           <p:nvPr/>
         </p:nvSpPr>
@@ -19254,7 +19254,7 @@
       </p:sp>
       <p:sp>
         <p:nvSpPr>
-          <p:cNvPr id="14" name="cd_468"/>
+          <p:cNvPr id="14" name="cd_469"/>
           <p:cNvSpPr/>
           <p:nvPr/>
         </p:nvSpPr>
@@ -19288,7 +19288,7 @@
       </p:sp>
       <p:sp>
         <p:nvSpPr>
-          <p:cNvPr id="15" name="te_469"/>
+          <p:cNvPr id="15" name="te_470"/>
           <p:cNvSpPr/>
           <p:nvPr/>
         </p:nvSpPr>
@@ -19324,7 +19324,7 @@
       </p:sp>
       <p:sp>
         <p:nvSpPr>
-          <p:cNvPr id="16" name="tt_470"/>
+          <p:cNvPr id="16" name="tt_471"/>
           <p:cNvSpPr/>
           <p:nvPr/>
         </p:nvSpPr>
@@ -19365,7 +19365,7 @@
       </p:sp>
       <p:sp>
         <p:nvSpPr>
-          <p:cNvPr id="17" name="R1_tk471"/>
+          <p:cNvPr id="17" name="R1_tk472"/>
           <p:cNvSpPr/>
           <p:nvPr/>
         </p:nvSpPr>
@@ -19401,7 +19401,7 @@
       </p:sp>
       <p:sp>
         <p:nvSpPr>
-          <p:cNvPr id="18" name="cd_472"/>
+          <p:cNvPr id="18" name="cd_473"/>
           <p:cNvSpPr/>
           <p:nvPr/>
         </p:nvSpPr>
@@ -19435,7 +19435,7 @@
       </p:sp>
       <p:sp>
         <p:nvSpPr>
-          <p:cNvPr id="19" name="te_473"/>
+          <p:cNvPr id="19" name="te_474"/>
           <p:cNvSpPr/>
           <p:nvPr/>
         </p:nvSpPr>
@@ -19471,7 +19471,7 @@
       </p:sp>
       <p:sp>
         <p:nvSpPr>
-          <p:cNvPr id="20" name="tt_474"/>
+          <p:cNvPr id="20" name="tt_475"/>
           <p:cNvSpPr/>
           <p:nvPr/>
         </p:nvSpPr>
@@ -19512,7 +19512,7 @@
       </p:sp>
       <p:sp>
         <p:nvSpPr>
-          <p:cNvPr id="21" name="R2_tk475"/>
+          <p:cNvPr id="21" name="R2_tk476"/>
           <p:cNvSpPr/>
           <p:nvPr/>
         </p:nvSpPr>
@@ -19548,7 +19548,7 @@
       </p:sp>
       <p:sp>
         <p:nvSpPr>
-          <p:cNvPr id="22" name="cd_476"/>
+          <p:cNvPr id="22" name="cd_477"/>
           <p:cNvSpPr/>
           <p:nvPr/>
         </p:nvSpPr>
@@ -19582,7 +19582,7 @@
       </p:sp>
       <p:sp>
         <p:nvSpPr>
-          <p:cNvPr id="23" name="te_477"/>
+          <p:cNvPr id="23" name="te_478"/>
           <p:cNvSpPr/>
           <p:nvPr/>
         </p:nvSpPr>
@@ -19618,7 +19618,7 @@
       </p:sp>
       <p:sp>
         <p:nvSpPr>
-          <p:cNvPr id="24" name="tt_478"/>
+          <p:cNvPr id="24" name="tt_479"/>
           <p:cNvSpPr/>
           <p:nvPr/>
         </p:nvSpPr>
@@ -19659,7 +19659,7 @@
       </p:sp>
       <p:sp>
         <p:nvSpPr>
-          <p:cNvPr id="25" name="R3_tk479"/>
+          <p:cNvPr id="25" name="R3_tk480"/>
           <p:cNvSpPr/>
           <p:nvPr/>
         </p:nvSpPr>
@@ -19695,7 +19695,7 @@
       </p:sp>
       <p:sp>
         <p:nvSpPr>
-          <p:cNvPr id="26" name="cd_480"/>
+          <p:cNvPr id="26" name="cd_481"/>
           <p:cNvSpPr/>
           <p:nvPr/>
         </p:nvSpPr>
@@ -19729,7 +19729,7 @@
       </p:sp>
       <p:sp>
         <p:nvSpPr>
-          <p:cNvPr id="27" name="te_481"/>
+          <p:cNvPr id="27" name="te_482"/>
           <p:cNvSpPr/>
           <p:nvPr/>
         </p:nvSpPr>
@@ -19765,7 +19765,7 @@
       </p:sp>
       <p:sp>
         <p:nvSpPr>
-          <p:cNvPr id="28" name="tt_482"/>
+          <p:cNvPr id="28" name="tt_483"/>
           <p:cNvSpPr/>
           <p:nvPr/>
         </p:nvSpPr>
@@ -19806,7 +19806,7 @@
       </p:sp>
       <p:sp>
         <p:nvSpPr>
-          <p:cNvPr id="29" name="R4_tk483"/>
+          <p:cNvPr id="29" name="R4_tk484"/>
           <p:cNvSpPr/>
           <p:nvPr/>
         </p:nvSpPr>
@@ -19842,7 +19842,7 @@
       </p:sp>
       <p:sp>
         <p:nvSpPr>
-          <p:cNvPr id="30" name="cd_484"/>
+          <p:cNvPr id="30" name="cd_485"/>
           <p:cNvSpPr/>
           <p:nvPr/>
         </p:nvSpPr>
@@ -19876,7 +19876,7 @@
       </p:sp>
       <p:sp>
         <p:nvSpPr>
-          <p:cNvPr id="31" name="te_485"/>
+          <p:cNvPr id="31" name="te_486"/>
           <p:cNvSpPr/>
           <p:nvPr/>
         </p:nvSpPr>
@@ -19912,7 +19912,7 @@
       </p:sp>
       <p:sp>
         <p:nvSpPr>
-          <p:cNvPr id="32" name="tt_486"/>
+          <p:cNvPr id="32" name="tt_487"/>
           <p:cNvSpPr/>
           <p:nvPr/>
         </p:nvSpPr>
@@ -19953,7 +19953,7 @@
       </p:sp>
       <p:sp>
         <p:nvSpPr>
-          <p:cNvPr id="33" name="R5_tk487"/>
+          <p:cNvPr id="33" name="R5_tk488"/>
           <p:cNvSpPr/>
           <p:nvPr/>
         </p:nvSpPr>
@@ -19989,7 +19989,7 @@
       </p:sp>
       <p:sp>
         <p:nvSpPr>
-          <p:cNvPr id="34" name="st_488"/>
+          <p:cNvPr id="34" name="st_489"/>
           <p:cNvSpPr/>
           <p:nvPr/>
         </p:nvSpPr>
@@ -22403,7 +22403,7 @@
       </p:grpSpPr>
       <p:sp>
         <p:nvSpPr>
-          <p:cNvPr id="3" name="dv_489"/>
+          <p:cNvPr id="3" name="dv_490"/>
           <p:cNvSpPr/>
           <p:nvPr/>
         </p:nvSpPr>
@@ -22439,7 +22439,7 @@
       </p:sp>
       <p:sp>
         <p:nvSpPr>
-          <p:cNvPr id="4" name="dvt_490"/>
+          <p:cNvPr id="4" name="dvt_491"/>
           <p:cNvSpPr/>
           <p:nvPr/>
         </p:nvSpPr>
@@ -22478,7 +22478,7 @@
       </p:sp>
       <p:sp>
         <p:nvSpPr>
-          <p:cNvPr id="5" name="dvs_491"/>
+          <p:cNvPr id="5" name="dvs_492"/>
           <p:cNvSpPr/>
           <p:nvPr/>
         </p:nvSpPr>
@@ -22517,7 +22517,7 @@
       </p:sp>
       <p:pic>
         <p:nvPicPr>
-          <p:cNvPr id="6" name="logo_492" descr="/home/claude/lls-course/v2/img/logo.png">    </p:cNvPr>
+          <p:cNvPr id="6" name="logo_493" descr="/home/claude/lls-course/v2/img/logo.png">    </p:cNvPr>
           <p:cNvPicPr>
             <a:picLocks noChangeAspect="1"/>
           </p:cNvPicPr>
@@ -22583,7 +22583,7 @@
       </p:grpSpPr>
       <p:sp>
         <p:nvSpPr>
-          <p:cNvPr id="3" name="bd_493"/>
+          <p:cNvPr id="3" name="bd_494"/>
           <p:cNvSpPr/>
           <p:nvPr/>
         </p:nvSpPr>
@@ -22635,7 +22635,7 @@
       </p:sp>
       <p:pic>
         <p:nvPicPr>
-          <p:cNvPr id="4" name="brY_494" descr="/home/claude/lls-course/v2/assets/brush-yellow.png">    </p:cNvPr>
+          <p:cNvPr id="4" name="brY_495" descr="/home/claude/lls-course/v2/assets/brush-yellow.png">    </p:cNvPr>
           <p:cNvPicPr>
             <a:picLocks noChangeAspect="1"/>
           </p:cNvPicPr>
@@ -22659,7 +22659,7 @@
       </p:pic>
       <p:sp>
         <p:nvSpPr>
-          <p:cNvPr id="5" name="title_495"/>
+          <p:cNvPr id="5" name="title_496"/>
           <p:cNvSpPr/>
           <p:nvPr/>
         </p:nvSpPr>
@@ -22700,7 +22700,7 @@
       </p:sp>
       <p:pic>
         <p:nvPicPr>
-          <p:cNvPr id="6" name="brP_496" descr="/home/claude/lls-course/v2/assets/brush-pink.png">    </p:cNvPr>
+          <p:cNvPr id="6" name="brP_497" descr="/home/claude/lls-course/v2/assets/brush-pink.png">    </p:cNvPr>
           <p:cNvPicPr>
             <a:picLocks noChangeAspect="1"/>
           </p:cNvPicPr>
@@ -22724,7 +22724,7 @@
       </p:pic>
       <p:sp>
         <p:nvSpPr>
-          <p:cNvPr id="7" name="ins_497"/>
+          <p:cNvPr id="7" name="ins_498"/>
           <p:cNvSpPr/>
           <p:nvPr/>
         </p:nvSpPr>
@@ -22765,7 +22765,7 @@
       </p:sp>
       <p:sp>
         <p:nvSpPr>
-          <p:cNvPr id="8" name="insIT_498"/>
+          <p:cNvPr id="8" name="insIT_499"/>
           <p:cNvSpPr/>
           <p:nvPr/>
         </p:nvSpPr>
@@ -22806,7 +22806,7 @@
       </p:sp>
       <p:sp>
         <p:nvSpPr>
-          <p:cNvPr id="9" name="cmd_499"/>
+          <p:cNvPr id="9" name="cmd_500"/>
           <p:cNvSpPr/>
           <p:nvPr/>
         </p:nvSpPr>
@@ -22887,7 +22887,7 @@
       </p:sp>
       <p:sp>
         <p:nvSpPr>
-          <p:cNvPr id="10" name="meta_500"/>
+          <p:cNvPr id="10" name="meta_501"/>
           <p:cNvSpPr/>
           <p:nvPr/>
         </p:nvSpPr>
@@ -22936,7 +22936,7 @@
       </p:sp>
       <p:sp>
         <p:nvSpPr>
-          <p:cNvPr id="11" name="tag_501"/>
+          <p:cNvPr id="11" name="tag_502"/>
           <p:cNvSpPr/>
           <p:nvPr/>
         </p:nvSpPr>
@@ -22999,7 +22999,7 @@
       </p:sp>
       <p:pic>
         <p:nvPicPr>
-          <p:cNvPr id="12" name="logo_502" descr="/home/claude/lls-course/v2/img/logo.png">    </p:cNvPr>
+          <p:cNvPr id="12" name="logo_503" descr="/home/claude/lls-course/v2/img/logo.png">    </p:cNvPr>
           <p:cNvPicPr>
             <a:picLocks noChangeAspect="1"/>
           </p:cNvPicPr>
@@ -23023,7 +23023,7 @@
       </p:pic>
       <p:sp>
         <p:nvSpPr>
-          <p:cNvPr id="13" name="foot_503"/>
+          <p:cNvPr id="13" name="foot_504"/>
           <p:cNvSpPr/>
           <p:nvPr/>
         </p:nvSpPr>
@@ -23062,7 +23062,7 @@
       </p:sp>
       <p:sp>
         <p:nvSpPr>
-          <p:cNvPr id="14" name="ext_504"/>
+          <p:cNvPr id="14" name="ext_505"/>
           <p:cNvSpPr/>
           <p:nvPr/>
         </p:nvSpPr>
@@ -23109,7 +23109,7 @@
       </p:sp>
       <p:sp>
         <p:nvSpPr>
-          <p:cNvPr id="15" name="cd_505"/>
+          <p:cNvPr id="15" name="cd_506"/>
           <p:cNvSpPr/>
           <p:nvPr/>
         </p:nvSpPr>
@@ -23143,7 +23143,7 @@
       </p:sp>
       <p:sp>
         <p:nvSpPr>
-          <p:cNvPr id="16" name="ii_506"/>
+          <p:cNvPr id="16" name="ii_507"/>
           <p:cNvSpPr/>
           <p:nvPr/>
         </p:nvSpPr>
@@ -23179,7 +23179,7 @@
       </p:sp>
       <p:sp>
         <p:nvSpPr>
-          <p:cNvPr id="17" name="ih_507"/>
+          <p:cNvPr id="17" name="ih_508"/>
           <p:cNvSpPr/>
           <p:nvPr/>
         </p:nvSpPr>
@@ -23218,7 +23218,7 @@
       </p:sp>
       <p:sp>
         <p:nvSpPr>
-          <p:cNvPr id="18" name="il_508"/>
+          <p:cNvPr id="18" name="il_509"/>
           <p:cNvSpPr/>
           <p:nvPr/>
         </p:nvSpPr>
@@ -23335,7 +23335,7 @@
       </p:sp>
       <p:sp>
         <p:nvSpPr>
-          <p:cNvPr id="19" name="R1_qb509"/>
+          <p:cNvPr id="19" name="R1_qb510"/>
           <p:cNvSpPr/>
           <p:nvPr/>
         </p:nvSpPr>
@@ -23387,7 +23387,7 @@
       </p:sp>
       <p:sp>
         <p:nvSpPr>
-          <p:cNvPr id="20" name="R1_sq510"/>
+          <p:cNvPr id="20" name="R1_sq511"/>
           <p:cNvSpPr/>
           <p:nvPr/>
         </p:nvSpPr>
@@ -23460,7 +23460,7 @@
       </p:sp>
       <p:sp>
         <p:nvSpPr>
-          <p:cNvPr id="21" name="R2_qb511"/>
+          <p:cNvPr id="21" name="R2_qb512"/>
           <p:cNvSpPr/>
           <p:nvPr/>
         </p:nvSpPr>
@@ -23512,7 +23512,7 @@
       </p:sp>
       <p:sp>
         <p:nvSpPr>
-          <p:cNvPr id="22" name="R2_sq512"/>
+          <p:cNvPr id="22" name="R2_sq513"/>
           <p:cNvSpPr/>
           <p:nvPr/>
         </p:nvSpPr>
@@ -23585,7 +23585,7 @@
       </p:sp>
       <p:sp>
         <p:nvSpPr>
-          <p:cNvPr id="23" name="R3_qb513"/>
+          <p:cNvPr id="23" name="R3_qb514"/>
           <p:cNvSpPr/>
           <p:nvPr/>
         </p:nvSpPr>
@@ -23637,7 +23637,7 @@
       </p:sp>
       <p:sp>
         <p:nvSpPr>
-          <p:cNvPr id="24" name="R3_sq514"/>
+          <p:cNvPr id="24" name="R3_sq515"/>
           <p:cNvSpPr/>
           <p:nvPr/>
         </p:nvSpPr>
@@ -23710,7 +23710,7 @@
       </p:sp>
       <p:sp>
         <p:nvSpPr>
-          <p:cNvPr id="25" name="R4_qb515"/>
+          <p:cNvPr id="25" name="R4_qb516"/>
           <p:cNvSpPr/>
           <p:nvPr/>
         </p:nvSpPr>
@@ -23762,7 +23762,7 @@
       </p:sp>
       <p:sp>
         <p:nvSpPr>
-          <p:cNvPr id="26" name="R4_sq516"/>
+          <p:cNvPr id="26" name="R4_sq517"/>
           <p:cNvSpPr/>
           <p:nvPr/>
         </p:nvSpPr>
@@ -23835,7 +23835,7 @@
       </p:sp>
       <p:sp>
         <p:nvSpPr>
-          <p:cNvPr id="27" name="R5_qb517"/>
+          <p:cNvPr id="27" name="R5_qb518"/>
           <p:cNvSpPr/>
           <p:nvPr/>
         </p:nvSpPr>
@@ -23887,7 +23887,7 @@
       </p:sp>
       <p:sp>
         <p:nvSpPr>
-          <p:cNvPr id="28" name="R5_sq518"/>
+          <p:cNvPr id="28" name="R5_sq519"/>
           <p:cNvSpPr/>
           <p:nvPr/>
         </p:nvSpPr>
@@ -30871,7 +30871,472 @@
       </p:sp>
       <p:sp>
         <p:nvSpPr>
-          <p:cNvPr id="16" name="cd_155"/>
+          <p:cNvPr id="16" name="R1_rdE155"/>
+          <p:cNvSpPr/>
+          <p:nvPr/>
+        </p:nvSpPr>
+        <p:spPr>
+          <a:xfrm>
+            <a:off x="457200" y="1527048"/>
+            <a:ext cx="5486400" cy="3090672"/>
+          </a:xfrm>
+          <a:prstGeom prst="rect">
+            <a:avLst/>
+          </a:prstGeom>
+          <a:solidFill>
+            <a:srgbClr val="FFFFFF"/>
+          </a:solidFill>
+          <a:ln/>
+        </p:spPr>
+        <p:txBody>
+          <a:bodyPr wrap="square" lIns="0" tIns="0" rIns="0" bIns="0" rtlCol="0" anchor="t"/>
+          <a:lstStyle/>
+          <a:p>
+            <a:pPr indent="0" marL="0">
+              <a:lnSpc>
+                <a:spcPct val="105000"/>
+              </a:lnSpc>
+              <a:spcAft>
+                <a:spcPts val="400"/>
+              </a:spcAft>
+              <a:buNone/>
+            </a:pPr>
+            <a:r>
+              <a:rPr lang="en-US" sz="1500" b="1" dirty="0">
+                <a:solidFill>
+                  <a:srgbClr val="1F6F43"/>
+                </a:solidFill>
+                <a:latin typeface="Georgia" pitchFamily="34" charset="0"/>
+                <a:ea typeface="Georgia" pitchFamily="34" charset="-122"/>
+                <a:cs typeface="Georgia" pitchFamily="34" charset="-120"/>
+              </a:rPr>
+              <a:t>Music while you work?</a:t>
+            </a:r>
+            <a:endParaRPr lang="en-US" sz="1000" dirty="0"/>
+          </a:p>
+          <a:p>
+            <a:pPr indent="0" marL="0">
+              <a:lnSpc>
+                <a:spcPct val="105000"/>
+              </a:lnSpc>
+              <a:spcAft>
+                <a:spcPts val="700"/>
+              </a:spcAft>
+              <a:buNone/>
+            </a:pPr>
+            <a:r>
+              <a:rPr lang="en-US" sz="1000" dirty="0">
+                <a:solidFill>
+                  <a:srgbClr val="1B2559"/>
+                </a:solidFill>
+                <a:latin typeface="Georgia" pitchFamily="34" charset="0"/>
+                <a:ea typeface="Georgia" pitchFamily="34" charset="-122"/>
+                <a:cs typeface="Georgia" pitchFamily="34" charset="-120"/>
+              </a:rPr>
+              <a:t>Some prefer to work in silence. Others find playing their favourite tunes loudly helps them to be productive. Up till now, it has been a matter of personal preference. But recently, scientific research has uncovered that listening to music while you work</a:t>
+            </a:r>
+            <a:pPr indent="0" marL="0">
+              <a:lnSpc>
+                <a:spcPct val="105000"/>
+              </a:lnSpc>
+              <a:spcAft>
+                <a:spcPts val="700"/>
+              </a:spcAft>
+              <a:buNone/>
+            </a:pPr>
+            <a:r>
+              <a:rPr lang="en-US" sz="1000" b="1" dirty="0">
+                <a:solidFill>
+                  <a:srgbClr val="2EB872"/>
+                </a:solidFill>
+                <a:latin typeface="Georgia" pitchFamily="34" charset="0"/>
+                <a:ea typeface="Georgia" pitchFamily="34" charset="-122"/>
+                <a:cs typeface="Georgia" pitchFamily="34" charset="-120"/>
+              </a:rPr>
+              <a:t> (1) ________ </a:t>
+            </a:r>
+            <a:pPr indent="0" marL="0">
+              <a:lnSpc>
+                <a:spcPct val="105000"/>
+              </a:lnSpc>
+              <a:spcAft>
+                <a:spcPts val="700"/>
+              </a:spcAft>
+              <a:buNone/>
+            </a:pPr>
+            <a:r>
+              <a:rPr lang="en-US" sz="1000" dirty="0">
+                <a:solidFill>
+                  <a:srgbClr val="1B2559"/>
+                </a:solidFill>
+                <a:latin typeface="Georgia" pitchFamily="34" charset="0"/>
+                <a:ea typeface="Georgia" pitchFamily="34" charset="-122"/>
+                <a:cs typeface="Georgia" pitchFamily="34" charset="-120"/>
+              </a:rPr>
+              <a:t>– although, </a:t>
+            </a:r>
+            <a:pPr indent="0" marL="0">
+              <a:lnSpc>
+                <a:spcPct val="105000"/>
+              </a:lnSpc>
+              <a:spcAft>
+                <a:spcPts val="700"/>
+              </a:spcAft>
+              <a:buNone/>
+            </a:pPr>
+            <a:r>
+              <a:rPr lang="en-US" sz="1000" b="1" dirty="0">
+                <a:solidFill>
+                  <a:srgbClr val="1B2559"/>
+                </a:solidFill>
+                <a:highlight>
+                  <a:srgbClr val="FFE066"/>
+                </a:highlight>
+                <a:latin typeface="Georgia" pitchFamily="34" charset="0"/>
+                <a:ea typeface="Georgia" pitchFamily="34" charset="-122"/>
+                <a:cs typeface="Georgia" pitchFamily="34" charset="-120"/>
+              </a:rPr>
+              <a:t>it depends on</a:t>
+            </a:r>
+            <a:pPr indent="0" marL="0">
+              <a:lnSpc>
+                <a:spcPct val="105000"/>
+              </a:lnSpc>
+              <a:spcAft>
+                <a:spcPts val="700"/>
+              </a:spcAft>
+              <a:buNone/>
+            </a:pPr>
+            <a:r>
+              <a:rPr lang="en-US" sz="1000" b="1" dirty="0">
+                <a:solidFill>
+                  <a:srgbClr val="2EB872"/>
+                </a:solidFill>
+                <a:latin typeface="Georgia" pitchFamily="34" charset="0"/>
+                <a:ea typeface="Georgia" pitchFamily="34" charset="-122"/>
+                <a:cs typeface="Georgia" pitchFamily="34" charset="-120"/>
+              </a:rPr>
+              <a:t> (2) ________ </a:t>
+            </a:r>
+            <a:pPr indent="0" marL="0">
+              <a:lnSpc>
+                <a:spcPct val="105000"/>
+              </a:lnSpc>
+              <a:spcAft>
+                <a:spcPts val="700"/>
+              </a:spcAft>
+              <a:buNone/>
+            </a:pPr>
+            <a:r>
+              <a:rPr lang="en-US" sz="1000" dirty="0">
+                <a:solidFill>
+                  <a:srgbClr val="1B2559"/>
+                </a:solidFill>
+                <a:latin typeface="Georgia" pitchFamily="34" charset="0"/>
+                <a:ea typeface="Georgia" pitchFamily="34" charset="-122"/>
+                <a:cs typeface="Georgia" pitchFamily="34" charset="-120"/>
+              </a:rPr>
+              <a:t>.</a:t>
+            </a:r>
+            <a:endParaRPr lang="en-US" sz="1000" dirty="0"/>
+          </a:p>
+          <a:p>
+            <a:pPr indent="0" marL="0">
+              <a:lnSpc>
+                <a:spcPct val="105000"/>
+              </a:lnSpc>
+              <a:spcAft>
+                <a:spcPts val="700"/>
+              </a:spcAft>
+              <a:buNone/>
+            </a:pPr>
+            <a:r>
+              <a:rPr lang="en-US" sz="1000" dirty="0">
+                <a:solidFill>
+                  <a:srgbClr val="1B2559"/>
+                </a:solidFill>
+                <a:latin typeface="Georgia" pitchFamily="34" charset="0"/>
+                <a:ea typeface="Georgia" pitchFamily="34" charset="-122"/>
+                <a:cs typeface="Georgia" pitchFamily="34" charset="-120"/>
+              </a:rPr>
+              <a:t>A study by Simone Ritter, at Radboud University in the Netherlands, and Sam Ferguson, at the University of Technology in Sydney, Australia, looked at how</a:t>
+            </a:r>
+            <a:pPr indent="0" marL="0">
+              <a:lnSpc>
+                <a:spcPct val="105000"/>
+              </a:lnSpc>
+              <a:spcAft>
+                <a:spcPts val="700"/>
+              </a:spcAft>
+              <a:buNone/>
+            </a:pPr>
+            <a:r>
+              <a:rPr lang="en-US" sz="1000" b="1" dirty="0">
+                <a:solidFill>
+                  <a:srgbClr val="2EB872"/>
+                </a:solidFill>
+                <a:latin typeface="Georgia" pitchFamily="34" charset="0"/>
+                <a:ea typeface="Georgia" pitchFamily="34" charset="-122"/>
+                <a:cs typeface="Georgia" pitchFamily="34" charset="-120"/>
+              </a:rPr>
+              <a:t> (3) ________ </a:t>
+            </a:r>
+            <a:pPr indent="0" marL="0">
+              <a:lnSpc>
+                <a:spcPct val="105000"/>
+              </a:lnSpc>
+              <a:spcAft>
+                <a:spcPts val="700"/>
+              </a:spcAft>
+              <a:buNone/>
+            </a:pPr>
+            <a:r>
+              <a:rPr lang="en-US" sz="1000" dirty="0">
+                <a:solidFill>
+                  <a:srgbClr val="1B2559"/>
+                </a:solidFill>
+                <a:latin typeface="Georgia" pitchFamily="34" charset="0"/>
+                <a:ea typeface="Georgia" pitchFamily="34" charset="-122"/>
+                <a:cs typeface="Georgia" pitchFamily="34" charset="-120"/>
+              </a:rPr>
+              <a:t>compared to working in silence. In their study, Ritter and Ferguson divided 155 volunteers into five groups, which were then given tasks to complete. Four of the groups did so while</a:t>
+            </a:r>
+            <a:pPr indent="0" marL="0">
+              <a:lnSpc>
+                <a:spcPct val="105000"/>
+              </a:lnSpc>
+              <a:spcAft>
+                <a:spcPts val="700"/>
+              </a:spcAft>
+              <a:buNone/>
+            </a:pPr>
+            <a:r>
+              <a:rPr lang="en-US" sz="1000" b="1" dirty="0">
+                <a:solidFill>
+                  <a:srgbClr val="2EB872"/>
+                </a:solidFill>
+                <a:latin typeface="Georgia" pitchFamily="34" charset="0"/>
+                <a:ea typeface="Georgia" pitchFamily="34" charset="-122"/>
+                <a:cs typeface="Georgia" pitchFamily="34" charset="-120"/>
+              </a:rPr>
+              <a:t> (4) ________ </a:t>
+            </a:r>
+            <a:pPr indent="0" marL="0">
+              <a:lnSpc>
+                <a:spcPct val="105000"/>
+              </a:lnSpc>
+              <a:spcAft>
+                <a:spcPts val="700"/>
+              </a:spcAft>
+              <a:buNone/>
+            </a:pPr>
+            <a:r>
+              <a:rPr lang="en-US" sz="1000" dirty="0">
+                <a:solidFill>
+                  <a:srgbClr val="1B2559"/>
+                </a:solidFill>
+                <a:latin typeface="Georgia" pitchFamily="34" charset="0"/>
+                <a:ea typeface="Georgia" pitchFamily="34" charset="-122"/>
+                <a:cs typeface="Georgia" pitchFamily="34" charset="-120"/>
+              </a:rPr>
+              <a:t>, such as Holst's Mars and Vivaldi's Spring. The fifth group worked in silence.</a:t>
+            </a:r>
+            <a:endParaRPr lang="en-US" sz="1000" dirty="0"/>
+          </a:p>
+          <a:p>
+            <a:pPr indent="0" marL="0">
+              <a:lnSpc>
+                <a:spcPct val="105000"/>
+              </a:lnSpc>
+              <a:spcAft>
+                <a:spcPts val="700"/>
+              </a:spcAft>
+              <a:buNone/>
+            </a:pPr>
+            <a:r>
+              <a:rPr lang="en-US" sz="1000" dirty="0">
+                <a:solidFill>
+                  <a:srgbClr val="1B2559"/>
+                </a:solidFill>
+                <a:latin typeface="Georgia" pitchFamily="34" charset="0"/>
+                <a:ea typeface="Georgia" pitchFamily="34" charset="-122"/>
+                <a:cs typeface="Georgia" pitchFamily="34" charset="-120"/>
+              </a:rPr>
+              <a:t>Their study found that </a:t>
+            </a:r>
+            <a:pPr indent="0" marL="0">
+              <a:lnSpc>
+                <a:spcPct val="105000"/>
+              </a:lnSpc>
+              <a:spcAft>
+                <a:spcPts val="700"/>
+              </a:spcAft>
+              <a:buNone/>
+            </a:pPr>
+            <a:r>
+              <a:rPr lang="en-US" sz="1000" b="1" dirty="0">
+                <a:solidFill>
+                  <a:srgbClr val="1B2559"/>
+                </a:solidFill>
+                <a:highlight>
+                  <a:srgbClr val="FFE066"/>
+                </a:highlight>
+                <a:latin typeface="Georgia" pitchFamily="34" charset="0"/>
+                <a:ea typeface="Georgia" pitchFamily="34" charset="-122"/>
+                <a:cs typeface="Georgia" pitchFamily="34" charset="-120"/>
+              </a:rPr>
+              <a:t>happy music improved 'divergent thinking'</a:t>
+            </a:r>
+            <a:pPr indent="0" marL="0">
+              <a:lnSpc>
+                <a:spcPct val="105000"/>
+              </a:lnSpc>
+              <a:spcAft>
+                <a:spcPts val="700"/>
+              </a:spcAft>
+              <a:buNone/>
+            </a:pPr>
+            <a:r>
+              <a:rPr lang="en-US" sz="1000" dirty="0">
+                <a:solidFill>
+                  <a:srgbClr val="1B2559"/>
+                </a:solidFill>
+                <a:latin typeface="Georgia" pitchFamily="34" charset="0"/>
+                <a:ea typeface="Georgia" pitchFamily="34" charset="-122"/>
+                <a:cs typeface="Georgia" pitchFamily="34" charset="-120"/>
+              </a:rPr>
+              <a:t>, which is all about creativity. However, they found that </a:t>
+            </a:r>
+            <a:pPr indent="0" marL="0">
+              <a:lnSpc>
+                <a:spcPct val="105000"/>
+              </a:lnSpc>
+              <a:spcAft>
+                <a:spcPts val="700"/>
+              </a:spcAft>
+              <a:buNone/>
+            </a:pPr>
+            <a:r>
+              <a:rPr lang="en-US" sz="1000" b="1" dirty="0">
+                <a:solidFill>
+                  <a:srgbClr val="1B2559"/>
+                </a:solidFill>
+                <a:highlight>
+                  <a:srgbClr val="FFE066"/>
+                </a:highlight>
+                <a:latin typeface="Georgia" pitchFamily="34" charset="0"/>
+                <a:ea typeface="Georgia" pitchFamily="34" charset="-122"/>
+                <a:cs typeface="Georgia" pitchFamily="34" charset="-120"/>
+              </a:rPr>
+              <a:t>it had no impact on 'convergent thinking'</a:t>
+            </a:r>
+            <a:pPr indent="0" marL="0">
+              <a:lnSpc>
+                <a:spcPct val="105000"/>
+              </a:lnSpc>
+              <a:spcAft>
+                <a:spcPts val="700"/>
+              </a:spcAft>
+              <a:buNone/>
+            </a:pPr>
+            <a:r>
+              <a:rPr lang="en-US" sz="1000" dirty="0">
+                <a:solidFill>
+                  <a:srgbClr val="1B2559"/>
+                </a:solidFill>
+                <a:latin typeface="Georgia" pitchFamily="34" charset="0"/>
+                <a:ea typeface="Georgia" pitchFamily="34" charset="-122"/>
+                <a:cs typeface="Georgia" pitchFamily="34" charset="-120"/>
+              </a:rPr>
+              <a:t>, which is all about problem solving. So, if you need to be creative with your work, then you should</a:t>
+            </a:r>
+            <a:pPr indent="0" marL="0">
+              <a:lnSpc>
+                <a:spcPct val="105000"/>
+              </a:lnSpc>
+              <a:spcAft>
+                <a:spcPts val="700"/>
+              </a:spcAft>
+              <a:buNone/>
+            </a:pPr>
+            <a:r>
+              <a:rPr lang="en-US" sz="1000" b="1" dirty="0">
+                <a:solidFill>
+                  <a:srgbClr val="2EB872"/>
+                </a:solidFill>
+                <a:latin typeface="Georgia" pitchFamily="34" charset="0"/>
+                <a:ea typeface="Georgia" pitchFamily="34" charset="-122"/>
+                <a:cs typeface="Georgia" pitchFamily="34" charset="-120"/>
+              </a:rPr>
+              <a:t> (5) ________ </a:t>
+            </a:r>
+            <a:pPr indent="0" marL="0">
+              <a:lnSpc>
+                <a:spcPct val="105000"/>
+              </a:lnSpc>
+              <a:spcAft>
+                <a:spcPts val="700"/>
+              </a:spcAft>
+              <a:buNone/>
+            </a:pPr>
+            <a:r>
+              <a:rPr lang="en-US" sz="1000" dirty="0">
+                <a:solidFill>
+                  <a:srgbClr val="1B2559"/>
+                </a:solidFill>
+                <a:latin typeface="Georgia" pitchFamily="34" charset="0"/>
+                <a:ea typeface="Georgia" pitchFamily="34" charset="-122"/>
+                <a:cs typeface="Georgia" pitchFamily="34" charset="-120"/>
+              </a:rPr>
+              <a:t>. But if you're trying to solve a problem, you're better off</a:t>
+            </a:r>
+            <a:pPr indent="0" marL="0">
+              <a:lnSpc>
+                <a:spcPct val="105000"/>
+              </a:lnSpc>
+              <a:spcAft>
+                <a:spcPts val="700"/>
+              </a:spcAft>
+              <a:buNone/>
+            </a:pPr>
+            <a:r>
+              <a:rPr lang="en-US" sz="1000" b="1" dirty="0">
+                <a:solidFill>
+                  <a:srgbClr val="2EB872"/>
+                </a:solidFill>
+                <a:latin typeface="Georgia" pitchFamily="34" charset="0"/>
+                <a:ea typeface="Georgia" pitchFamily="34" charset="-122"/>
+                <a:cs typeface="Georgia" pitchFamily="34" charset="-120"/>
+              </a:rPr>
+              <a:t> (6) ________ </a:t>
+            </a:r>
+            <a:pPr indent="0" marL="0">
+              <a:lnSpc>
+                <a:spcPct val="105000"/>
+              </a:lnSpc>
+              <a:spcAft>
+                <a:spcPts val="700"/>
+              </a:spcAft>
+              <a:buNone/>
+            </a:pPr>
+            <a:r>
+              <a:rPr lang="en-US" sz="1000" dirty="0">
+                <a:solidFill>
+                  <a:srgbClr val="1B2559"/>
+                </a:solidFill>
+                <a:latin typeface="Georgia" pitchFamily="34" charset="0"/>
+                <a:ea typeface="Georgia" pitchFamily="34" charset="-122"/>
+                <a:cs typeface="Georgia" pitchFamily="34" charset="-120"/>
+              </a:rPr>
+              <a:t>.</a:t>
+            </a:r>
+            <a:endParaRPr lang="en-US" sz="1000" dirty="0"/>
+          </a:p>
+        </p:txBody>
+      </p:sp>
+      <p:sp>
+        <p:nvSpPr>
+          <p:cNvPr id="17" name="cd_156"/>
           <p:cNvSpPr/>
           <p:nvPr/>
         </p:nvSpPr>
@@ -30905,7 +31370,7 @@
       </p:sp>
       <p:sp>
         <p:nvSpPr>
-          <p:cNvPr id="17" name="ii_156"/>
+          <p:cNvPr id="18" name="ii_157"/>
           <p:cNvSpPr/>
           <p:nvPr/>
         </p:nvSpPr>
@@ -30941,7 +31406,7 @@
       </p:sp>
       <p:sp>
         <p:nvSpPr>
-          <p:cNvPr id="18" name="ih_157"/>
+          <p:cNvPr id="19" name="ih_158"/>
           <p:cNvSpPr/>
           <p:nvPr/>
         </p:nvSpPr>
@@ -30980,7 +31445,7 @@
       </p:sp>
       <p:sp>
         <p:nvSpPr>
-          <p:cNvPr id="19" name="il_158"/>
+          <p:cNvPr id="20" name="il_159"/>
           <p:cNvSpPr/>
           <p:nvPr/>
         </p:nvSpPr>
@@ -31070,7 +31535,7 @@
       </p:sp>
       <p:sp>
         <p:nvSpPr>
-          <p:cNvPr id="20" name="R1_chip159"/>
+          <p:cNvPr id="21" name="R1_chip160"/>
           <p:cNvSpPr/>
           <p:nvPr/>
         </p:nvSpPr>
@@ -31159,7 +31624,7 @@
                                           </p:stCondLst>
                                         </p:cTn>
                                         <p:tgtEl>
-                                          <p:spTgt spid="20"/>
+                                          <p:spTgt spid="16"/>
                                         </p:tgtEl>
                                         <p:attrNameLst>
                                           <p:attrName>style.visibility</p:attrName>
@@ -31173,7 +31638,42 @@
                                       <p:cBhvr>
                                         <p:cTn id="7" dur="400"/>
                                         <p:tgtEl>
-                                          <p:spTgt spid="20"/>
+                                          <p:spTgt spid="16"/>
+                                        </p:tgtEl>
+                                      </p:cBhvr>
+                                    </p:animEffect>
+                                  </p:childTnLst>
+                                </p:cTn>
+                              </p:par>
+                              <p:par>
+                                <p:cTn id="8" presetID="10" presetClass="entr" presetSubtype="0" fill="hold" nodeType="withEffect">
+                                  <p:stCondLst>
+                                    <p:cond delay="0"/>
+                                  </p:stCondLst>
+                                  <p:childTnLst>
+                                    <p:set>
+                                      <p:cBhvr>
+                                        <p:cTn id="9" dur="1" fill="hold">
+                                          <p:stCondLst>
+                                            <p:cond delay="0"/>
+                                          </p:stCondLst>
+                                        </p:cTn>
+                                        <p:tgtEl>
+                                          <p:spTgt spid="21"/>
+                                        </p:tgtEl>
+                                        <p:attrNameLst>
+                                          <p:attrName>style.visibility</p:attrName>
+                                        </p:attrNameLst>
+                                      </p:cBhvr>
+                                      <p:to>
+                                        <p:strVal val="visible"/>
+                                      </p:to>
+                                    </p:set>
+                                    <p:animEffect transition="in" filter="fade">
+                                      <p:cBhvr>
+                                        <p:cTn id="10" dur="400"/>
+                                        <p:tgtEl>
+                                          <p:spTgt spid="21"/>
                                         </p:tgtEl>
                                       </p:cBhvr>
                                     </p:animEffect>
@@ -31244,7 +31744,7 @@
       </p:grpSpPr>
       <p:sp>
         <p:nvSpPr>
-          <p:cNvPr id="3" name="bd_160"/>
+          <p:cNvPr id="3" name="bd_161"/>
           <p:cNvSpPr/>
           <p:nvPr/>
         </p:nvSpPr>
@@ -31296,7 +31796,7 @@
       </p:sp>
       <p:pic>
         <p:nvPicPr>
-          <p:cNvPr id="4" name="brY_161" descr="/home/claude/lls-course/v2/assets/brush-yellow.png">    </p:cNvPr>
+          <p:cNvPr id="4" name="brY_162" descr="/home/claude/lls-course/v2/assets/brush-yellow.png">    </p:cNvPr>
           <p:cNvPicPr>
             <a:picLocks noChangeAspect="1"/>
           </p:cNvPicPr>
@@ -31320,7 +31820,7 @@
       </p:pic>
       <p:sp>
         <p:nvSpPr>
-          <p:cNvPr id="5" name="title_162"/>
+          <p:cNvPr id="5" name="title_163"/>
           <p:cNvSpPr/>
           <p:nvPr/>
         </p:nvSpPr>
@@ -31361,7 +31861,7 @@
       </p:sp>
       <p:pic>
         <p:nvPicPr>
-          <p:cNvPr id="6" name="brP_163" descr="/home/claude/lls-course/v2/assets/brush-pink.png">    </p:cNvPr>
+          <p:cNvPr id="6" name="brP_164" descr="/home/claude/lls-course/v2/assets/brush-pink.png">    </p:cNvPr>
           <p:cNvPicPr>
             <a:picLocks noChangeAspect="1"/>
           </p:cNvPicPr>
@@ -31385,7 +31885,7 @@
       </p:pic>
       <p:sp>
         <p:nvSpPr>
-          <p:cNvPr id="7" name="ins_164"/>
+          <p:cNvPr id="7" name="ins_165"/>
           <p:cNvSpPr/>
           <p:nvPr/>
         </p:nvSpPr>
@@ -31426,7 +31926,7 @@
       </p:sp>
       <p:sp>
         <p:nvSpPr>
-          <p:cNvPr id="8" name="insIT_165"/>
+          <p:cNvPr id="8" name="insIT_166"/>
           <p:cNvSpPr/>
           <p:nvPr/>
         </p:nvSpPr>
@@ -31467,7 +31967,7 @@
       </p:sp>
       <p:sp>
         <p:nvSpPr>
-          <p:cNvPr id="9" name="cmd_166"/>
+          <p:cNvPr id="9" name="cmd_167"/>
           <p:cNvSpPr/>
           <p:nvPr/>
         </p:nvSpPr>
@@ -31573,7 +32073,7 @@
       </p:sp>
       <p:sp>
         <p:nvSpPr>
-          <p:cNvPr id="10" name="meta_167"/>
+          <p:cNvPr id="10" name="meta_168"/>
           <p:cNvSpPr/>
           <p:nvPr/>
         </p:nvSpPr>
@@ -31622,7 +32122,7 @@
       </p:sp>
       <p:sp>
         <p:nvSpPr>
-          <p:cNvPr id="11" name="tag_168"/>
+          <p:cNvPr id="11" name="tag_169"/>
           <p:cNvSpPr/>
           <p:nvPr/>
         </p:nvSpPr>
@@ -31685,7 +32185,7 @@
       </p:sp>
       <p:pic>
         <p:nvPicPr>
-          <p:cNvPr id="12" name="logo_169" descr="/home/claude/lls-course/v2/img/logo.png">    </p:cNvPr>
+          <p:cNvPr id="12" name="logo_170" descr="/home/claude/lls-course/v2/img/logo.png">    </p:cNvPr>
           <p:cNvPicPr>
             <a:picLocks noChangeAspect="1"/>
           </p:cNvPicPr>
@@ -31709,7 +32209,7 @@
       </p:pic>
       <p:sp>
         <p:nvSpPr>
-          <p:cNvPr id="13" name="foot_170"/>
+          <p:cNvPr id="13" name="foot_171"/>
           <p:cNvSpPr/>
           <p:nvPr/>
         </p:nvSpPr>
@@ -31748,7 +32248,7 @@
       </p:sp>
       <p:sp>
         <p:nvSpPr>
-          <p:cNvPr id="14" name="cd_171"/>
+          <p:cNvPr id="14" name="cd_172"/>
           <p:cNvSpPr/>
           <p:nvPr/>
         </p:nvSpPr>
@@ -31782,7 +32282,7 @@
       </p:sp>
       <p:sp>
         <p:nvSpPr>
-          <p:cNvPr id="15" name="rd_172"/>
+          <p:cNvPr id="15" name="rd_173"/>
           <p:cNvSpPr/>
           <p:nvPr/>
         </p:nvSpPr>
@@ -32139,7 +32639,7 @@
       </p:sp>
       <p:sp>
         <p:nvSpPr>
-          <p:cNvPr id="16" name="R1_rdA173"/>
+          <p:cNvPr id="16" name="R1_rdA174"/>
           <p:cNvSpPr/>
           <p:nvPr/>
         </p:nvSpPr>
@@ -32501,7 +33001,7 @@
       </p:sp>
       <p:sp>
         <p:nvSpPr>
-          <p:cNvPr id="17" name="R2_rdA174"/>
+          <p:cNvPr id="17" name="R2_rdA175"/>
           <p:cNvSpPr/>
           <p:nvPr/>
         </p:nvSpPr>
@@ -32866,7 +33366,7 @@
       </p:sp>
       <p:sp>
         <p:nvSpPr>
-          <p:cNvPr id="18" name="R3_rdA175"/>
+          <p:cNvPr id="18" name="R3_rdA176"/>
           <p:cNvSpPr/>
           <p:nvPr/>
         </p:nvSpPr>
@@ -33234,7 +33734,7 @@
       </p:sp>
       <p:sp>
         <p:nvSpPr>
-          <p:cNvPr id="19" name="R4_rdA176"/>
+          <p:cNvPr id="19" name="R4_rdA177"/>
           <p:cNvSpPr/>
           <p:nvPr/>
         </p:nvSpPr>
@@ -33605,7 +34105,7 @@
       </p:sp>
       <p:sp>
         <p:nvSpPr>
-          <p:cNvPr id="20" name="R5_rdA177"/>
+          <p:cNvPr id="20" name="R5_rdA178"/>
           <p:cNvSpPr/>
           <p:nvPr/>
         </p:nvSpPr>
@@ -33979,7 +34479,7 @@
       </p:sp>
       <p:sp>
         <p:nvSpPr>
-          <p:cNvPr id="21" name="rbh_178"/>
+          <p:cNvPr id="21" name="rbh_179"/>
           <p:cNvSpPr/>
           <p:nvPr/>
         </p:nvSpPr>
@@ -34018,7 +34518,7 @@
       </p:sp>
       <p:sp>
         <p:nvSpPr>
-          <p:cNvPr id="22" name="bd_179"/>
+          <p:cNvPr id="22" name="bd_180"/>
           <p:cNvSpPr/>
           <p:nvPr/>
         </p:nvSpPr>
@@ -34070,7 +34570,7 @@
       </p:sp>
       <p:sp>
         <p:nvSpPr>
-          <p:cNvPr id="23" name="rb_180"/>
+          <p:cNvPr id="23" name="rb_181"/>
           <p:cNvSpPr/>
           <p:nvPr/>
         </p:nvSpPr>
@@ -34119,7 +34619,7 @@
       </p:sp>
       <p:sp>
         <p:nvSpPr>
-          <p:cNvPr id="24" name="bd_181"/>
+          <p:cNvPr id="24" name="bd_182"/>
           <p:cNvSpPr/>
           <p:nvPr/>
         </p:nvSpPr>
@@ -34171,7 +34671,7 @@
       </p:sp>
       <p:sp>
         <p:nvSpPr>
-          <p:cNvPr id="25" name="rb_182"/>
+          <p:cNvPr id="25" name="rb_183"/>
           <p:cNvSpPr/>
           <p:nvPr/>
         </p:nvSpPr>
@@ -34220,7 +34720,7 @@
       </p:sp>
       <p:sp>
         <p:nvSpPr>
-          <p:cNvPr id="26" name="bd_183"/>
+          <p:cNvPr id="26" name="bd_184"/>
           <p:cNvSpPr/>
           <p:nvPr/>
         </p:nvSpPr>
@@ -34272,7 +34772,7 @@
       </p:sp>
       <p:sp>
         <p:nvSpPr>
-          <p:cNvPr id="27" name="rb_184"/>
+          <p:cNvPr id="27" name="rb_185"/>
           <p:cNvSpPr/>
           <p:nvPr/>
         </p:nvSpPr>
@@ -34321,7 +34821,7 @@
       </p:sp>
       <p:sp>
         <p:nvSpPr>
-          <p:cNvPr id="28" name="bd_185"/>
+          <p:cNvPr id="28" name="bd_186"/>
           <p:cNvSpPr/>
           <p:nvPr/>
         </p:nvSpPr>
@@ -34373,7 +34873,7 @@
       </p:sp>
       <p:sp>
         <p:nvSpPr>
-          <p:cNvPr id="29" name="rb_186"/>
+          <p:cNvPr id="29" name="rb_187"/>
           <p:cNvSpPr/>
           <p:nvPr/>
         </p:nvSpPr>
@@ -34422,7 +34922,7 @@
       </p:sp>
       <p:sp>
         <p:nvSpPr>
-          <p:cNvPr id="30" name="bd_187"/>
+          <p:cNvPr id="30" name="bd_188"/>
           <p:cNvSpPr/>
           <p:nvPr/>
         </p:nvSpPr>
@@ -34474,7 +34974,7 @@
       </p:sp>
       <p:sp>
         <p:nvSpPr>
-          <p:cNvPr id="31" name="rb_188"/>
+          <p:cNvPr id="31" name="rb_189"/>
           <p:cNvSpPr/>
           <p:nvPr/>
         </p:nvSpPr>
@@ -34523,7 +35023,7 @@
       </p:sp>
       <p:sp>
         <p:nvSpPr>
-          <p:cNvPr id="32" name="bd_189"/>
+          <p:cNvPr id="32" name="bd_190"/>
           <p:cNvSpPr/>
           <p:nvPr/>
         </p:nvSpPr>
@@ -34575,7 +35075,7 @@
       </p:sp>
       <p:sp>
         <p:nvSpPr>
-          <p:cNvPr id="33" name="rb_190"/>
+          <p:cNvPr id="33" name="rb_191"/>
           <p:cNvSpPr/>
           <p:nvPr/>
         </p:nvSpPr>
@@ -34961,7 +35461,7 @@
       </p:grpSpPr>
       <p:sp>
         <p:nvSpPr>
-          <p:cNvPr id="3" name="bd_191"/>
+          <p:cNvPr id="3" name="bd_192"/>
           <p:cNvSpPr/>
           <p:nvPr/>
         </p:nvSpPr>
@@ -35013,7 +35513,7 @@
       </p:sp>
       <p:pic>
         <p:nvPicPr>
-          <p:cNvPr id="4" name="brY_192" descr="/home/claude/lls-course/v2/assets/brush-yellow.png">    </p:cNvPr>
+          <p:cNvPr id="4" name="brY_193" descr="/home/claude/lls-course/v2/assets/brush-yellow.png">    </p:cNvPr>
           <p:cNvPicPr>
             <a:picLocks noChangeAspect="1"/>
           </p:cNvPicPr>
@@ -35037,7 +35537,7 @@
       </p:pic>
       <p:sp>
         <p:nvSpPr>
-          <p:cNvPr id="5" name="title_193"/>
+          <p:cNvPr id="5" name="title_194"/>
           <p:cNvSpPr/>
           <p:nvPr/>
         </p:nvSpPr>
@@ -35078,7 +35578,7 @@
       </p:sp>
       <p:pic>
         <p:nvPicPr>
-          <p:cNvPr id="6" name="brP_194" descr="/home/claude/lls-course/v2/assets/brush-pink.png">    </p:cNvPr>
+          <p:cNvPr id="6" name="brP_195" descr="/home/claude/lls-course/v2/assets/brush-pink.png">    </p:cNvPr>
           <p:cNvPicPr>
             <a:picLocks noChangeAspect="1"/>
           </p:cNvPicPr>
@@ -35102,7 +35602,7 @@
       </p:pic>
       <p:sp>
         <p:nvSpPr>
-          <p:cNvPr id="7" name="ins_195"/>
+          <p:cNvPr id="7" name="ins_196"/>
           <p:cNvSpPr/>
           <p:nvPr/>
         </p:nvSpPr>
@@ -35143,7 +35643,7 @@
       </p:sp>
       <p:sp>
         <p:nvSpPr>
-          <p:cNvPr id="8" name="insIT_196"/>
+          <p:cNvPr id="8" name="insIT_197"/>
           <p:cNvSpPr/>
           <p:nvPr/>
         </p:nvSpPr>
@@ -35184,7 +35684,7 @@
       </p:sp>
       <p:sp>
         <p:nvSpPr>
-          <p:cNvPr id="9" name="cmd_197"/>
+          <p:cNvPr id="9" name="cmd_198"/>
           <p:cNvSpPr/>
           <p:nvPr/>
         </p:nvSpPr>
@@ -35290,7 +35790,7 @@
       </p:sp>
       <p:sp>
         <p:nvSpPr>
-          <p:cNvPr id="10" name="meta_198"/>
+          <p:cNvPr id="10" name="meta_199"/>
           <p:cNvSpPr/>
           <p:nvPr/>
         </p:nvSpPr>
@@ -35339,7 +35839,7 @@
       </p:sp>
       <p:sp>
         <p:nvSpPr>
-          <p:cNvPr id="11" name="tag_199"/>
+          <p:cNvPr id="11" name="tag_200"/>
           <p:cNvSpPr/>
           <p:nvPr/>
         </p:nvSpPr>
@@ -35402,7 +35902,7 @@
       </p:sp>
       <p:pic>
         <p:nvPicPr>
-          <p:cNvPr id="12" name="logo_200" descr="/home/claude/lls-course/v2/img/logo.png">    </p:cNvPr>
+          <p:cNvPr id="12" name="logo_201" descr="/home/claude/lls-course/v2/img/logo.png">    </p:cNvPr>
           <p:cNvPicPr>
             <a:picLocks noChangeAspect="1"/>
           </p:cNvPicPr>
@@ -35426,7 +35926,7 @@
       </p:pic>
       <p:sp>
         <p:nvSpPr>
-          <p:cNvPr id="13" name="foot_201"/>
+          <p:cNvPr id="13" name="foot_202"/>
           <p:cNvSpPr/>
           <p:nvPr/>
         </p:nvSpPr>
@@ -35465,7 +35965,7 @@
       </p:sp>
       <p:sp>
         <p:nvSpPr>
-          <p:cNvPr id="14" name="pf_202"/>
+          <p:cNvPr id="14" name="pf_203"/>
           <p:cNvSpPr/>
           <p:nvPr/>
         </p:nvSpPr>
@@ -35499,7 +35999,7 @@
       </p:sp>
       <p:pic>
         <p:nvPicPr>
-          <p:cNvPr id="15" name="ph_203" descr="/home/claude/lls-course/v2/cache/b2_6b2_theatre_jpg_489x297_31.png">    </p:cNvPr>
+          <p:cNvPr id="15" name="ph_204" descr="/home/claude/lls-course/v2/cache/b2_6b2_theatre_jpg_489x297_31.png">    </p:cNvPr>
           <p:cNvPicPr>
             <a:picLocks noChangeAspect="1"/>
           </p:cNvPicPr>
@@ -35523,7 +36023,7 @@
       </p:pic>
       <p:sp>
         <p:nvSpPr>
-          <p:cNvPr id="16" name="cd_204"/>
+          <p:cNvPr id="16" name="cd_205"/>
           <p:cNvSpPr/>
           <p:nvPr/>
         </p:nvSpPr>
@@ -35557,7 +36057,7 @@
       </p:sp>
       <p:sp>
         <p:nvSpPr>
-          <p:cNvPr id="17" name="ii_205"/>
+          <p:cNvPr id="17" name="ii_206"/>
           <p:cNvSpPr/>
           <p:nvPr/>
         </p:nvSpPr>
@@ -35593,7 +36093,7 @@
       </p:sp>
       <p:sp>
         <p:nvSpPr>
-          <p:cNvPr id="18" name="ih_206"/>
+          <p:cNvPr id="18" name="ih_207"/>
           <p:cNvSpPr/>
           <p:nvPr/>
         </p:nvSpPr>
@@ -35632,7 +36132,7 @@
       </p:sp>
       <p:sp>
         <p:nvSpPr>
-          <p:cNvPr id="19" name="il_207"/>
+          <p:cNvPr id="19" name="il_208"/>
           <p:cNvSpPr/>
           <p:nvPr/>
         </p:nvSpPr>
@@ -35749,7 +36249,7 @@
       </p:sp>
       <p:sp>
         <p:nvSpPr>
-          <p:cNvPr id="20" name="R1_qb208"/>
+          <p:cNvPr id="20" name="R1_qb209"/>
           <p:cNvSpPr/>
           <p:nvPr/>
         </p:nvSpPr>
@@ -35801,7 +36301,7 @@
       </p:sp>
       <p:sp>
         <p:nvSpPr>
-          <p:cNvPr id="21" name="R1_sq209"/>
+          <p:cNvPr id="21" name="R1_sq210"/>
           <p:cNvSpPr/>
           <p:nvPr/>
         </p:nvSpPr>
@@ -35874,7 +36374,7 @@
       </p:sp>
       <p:sp>
         <p:nvSpPr>
-          <p:cNvPr id="22" name="R2_qb210"/>
+          <p:cNvPr id="22" name="R2_qb211"/>
           <p:cNvSpPr/>
           <p:nvPr/>
         </p:nvSpPr>
@@ -35926,7 +36426,7 @@
       </p:sp>
       <p:sp>
         <p:nvSpPr>
-          <p:cNvPr id="23" name="R2_sq211"/>
+          <p:cNvPr id="23" name="R2_sq212"/>
           <p:cNvSpPr/>
           <p:nvPr/>
         </p:nvSpPr>
@@ -35999,7 +36499,7 @@
       </p:sp>
       <p:sp>
         <p:nvSpPr>
-          <p:cNvPr id="24" name="R3_qb212"/>
+          <p:cNvPr id="24" name="R3_qb213"/>
           <p:cNvSpPr/>
           <p:nvPr/>
         </p:nvSpPr>
@@ -36051,7 +36551,7 @@
       </p:sp>
       <p:sp>
         <p:nvSpPr>
-          <p:cNvPr id="25" name="R3_sq213"/>
+          <p:cNvPr id="25" name="R3_sq214"/>
           <p:cNvSpPr/>
           <p:nvPr/>
         </p:nvSpPr>
@@ -36460,7 +36960,7 @@
       </p:grpSpPr>
       <p:sp>
         <p:nvSpPr>
-          <p:cNvPr id="3" name="bd_214"/>
+          <p:cNvPr id="3" name="bd_215"/>
           <p:cNvSpPr/>
           <p:nvPr/>
         </p:nvSpPr>
@@ -36512,7 +37012,7 @@
       </p:sp>
       <p:pic>
         <p:nvPicPr>
-          <p:cNvPr id="4" name="brY_215" descr="/home/claude/lls-course/v2/assets/brush-yellow.png">    </p:cNvPr>
+          <p:cNvPr id="4" name="brY_216" descr="/home/claude/lls-course/v2/assets/brush-yellow.png">    </p:cNvPr>
           <p:cNvPicPr>
             <a:picLocks noChangeAspect="1"/>
           </p:cNvPicPr>
@@ -36536,7 +37036,7 @@
       </p:pic>
       <p:sp>
         <p:nvSpPr>
-          <p:cNvPr id="5" name="title_216"/>
+          <p:cNvPr id="5" name="title_217"/>
           <p:cNvSpPr/>
           <p:nvPr/>
         </p:nvSpPr>
@@ -36577,7 +37077,7 @@
       </p:sp>
       <p:pic>
         <p:nvPicPr>
-          <p:cNvPr id="6" name="brP_217" descr="/home/claude/lls-course/v2/assets/brush-pink.png">    </p:cNvPr>
+          <p:cNvPr id="6" name="brP_218" descr="/home/claude/lls-course/v2/assets/brush-pink.png">    </p:cNvPr>
           <p:cNvPicPr>
             <a:picLocks noChangeAspect="1"/>
           </p:cNvPicPr>
@@ -36601,7 +37101,7 @@
       </p:pic>
       <p:sp>
         <p:nvSpPr>
-          <p:cNvPr id="7" name="ins_218"/>
+          <p:cNvPr id="7" name="ins_219"/>
           <p:cNvSpPr/>
           <p:nvPr/>
         </p:nvSpPr>
@@ -36642,7 +37142,7 @@
       </p:sp>
       <p:sp>
         <p:nvSpPr>
-          <p:cNvPr id="8" name="insIT_219"/>
+          <p:cNvPr id="8" name="insIT_220"/>
           <p:cNvSpPr/>
           <p:nvPr/>
         </p:nvSpPr>
@@ -36683,7 +37183,7 @@
       </p:sp>
       <p:sp>
         <p:nvSpPr>
-          <p:cNvPr id="9" name="cmd_220"/>
+          <p:cNvPr id="9" name="cmd_221"/>
           <p:cNvSpPr/>
           <p:nvPr/>
         </p:nvSpPr>
@@ -36764,7 +37264,7 @@
       </p:sp>
       <p:sp>
         <p:nvSpPr>
-          <p:cNvPr id="10" name="meta_221"/>
+          <p:cNvPr id="10" name="meta_222"/>
           <p:cNvSpPr/>
           <p:nvPr/>
         </p:nvSpPr>
@@ -36813,7 +37313,7 @@
       </p:sp>
       <p:sp>
         <p:nvSpPr>
-          <p:cNvPr id="11" name="tag_222"/>
+          <p:cNvPr id="11" name="tag_223"/>
           <p:cNvSpPr/>
           <p:nvPr/>
         </p:nvSpPr>
@@ -36876,7 +37376,7 @@
       </p:sp>
       <p:pic>
         <p:nvPicPr>
-          <p:cNvPr id="12" name="logo_223" descr="/home/claude/lls-course/v2/img/logo.png">    </p:cNvPr>
+          <p:cNvPr id="12" name="logo_224" descr="/home/claude/lls-course/v2/img/logo.png">    </p:cNvPr>
           <p:cNvPicPr>
             <a:picLocks noChangeAspect="1"/>
           </p:cNvPicPr>
@@ -36900,7 +37400,7 @@
       </p:pic>
       <p:sp>
         <p:nvSpPr>
-          <p:cNvPr id="13" name="foot_224"/>
+          <p:cNvPr id="13" name="foot_225"/>
           <p:cNvSpPr/>
           <p:nvPr/>
         </p:nvSpPr>
@@ -36939,7 +37439,7 @@
       </p:sp>
       <p:sp>
         <p:nvSpPr>
-          <p:cNvPr id="14" name="cd_225"/>
+          <p:cNvPr id="14" name="cd_226"/>
           <p:cNvSpPr/>
           <p:nvPr/>
         </p:nvSpPr>
@@ -36973,7 +37473,7 @@
       </p:sp>
       <p:sp>
         <p:nvSpPr>
-          <p:cNvPr id="15" name="rd_226"/>
+          <p:cNvPr id="15" name="rd_227"/>
           <p:cNvSpPr/>
           <p:nvPr/>
         </p:nvSpPr>
@@ -37041,7 +37541,7 @@
       </p:sp>
       <p:sp>
         <p:nvSpPr>
-          <p:cNvPr id="16" name="rd_227"/>
+          <p:cNvPr id="16" name="rd_228"/>
           <p:cNvSpPr/>
           <p:nvPr/>
         </p:nvSpPr>
@@ -37109,7 +37609,7 @@
       </p:sp>
       <p:sp>
         <p:nvSpPr>
-          <p:cNvPr id="17" name="rdl_228"/>
+          <p:cNvPr id="17" name="rdl_229"/>
           <p:cNvSpPr/>
           <p:nvPr/>
         </p:nvSpPr>

</xml_diff>